<commit_message>
Präsentation: Vergleichsfolie mit postbariatrischen Terminen und Ernährungsberatung
Folie 2 an die Anpassungen des Nutzers angeglichen (ZSG, Pfad mit fünf
Schritten, Zyklus bis Behandlungsschluss). Folie 3 zeigt neu den nicht
quantifizierten Anteil postbariatrischer Termine der Viszeralchirurgie,
die ebenfalls am ZSG stattfinden, sowie die gemeinsam beanspruchte
Ernährungsberatung.

Co-Authored-By: Claude Opus 5.5 <noreply@anthropic.com>
Claude-Session: https://claude.ai/code/session_01Y3aMFwC6xTttGKHnTQtGy4
</commit_message>
<xml_diff>
--- a/praesentation/Zusammenarbeit_Adipositas_UDEM_UVCM_Entwurf.pptx
+++ b/praesentation/Zusammenarbeit_Adipositas_UDEM_UVCM_Entwurf.pptx
@@ -23537,7 +23537,7 @@
                   <a:srgbClr val="677078"/>
                 </a:solidFill>
               </a:rPr>
-              <a:t>Ärztliche Termine mit Adipositas pro Monat – UDEM und Viszerale Chirurgie</a:t>
+              <a:t>Ärztliche Termine mit Adipositas pro Monat – ZSG und Viszerale Chirurgie</a:t>
             </a:r>
           </a:p>
         </p:txBody>
@@ -23661,7 +23661,7 @@
                   <a:srgbClr val="171C1B"/>
                 </a:solidFill>
               </a:rPr>
-              <a:t>UDEM</a:t>
+              <a:t>ZSG</a:t>
             </a:r>
           </a:p>
         </p:txBody>
@@ -23856,7 +23856,7 @@
         </p:nvSpPr>
         <p:spPr>
           <a:xfrm>
-            <a:off x="548640" y="2670048"/>
+            <a:off x="548640" y="2743200"/>
             <a:ext cx="1508760" cy="182880"/>
           </a:xfrm>
           <a:prstGeom prst="rect">
@@ -23890,7 +23890,7 @@
         </p:nvSpPr>
         <p:spPr>
           <a:xfrm>
-            <a:off x="548640" y="2852928"/>
+            <a:off x="548640" y="2926080"/>
             <a:ext cx="1508760" cy="310896"/>
           </a:xfrm>
           <a:prstGeom prst="rect">
@@ -23924,8 +23924,8 @@
         </p:nvSpPr>
         <p:spPr>
           <a:xfrm>
-            <a:off x="2148840" y="2651760"/>
-            <a:ext cx="1046073" cy="384048"/>
+            <a:off x="2148840" y="2724912"/>
+            <a:ext cx="627644" cy="384048"/>
           </a:xfrm>
           <a:prstGeom prst="rect">
             <a:avLst/>
@@ -23962,13 +23962,64 @@
       </p:sp>
       <p:sp>
         <p:nvSpPr>
-          <p:cNvPr id="31" name="TextBox 30"/>
+          <p:cNvPr id="31" name="Rectangle 30"/>
+          <p:cNvSpPr/>
+          <p:nvPr/>
+        </p:nvSpPr>
+        <p:spPr>
+          <a:xfrm>
+            <a:off x="2794772" y="2724912"/>
+            <a:ext cx="400141" cy="384048"/>
+          </a:xfrm>
+          <a:prstGeom prst="rect">
+            <a:avLst/>
+          </a:prstGeom>
+          <a:pattFill prst="wdUpDiag">
+            <a:fgClr>
+              <a:srgbClr val="009670"/>
+            </a:fgClr>
+            <a:bgClr>
+              <a:srgbClr val="FFFFFF"/>
+            </a:bgClr>
+          </a:pattFill>
+          <a:ln w="12700">
+            <a:solidFill>
+              <a:srgbClr val="009670"/>
+            </a:solidFill>
+          </a:ln>
+          <a:effectLst/>
+        </p:spPr>
+        <p:style>
+          <a:lnRef idx="1">
+            <a:schemeClr val="accent1"/>
+          </a:lnRef>
+          <a:fillRef idx="3">
+            <a:schemeClr val="accent1"/>
+          </a:fillRef>
+          <a:effectRef idx="2">
+            <a:schemeClr val="accent1"/>
+          </a:effectRef>
+          <a:fontRef idx="minor">
+            <a:schemeClr val="lt1"/>
+          </a:fontRef>
+        </p:style>
+        <p:txBody>
+          <a:bodyPr rtlCol="0" anchor="ctr"/>
+          <a:lstStyle/>
+          <a:p>
+            <a:pPr algn="ctr"/>
+          </a:p>
+        </p:txBody>
+      </p:sp>
+      <p:sp>
+        <p:nvSpPr>
+          <p:cNvPr id="32" name="TextBox 31"/>
           <p:cNvSpPr txBox="1"/>
           <p:nvPr/>
         </p:nvSpPr>
         <p:spPr>
           <a:xfrm>
-            <a:off x="3286353" y="2706624"/>
+            <a:off x="3286353" y="2779776"/>
             <a:ext cx="731520" cy="274320"/>
           </a:xfrm>
           <a:prstGeom prst="rect">
@@ -23996,22 +24047,23 @@
       </p:sp>
       <p:cxnSp>
         <p:nvCxnSpPr>
-          <p:cNvPr id="32" name="Connector 31"/>
+          <p:cNvPr id="33" name="Connector 32"/>
           <p:cNvCxnSpPr/>
           <p:nvPr/>
         </p:nvCxnSpPr>
         <p:spPr>
-          <a:xfrm>
-            <a:off x="2148840" y="1920240"/>
-            <a:ext cx="0" cy="1188720"/>
+          <a:xfrm flipV="1">
+            <a:off x="2994842" y="2404872"/>
+            <a:ext cx="0" cy="301752"/>
           </a:xfrm>
           <a:prstGeom prst="line">
             <a:avLst/>
           </a:prstGeom>
-          <a:ln w="12700">
+          <a:ln w="19050">
             <a:solidFill>
-              <a:srgbClr val="677078"/>
+              <a:srgbClr val="009670"/>
             </a:solidFill>
+            <a:tailEnd type="triangle" w="med" len="med"/>
           </a:ln>
         </p:spPr>
         <p:style>
@@ -24031,102 +24083,14 @@
       </p:cxnSp>
       <p:sp>
         <p:nvSpPr>
-          <p:cNvPr id="33" name="Rectangle 32"/>
-          <p:cNvSpPr/>
-          <p:nvPr/>
-        </p:nvSpPr>
-        <p:spPr>
-          <a:xfrm>
-            <a:off x="5989320" y="1645920"/>
-            <a:ext cx="2606040" cy="1755648"/>
-          </a:xfrm>
-          <a:prstGeom prst="rect">
-            <a:avLst/>
-          </a:prstGeom>
-          <a:solidFill>
-            <a:srgbClr val="F0F6F3"/>
-          </a:solidFill>
-          <a:ln>
-            <a:noFill/>
-          </a:ln>
-          <a:effectLst/>
-        </p:spPr>
-        <p:style>
-          <a:lnRef idx="1">
-            <a:schemeClr val="accent1"/>
-          </a:lnRef>
-          <a:fillRef idx="3">
-            <a:schemeClr val="accent1"/>
-          </a:fillRef>
-          <a:effectRef idx="2">
-            <a:schemeClr val="accent1"/>
-          </a:effectRef>
-          <a:fontRef idx="minor">
-            <a:schemeClr val="lt1"/>
-          </a:fontRef>
-        </p:style>
-        <p:txBody>
-          <a:bodyPr rtlCol="0" anchor="ctr"/>
-          <a:lstStyle/>
-          <a:p>
-            <a:pPr algn="ctr"/>
-          </a:p>
-        </p:txBody>
-      </p:sp>
-      <p:sp>
-        <p:nvSpPr>
-          <p:cNvPr id="34" name="Rectangle 33"/>
-          <p:cNvSpPr/>
-          <p:nvPr/>
-        </p:nvSpPr>
-        <p:spPr>
-          <a:xfrm>
-            <a:off x="5989320" y="1645920"/>
-            <a:ext cx="36576" cy="1755648"/>
-          </a:xfrm>
-          <a:prstGeom prst="rect">
-            <a:avLst/>
-          </a:prstGeom>
-          <a:solidFill>
-            <a:srgbClr val="EE8F7A"/>
-          </a:solidFill>
-          <a:ln>
-            <a:noFill/>
-          </a:ln>
-          <a:effectLst/>
-        </p:spPr>
-        <p:style>
-          <a:lnRef idx="1">
-            <a:schemeClr val="accent1"/>
-          </a:lnRef>
-          <a:fillRef idx="3">
-            <a:schemeClr val="accent1"/>
-          </a:fillRef>
-          <a:effectRef idx="2">
-            <a:schemeClr val="accent1"/>
-          </a:effectRef>
-          <a:fontRef idx="minor">
-            <a:schemeClr val="lt1"/>
-          </a:fontRef>
-        </p:style>
-        <p:txBody>
-          <a:bodyPr rtlCol="0" anchor="ctr"/>
-          <a:lstStyle/>
-          <a:p>
-            <a:pPr algn="ctr"/>
-          </a:p>
-        </p:txBody>
-      </p:sp>
-      <p:sp>
-        <p:nvSpPr>
-          <p:cNvPr id="35" name="TextBox 34"/>
+          <p:cNvPr id="34" name="TextBox 33"/>
           <p:cNvSpPr txBox="1"/>
           <p:nvPr/>
         </p:nvSpPr>
         <p:spPr>
           <a:xfrm>
-            <a:off x="6172200" y="1773936"/>
-            <a:ext cx="2286000" cy="164592"/>
+            <a:off x="3086282" y="2450592"/>
+            <a:ext cx="1737360" cy="274320"/>
           </a:xfrm>
           <a:prstGeom prst="rect">
             <a:avLst/>
@@ -24141,237 +24105,44 @@
           <a:p>
             <a:pPr algn="l"/>
             <a:r>
-              <a:rPr sz="980" b="1" i="0">
+              <a:rPr sz="800" b="1" i="0">
                 <a:solidFill>
                   <a:srgbClr val="009670"/>
                 </a:solidFill>
               </a:rPr>
-              <a:t>ZUSÄTZLICH AM UDEM</a:t>
-            </a:r>
-          </a:p>
-        </p:txBody>
-      </p:sp>
-      <p:sp>
-        <p:nvSpPr>
-          <p:cNvPr id="36" name="TextBox 35"/>
-          <p:cNvSpPr txBox="1"/>
-          <p:nvPr/>
-        </p:nvSpPr>
-        <p:spPr>
-          <a:xfrm>
-            <a:off x="6172200" y="2057400"/>
-            <a:ext cx="731520" cy="274320"/>
-          </a:xfrm>
-          <a:prstGeom prst="rect">
-            <a:avLst/>
-          </a:prstGeom>
-          <a:noFill/>
-        </p:spPr>
-        <p:txBody>
-          <a:bodyPr wrap="square" lIns="0" rIns="0" tIns="0" bIns="0" anchor="t">
-            <a:spAutoFit/>
-          </a:bodyPr>
-          <a:lstStyle/>
+              <a:t>Postbariatrische Termine</a:t>
+            </a:r>
+          </a:p>
           <a:p>
             <a:pPr algn="l"/>
             <a:r>
-              <a:rPr sz="1500" b="1" i="0">
+              <a:rPr sz="800" b="0" i="0">
                 <a:solidFill>
-                  <a:srgbClr val="171C1B"/>
+                  <a:srgbClr val="009670"/>
                 </a:solidFill>
               </a:rPr>
-              <a:t>≈ 300</a:t>
-            </a:r>
-          </a:p>
-        </p:txBody>
-      </p:sp>
-      <p:sp>
-        <p:nvSpPr>
-          <p:cNvPr id="37" name="TextBox 36"/>
-          <p:cNvSpPr txBox="1"/>
-          <p:nvPr/>
-        </p:nvSpPr>
-        <p:spPr>
-          <a:xfrm>
-            <a:off x="6903720" y="2066543"/>
-            <a:ext cx="1645920" cy="182880"/>
-          </a:xfrm>
-          <a:prstGeom prst="rect">
-            <a:avLst/>
-          </a:prstGeom>
-          <a:noFill/>
-        </p:spPr>
-        <p:txBody>
-          <a:bodyPr wrap="square" lIns="0" rIns="0" tIns="0" bIns="0" anchor="t">
-            <a:spAutoFit/>
-          </a:bodyPr>
-          <a:lstStyle/>
-          <a:p>
-            <a:pPr algn="l"/>
-            <a:r>
-              <a:rPr sz="1000" b="1" i="0">
-                <a:solidFill>
-                  <a:srgbClr val="171C1B"/>
-                </a:solidFill>
-              </a:rPr>
-              <a:t>Metabolic Assessments</a:t>
-            </a:r>
-          </a:p>
-        </p:txBody>
-      </p:sp>
-      <p:sp>
-        <p:nvSpPr>
-          <p:cNvPr id="38" name="TextBox 37"/>
-          <p:cNvSpPr txBox="1"/>
-          <p:nvPr/>
-        </p:nvSpPr>
-        <p:spPr>
-          <a:xfrm>
-            <a:off x="6903720" y="2240280"/>
-            <a:ext cx="1645920" cy="182880"/>
-          </a:xfrm>
-          <a:prstGeom prst="rect">
-            <a:avLst/>
-          </a:prstGeom>
-          <a:noFill/>
-        </p:spPr>
-        <p:txBody>
-          <a:bodyPr wrap="square" lIns="0" rIns="0" tIns="0" bIns="0" anchor="t">
-            <a:spAutoFit/>
-          </a:bodyPr>
-          <a:lstStyle/>
-          <a:p>
-            <a:pPr algn="l"/>
-            <a:r>
-              <a:rPr sz="850" b="0" i="0">
-                <a:solidFill>
-                  <a:srgbClr val="677078"/>
-                </a:solidFill>
-              </a:rPr>
-              <a:t>BIA &amp; Fibroscan</a:t>
-            </a:r>
-          </a:p>
-        </p:txBody>
-      </p:sp>
-      <p:sp>
-        <p:nvSpPr>
-          <p:cNvPr id="39" name="TextBox 38"/>
-          <p:cNvSpPr txBox="1"/>
-          <p:nvPr/>
-        </p:nvSpPr>
-        <p:spPr>
-          <a:xfrm>
-            <a:off x="6172200" y="2514600"/>
-            <a:ext cx="731520" cy="274320"/>
-          </a:xfrm>
-          <a:prstGeom prst="rect">
-            <a:avLst/>
-          </a:prstGeom>
-          <a:noFill/>
-        </p:spPr>
-        <p:txBody>
-          <a:bodyPr wrap="square" lIns="0" rIns="0" tIns="0" bIns="0" anchor="t">
-            <a:spAutoFit/>
-          </a:bodyPr>
-          <a:lstStyle/>
-          <a:p>
-            <a:pPr algn="l"/>
-            <a:r>
-              <a:rPr sz="1500" b="1" i="0">
-                <a:solidFill>
-                  <a:srgbClr val="171C1B"/>
-                </a:solidFill>
-              </a:rPr>
-              <a:t>≈ 180</a:t>
-            </a:r>
-          </a:p>
-        </p:txBody>
-      </p:sp>
-      <p:sp>
-        <p:nvSpPr>
-          <p:cNvPr id="40" name="TextBox 39"/>
-          <p:cNvSpPr txBox="1"/>
-          <p:nvPr/>
-        </p:nvSpPr>
-        <p:spPr>
-          <a:xfrm>
-            <a:off x="6903720" y="2523744"/>
-            <a:ext cx="1645920" cy="182880"/>
-          </a:xfrm>
-          <a:prstGeom prst="rect">
-            <a:avLst/>
-          </a:prstGeom>
-          <a:noFill/>
-        </p:spPr>
-        <p:txBody>
-          <a:bodyPr wrap="square" lIns="0" rIns="0" tIns="0" bIns="0" anchor="t">
-            <a:spAutoFit/>
-          </a:bodyPr>
-          <a:lstStyle/>
-          <a:p>
-            <a:pPr algn="l"/>
-            <a:r>
-              <a:rPr sz="1000" b="1" i="0">
-                <a:solidFill>
-                  <a:srgbClr val="171C1B"/>
-                </a:solidFill>
-              </a:rPr>
-              <a:t>Meilensteinkontrollen</a:t>
-            </a:r>
-          </a:p>
-        </p:txBody>
-      </p:sp>
-      <p:sp>
-        <p:nvSpPr>
-          <p:cNvPr id="41" name="TextBox 40"/>
-          <p:cNvSpPr txBox="1"/>
-          <p:nvPr/>
-        </p:nvSpPr>
-        <p:spPr>
-          <a:xfrm>
-            <a:off x="6903720" y="2697480"/>
-            <a:ext cx="1645920" cy="182880"/>
-          </a:xfrm>
-          <a:prstGeom prst="rect">
-            <a:avLst/>
-          </a:prstGeom>
-          <a:noFill/>
-        </p:spPr>
-        <p:txBody>
-          <a:bodyPr wrap="square" lIns="0" rIns="0" tIns="0" bIns="0" anchor="t">
-            <a:spAutoFit/>
-          </a:bodyPr>
-          <a:lstStyle/>
-          <a:p>
-            <a:pPr algn="l"/>
-            <a:r>
-              <a:rPr sz="850" b="0" i="0">
-                <a:solidFill>
-                  <a:srgbClr val="677078"/>
-                </a:solidFill>
-              </a:rPr>
-              <a:t>dipl. Pflege</a:t>
+              <a:t>Anteil ebenfalls am ZSG</a:t>
             </a:r>
           </a:p>
         </p:txBody>
       </p:sp>
       <p:cxnSp>
         <p:nvCxnSpPr>
-          <p:cNvPr id="42" name="Connector 41"/>
+          <p:cNvPr id="35" name="Connector 34"/>
           <p:cNvCxnSpPr/>
           <p:nvPr/>
         </p:nvCxnSpPr>
         <p:spPr>
           <a:xfrm>
-            <a:off x="6172200" y="2999232"/>
-            <a:ext cx="2240280" cy="0"/>
+            <a:off x="2148840" y="1920240"/>
+            <a:ext cx="0" cy="1261872"/>
           </a:xfrm>
           <a:prstGeom prst="line">
             <a:avLst/>
           </a:prstGeom>
           <a:ln w="12700">
             <a:solidFill>
-              <a:srgbClr val="CFD8D5"/>
+              <a:srgbClr val="677078"/>
             </a:solidFill>
           </a:ln>
         </p:spPr>
@@ -24392,65 +24163,28 @@
       </p:cxnSp>
       <p:sp>
         <p:nvSpPr>
-          <p:cNvPr id="43" name="TextBox 42"/>
-          <p:cNvSpPr txBox="1"/>
-          <p:nvPr/>
-        </p:nvSpPr>
-        <p:spPr>
-          <a:xfrm>
-            <a:off x="6172200" y="3072384"/>
-            <a:ext cx="2286000" cy="228600"/>
-          </a:xfrm>
-          <a:prstGeom prst="rect">
-            <a:avLst/>
-          </a:prstGeom>
-          <a:noFill/>
-        </p:spPr>
-        <p:txBody>
-          <a:bodyPr wrap="square" lIns="0" rIns="0" tIns="0" bIns="0" anchor="t">
-            <a:spAutoFit/>
-          </a:bodyPr>
-          <a:lstStyle/>
-          <a:p>
-            <a:pPr algn="l"/>
-            <a:r>
-              <a:rPr sz="1200" b="1" i="0">
-                <a:solidFill>
-                  <a:srgbClr val="171C1B"/>
-                </a:solidFill>
-              </a:rPr>
-              <a:t>≈ 780</a:t>
-            </a:r>
-            <a:r>
-              <a:rPr sz="1000" b="0" i="0">
-                <a:solidFill>
-                  <a:srgbClr val="171C1B"/>
-                </a:solidFill>
-              </a:rPr>
-              <a:t> Kontakte pro Monat gesamt</a:t>
-            </a:r>
-          </a:p>
-        </p:txBody>
-      </p:sp>
-      <p:sp>
-        <p:nvSpPr>
-          <p:cNvPr id="44" name="Rectangle 43"/>
+          <p:cNvPr id="36" name="Rounded Rectangle 35"/>
           <p:cNvSpPr/>
           <p:nvPr/>
         </p:nvSpPr>
         <p:spPr>
           <a:xfrm>
-            <a:off x="548640" y="3639312"/>
-            <a:ext cx="8046720" cy="502920"/>
-          </a:xfrm>
-          <a:prstGeom prst="rect">
-            <a:avLst/>
+            <a:off x="548640" y="3310128"/>
+            <a:ext cx="5120640" cy="274320"/>
+          </a:xfrm>
+          <a:prstGeom prst="roundRect">
+            <a:avLst>
+              <a:gd name="adj" fmla="val 50000"/>
+            </a:avLst>
           </a:prstGeom>
           <a:solidFill>
-            <a:srgbClr val="F0F6F3"/>
+            <a:srgbClr val="FFFFFF"/>
           </a:solidFill>
-          <a:ln>
-            <a:noFill/>
+          <a:ln w="12700">
+            <a:solidFill>
+              <a:srgbClr val="009670"/>
+            </a:solidFill>
+            <a:prstDash val="dash"/>
           </a:ln>
           <a:effectLst/>
         </p:spPr>
@@ -24469,29 +24203,45 @@
           </a:fontRef>
         </p:style>
         <p:txBody>
-          <a:bodyPr rtlCol="0" anchor="ctr"/>
-          <a:lstStyle/>
-          <a:p>
-            <a:pPr algn="ctr"/>
-          </a:p>
-        </p:txBody>
-      </p:sp>
-      <p:sp>
-        <p:nvSpPr>
-          <p:cNvPr id="45" name="Rectangle 44"/>
+          <a:bodyPr rtlCol="0" anchor="ctr" wrap="square" lIns="146304" rIns="146304" tIns="18288" bIns="18288"/>
+          <a:lstStyle/>
+          <a:p>
+            <a:pPr algn="l"/>
+            <a:r>
+              <a:rPr sz="900" b="1">
+                <a:solidFill>
+                  <a:srgbClr val="171C1B"/>
+                </a:solidFill>
+              </a:rPr>
+              <a:t>Ernährungsberatung</a:t>
+            </a:r>
+            <a:r>
+              <a:rPr sz="900" b="0">
+                <a:solidFill>
+                  <a:srgbClr val="677078"/>
+                </a:solidFill>
+              </a:rPr>
+              <a:t>  ·  gemeinsam beansprucht von ZSG und Viszeraler Chirurgie</a:t>
+            </a:r>
+          </a:p>
+        </p:txBody>
+      </p:sp>
+      <p:sp>
+        <p:nvSpPr>
+          <p:cNvPr id="37" name="Rectangle 36"/>
           <p:cNvSpPr/>
           <p:nvPr/>
         </p:nvSpPr>
         <p:spPr>
           <a:xfrm>
-            <a:off x="548640" y="3639312"/>
-            <a:ext cx="36576" cy="502920"/>
+            <a:off x="5989320" y="1645920"/>
+            <a:ext cx="2606040" cy="1883664"/>
           </a:xfrm>
           <a:prstGeom prst="rect">
             <a:avLst/>
           </a:prstGeom>
           <a:solidFill>
-            <a:srgbClr val="009670"/>
+            <a:srgbClr val="F0F6F3"/>
           </a:solidFill>
           <a:ln>
             <a:noFill/>
@@ -24522,14 +24272,461 @@
       </p:sp>
       <p:sp>
         <p:nvSpPr>
-          <p:cNvPr id="46" name="TextBox 45"/>
+          <p:cNvPr id="38" name="Rectangle 37"/>
+          <p:cNvSpPr/>
+          <p:nvPr/>
+        </p:nvSpPr>
+        <p:spPr>
+          <a:xfrm>
+            <a:off x="5989320" y="1645920"/>
+            <a:ext cx="36576" cy="1883664"/>
+          </a:xfrm>
+          <a:prstGeom prst="rect">
+            <a:avLst/>
+          </a:prstGeom>
+          <a:solidFill>
+            <a:srgbClr val="EE8F7A"/>
+          </a:solidFill>
+          <a:ln>
+            <a:noFill/>
+          </a:ln>
+          <a:effectLst/>
+        </p:spPr>
+        <p:style>
+          <a:lnRef idx="1">
+            <a:schemeClr val="accent1"/>
+          </a:lnRef>
+          <a:fillRef idx="3">
+            <a:schemeClr val="accent1"/>
+          </a:fillRef>
+          <a:effectRef idx="2">
+            <a:schemeClr val="accent1"/>
+          </a:effectRef>
+          <a:fontRef idx="minor">
+            <a:schemeClr val="lt1"/>
+          </a:fontRef>
+        </p:style>
+        <p:txBody>
+          <a:bodyPr rtlCol="0" anchor="ctr"/>
+          <a:lstStyle/>
+          <a:p>
+            <a:pPr algn="ctr"/>
+          </a:p>
+        </p:txBody>
+      </p:sp>
+      <p:sp>
+        <p:nvSpPr>
+          <p:cNvPr id="39" name="TextBox 38"/>
           <p:cNvSpPr txBox="1"/>
           <p:nvPr/>
         </p:nvSpPr>
         <p:spPr>
           <a:xfrm>
-            <a:off x="685800" y="3639312"/>
-            <a:ext cx="7772400" cy="502920"/>
+            <a:off x="6172200" y="1773936"/>
+            <a:ext cx="2286000" cy="164592"/>
+          </a:xfrm>
+          <a:prstGeom prst="rect">
+            <a:avLst/>
+          </a:prstGeom>
+          <a:noFill/>
+        </p:spPr>
+        <p:txBody>
+          <a:bodyPr wrap="square" lIns="0" rIns="0" tIns="0" bIns="0" anchor="t">
+            <a:spAutoFit/>
+          </a:bodyPr>
+          <a:lstStyle/>
+          <a:p>
+            <a:pPr algn="l"/>
+            <a:r>
+              <a:rPr sz="980" b="1" i="0">
+                <a:solidFill>
+                  <a:srgbClr val="009670"/>
+                </a:solidFill>
+              </a:rPr>
+              <a:t>ZUSÄTZLICH AM ZSG</a:t>
+            </a:r>
+          </a:p>
+        </p:txBody>
+      </p:sp>
+      <p:sp>
+        <p:nvSpPr>
+          <p:cNvPr id="40" name="TextBox 39"/>
+          <p:cNvSpPr txBox="1"/>
+          <p:nvPr/>
+        </p:nvSpPr>
+        <p:spPr>
+          <a:xfrm>
+            <a:off x="6172200" y="2084832"/>
+            <a:ext cx="731520" cy="274320"/>
+          </a:xfrm>
+          <a:prstGeom prst="rect">
+            <a:avLst/>
+          </a:prstGeom>
+          <a:noFill/>
+        </p:spPr>
+        <p:txBody>
+          <a:bodyPr wrap="square" lIns="0" rIns="0" tIns="0" bIns="0" anchor="t">
+            <a:spAutoFit/>
+          </a:bodyPr>
+          <a:lstStyle/>
+          <a:p>
+            <a:pPr algn="l"/>
+            <a:r>
+              <a:rPr sz="1500" b="1" i="0">
+                <a:solidFill>
+                  <a:srgbClr val="171C1B"/>
+                </a:solidFill>
+              </a:rPr>
+              <a:t>≈ 300</a:t>
+            </a:r>
+          </a:p>
+        </p:txBody>
+      </p:sp>
+      <p:sp>
+        <p:nvSpPr>
+          <p:cNvPr id="41" name="TextBox 40"/>
+          <p:cNvSpPr txBox="1"/>
+          <p:nvPr/>
+        </p:nvSpPr>
+        <p:spPr>
+          <a:xfrm>
+            <a:off x="6903720" y="2093976"/>
+            <a:ext cx="1645920" cy="182880"/>
+          </a:xfrm>
+          <a:prstGeom prst="rect">
+            <a:avLst/>
+          </a:prstGeom>
+          <a:noFill/>
+        </p:spPr>
+        <p:txBody>
+          <a:bodyPr wrap="square" lIns="0" rIns="0" tIns="0" bIns="0" anchor="t">
+            <a:spAutoFit/>
+          </a:bodyPr>
+          <a:lstStyle/>
+          <a:p>
+            <a:pPr algn="l"/>
+            <a:r>
+              <a:rPr sz="1000" b="1" i="0">
+                <a:solidFill>
+                  <a:srgbClr val="171C1B"/>
+                </a:solidFill>
+              </a:rPr>
+              <a:t>Metabolic Assessments</a:t>
+            </a:r>
+          </a:p>
+        </p:txBody>
+      </p:sp>
+      <p:sp>
+        <p:nvSpPr>
+          <p:cNvPr id="42" name="TextBox 41"/>
+          <p:cNvSpPr txBox="1"/>
+          <p:nvPr/>
+        </p:nvSpPr>
+        <p:spPr>
+          <a:xfrm>
+            <a:off x="6903720" y="2267712"/>
+            <a:ext cx="1645920" cy="182880"/>
+          </a:xfrm>
+          <a:prstGeom prst="rect">
+            <a:avLst/>
+          </a:prstGeom>
+          <a:noFill/>
+        </p:spPr>
+        <p:txBody>
+          <a:bodyPr wrap="square" lIns="0" rIns="0" tIns="0" bIns="0" anchor="t">
+            <a:spAutoFit/>
+          </a:bodyPr>
+          <a:lstStyle/>
+          <a:p>
+            <a:pPr algn="l"/>
+            <a:r>
+              <a:rPr sz="850" b="0" i="0">
+                <a:solidFill>
+                  <a:srgbClr val="677078"/>
+                </a:solidFill>
+              </a:rPr>
+              <a:t>BIA &amp; Fibroscan</a:t>
+            </a:r>
+          </a:p>
+        </p:txBody>
+      </p:sp>
+      <p:sp>
+        <p:nvSpPr>
+          <p:cNvPr id="43" name="TextBox 42"/>
+          <p:cNvSpPr txBox="1"/>
+          <p:nvPr/>
+        </p:nvSpPr>
+        <p:spPr>
+          <a:xfrm>
+            <a:off x="6172200" y="2587752"/>
+            <a:ext cx="731520" cy="274320"/>
+          </a:xfrm>
+          <a:prstGeom prst="rect">
+            <a:avLst/>
+          </a:prstGeom>
+          <a:noFill/>
+        </p:spPr>
+        <p:txBody>
+          <a:bodyPr wrap="square" lIns="0" rIns="0" tIns="0" bIns="0" anchor="t">
+            <a:spAutoFit/>
+          </a:bodyPr>
+          <a:lstStyle/>
+          <a:p>
+            <a:pPr algn="l"/>
+            <a:r>
+              <a:rPr sz="1500" b="1" i="0">
+                <a:solidFill>
+                  <a:srgbClr val="171C1B"/>
+                </a:solidFill>
+              </a:rPr>
+              <a:t>≈ 180</a:t>
+            </a:r>
+          </a:p>
+        </p:txBody>
+      </p:sp>
+      <p:sp>
+        <p:nvSpPr>
+          <p:cNvPr id="44" name="TextBox 43"/>
+          <p:cNvSpPr txBox="1"/>
+          <p:nvPr/>
+        </p:nvSpPr>
+        <p:spPr>
+          <a:xfrm>
+            <a:off x="6903720" y="2596896"/>
+            <a:ext cx="1645920" cy="182880"/>
+          </a:xfrm>
+          <a:prstGeom prst="rect">
+            <a:avLst/>
+          </a:prstGeom>
+          <a:noFill/>
+        </p:spPr>
+        <p:txBody>
+          <a:bodyPr wrap="square" lIns="0" rIns="0" tIns="0" bIns="0" anchor="t">
+            <a:spAutoFit/>
+          </a:bodyPr>
+          <a:lstStyle/>
+          <a:p>
+            <a:pPr algn="l"/>
+            <a:r>
+              <a:rPr sz="1000" b="1" i="0">
+                <a:solidFill>
+                  <a:srgbClr val="171C1B"/>
+                </a:solidFill>
+              </a:rPr>
+              <a:t>Meilensteinkontrollen</a:t>
+            </a:r>
+          </a:p>
+        </p:txBody>
+      </p:sp>
+      <p:sp>
+        <p:nvSpPr>
+          <p:cNvPr id="45" name="TextBox 44"/>
+          <p:cNvSpPr txBox="1"/>
+          <p:nvPr/>
+        </p:nvSpPr>
+        <p:spPr>
+          <a:xfrm>
+            <a:off x="6903720" y="2770632"/>
+            <a:ext cx="1645920" cy="182880"/>
+          </a:xfrm>
+          <a:prstGeom prst="rect">
+            <a:avLst/>
+          </a:prstGeom>
+          <a:noFill/>
+        </p:spPr>
+        <p:txBody>
+          <a:bodyPr wrap="square" lIns="0" rIns="0" tIns="0" bIns="0" anchor="t">
+            <a:spAutoFit/>
+          </a:bodyPr>
+          <a:lstStyle/>
+          <a:p>
+            <a:pPr algn="l"/>
+            <a:r>
+              <a:rPr sz="850" b="0" i="0">
+                <a:solidFill>
+                  <a:srgbClr val="677078"/>
+                </a:solidFill>
+              </a:rPr>
+              <a:t>dipl. Pflege</a:t>
+            </a:r>
+          </a:p>
+        </p:txBody>
+      </p:sp>
+      <p:cxnSp>
+        <p:nvCxnSpPr>
+          <p:cNvPr id="46" name="Connector 45"/>
+          <p:cNvCxnSpPr/>
+          <p:nvPr/>
+        </p:nvCxnSpPr>
+        <p:spPr>
+          <a:xfrm>
+            <a:off x="6172200" y="3108960"/>
+            <a:ext cx="2240280" cy="0"/>
+          </a:xfrm>
+          <a:prstGeom prst="line">
+            <a:avLst/>
+          </a:prstGeom>
+          <a:ln w="12700">
+            <a:solidFill>
+              <a:srgbClr val="CFD8D5"/>
+            </a:solidFill>
+          </a:ln>
+        </p:spPr>
+        <p:style>
+          <a:lnRef idx="2">
+            <a:schemeClr val="accent1"/>
+          </a:lnRef>
+          <a:fillRef idx="0">
+            <a:schemeClr val="accent1"/>
+          </a:fillRef>
+          <a:effectRef idx="1">
+            <a:schemeClr val="accent1"/>
+          </a:effectRef>
+          <a:fontRef idx="minor">
+            <a:schemeClr val="tx1"/>
+          </a:fontRef>
+        </p:style>
+      </p:cxnSp>
+      <p:sp>
+        <p:nvSpPr>
+          <p:cNvPr id="47" name="TextBox 46"/>
+          <p:cNvSpPr txBox="1"/>
+          <p:nvPr/>
+        </p:nvSpPr>
+        <p:spPr>
+          <a:xfrm>
+            <a:off x="6172200" y="3200400"/>
+            <a:ext cx="2286000" cy="228600"/>
+          </a:xfrm>
+          <a:prstGeom prst="rect">
+            <a:avLst/>
+          </a:prstGeom>
+          <a:noFill/>
+        </p:spPr>
+        <p:txBody>
+          <a:bodyPr wrap="square" lIns="0" rIns="0" tIns="0" bIns="0" anchor="t">
+            <a:spAutoFit/>
+          </a:bodyPr>
+          <a:lstStyle/>
+          <a:p>
+            <a:pPr algn="l"/>
+            <a:r>
+              <a:rPr sz="1200" b="1" i="0">
+                <a:solidFill>
+                  <a:srgbClr val="171C1B"/>
+                </a:solidFill>
+              </a:rPr>
+              <a:t>≈ 780</a:t>
+            </a:r>
+            <a:r>
+              <a:rPr sz="1000" b="0" i="0">
+                <a:solidFill>
+                  <a:srgbClr val="171C1B"/>
+                </a:solidFill>
+              </a:rPr>
+              <a:t> Kontakte pro Monat gesamt</a:t>
+            </a:r>
+          </a:p>
+        </p:txBody>
+      </p:sp>
+      <p:sp>
+        <p:nvSpPr>
+          <p:cNvPr id="48" name="Rectangle 47"/>
+          <p:cNvSpPr/>
+          <p:nvPr/>
+        </p:nvSpPr>
+        <p:spPr>
+          <a:xfrm>
+            <a:off x="548640" y="3675887"/>
+            <a:ext cx="8046720" cy="475488"/>
+          </a:xfrm>
+          <a:prstGeom prst="rect">
+            <a:avLst/>
+          </a:prstGeom>
+          <a:solidFill>
+            <a:srgbClr val="F0F6F3"/>
+          </a:solidFill>
+          <a:ln>
+            <a:noFill/>
+          </a:ln>
+          <a:effectLst/>
+        </p:spPr>
+        <p:style>
+          <a:lnRef idx="1">
+            <a:schemeClr val="accent1"/>
+          </a:lnRef>
+          <a:fillRef idx="3">
+            <a:schemeClr val="accent1"/>
+          </a:fillRef>
+          <a:effectRef idx="2">
+            <a:schemeClr val="accent1"/>
+          </a:effectRef>
+          <a:fontRef idx="minor">
+            <a:schemeClr val="lt1"/>
+          </a:fontRef>
+        </p:style>
+        <p:txBody>
+          <a:bodyPr rtlCol="0" anchor="ctr"/>
+          <a:lstStyle/>
+          <a:p>
+            <a:pPr algn="ctr"/>
+          </a:p>
+        </p:txBody>
+      </p:sp>
+      <p:sp>
+        <p:nvSpPr>
+          <p:cNvPr id="49" name="Rectangle 48"/>
+          <p:cNvSpPr/>
+          <p:nvPr/>
+        </p:nvSpPr>
+        <p:spPr>
+          <a:xfrm>
+            <a:off x="548640" y="3675887"/>
+            <a:ext cx="36576" cy="475488"/>
+          </a:xfrm>
+          <a:prstGeom prst="rect">
+            <a:avLst/>
+          </a:prstGeom>
+          <a:solidFill>
+            <a:srgbClr val="009670"/>
+          </a:solidFill>
+          <a:ln>
+            <a:noFill/>
+          </a:ln>
+          <a:effectLst/>
+        </p:spPr>
+        <p:style>
+          <a:lnRef idx="1">
+            <a:schemeClr val="accent1"/>
+          </a:lnRef>
+          <a:fillRef idx="3">
+            <a:schemeClr val="accent1"/>
+          </a:fillRef>
+          <a:effectRef idx="2">
+            <a:schemeClr val="accent1"/>
+          </a:effectRef>
+          <a:fontRef idx="minor">
+            <a:schemeClr val="lt1"/>
+          </a:fontRef>
+        </p:style>
+        <p:txBody>
+          <a:bodyPr rtlCol="0" anchor="ctr"/>
+          <a:lstStyle/>
+          <a:p>
+            <a:pPr algn="ctr"/>
+          </a:p>
+        </p:txBody>
+      </p:sp>
+      <p:sp>
+        <p:nvSpPr>
+          <p:cNvPr id="50" name="TextBox 49"/>
+          <p:cNvSpPr txBox="1"/>
+          <p:nvPr/>
+        </p:nvSpPr>
+        <p:spPr>
+          <a:xfrm>
+            <a:off x="685800" y="3675887"/>
+            <a:ext cx="7772400" cy="475488"/>
           </a:xfrm>
           <a:prstGeom prst="rect">
             <a:avLst/>
@@ -24556,13 +24753,13 @@
       </p:sp>
       <p:sp>
         <p:nvSpPr>
-          <p:cNvPr id="47" name="TextBox 46"/>
+          <p:cNvPr id="51" name="TextBox 50"/>
           <p:cNvSpPr txBox="1"/>
           <p:nvPr/>
         </p:nvSpPr>
         <p:spPr>
           <a:xfrm>
-            <a:off x="548640" y="4315968"/>
+            <a:off x="548640" y="4297680"/>
             <a:ext cx="8046720" cy="365760"/>
           </a:xfrm>
           <a:prstGeom prst="rect">
@@ -24583,7 +24780,7 @@
                   <a:srgbClr val="677078"/>
                 </a:solidFill>
               </a:rPr>
-              <a:t>Viszerale Chirurgie: ärztliche Termine mit Besuchsgrund «Adipositas», Monatsdurchschnitt 1.4.–1.10.2026 (kann postoperative Kontrollen enthalten). UDEM: gerundete Monatswerte; ärztlich = Erstkonsultationen und Jahreskontrollen.</a:t>
+              <a:t>Viszerale Chirurgie: ärztliche Termine mit Besuchsgrund «Adipositas», Monatsdurchschnitt 1.4.–1.10.2026; Anteil postbariatrischer Termine nicht quantifiziert (schematisch). ZSG: gerundete Monatswerte; ärztlich = Erstkonsultationen und Jahreskontrollen.</a:t>
             </a:r>
           </a:p>
         </p:txBody>
@@ -35769,7 +35966,7 @@
                   <a:srgbClr val="171C1B"/>
                 </a:solidFill>
               </a:rPr>
-              <a:t>Adipositas-Sprechstunde am UDEM</a:t>
+              <a:t>Adipositas-Sprechstunde am ZSG</a:t>
             </a:r>
           </a:p>
         </p:txBody>
@@ -36536,7 +36733,7 @@
         </p:nvSpPr>
         <p:spPr>
           <a:xfrm>
-            <a:off x="548640" y="2807208"/>
+            <a:off x="548640" y="2880360"/>
             <a:ext cx="5486400" cy="164592"/>
           </a:xfrm>
           <a:prstGeom prst="rect">
@@ -36570,8 +36767,8 @@
         </p:nvSpPr>
         <p:spPr>
           <a:xfrm>
-            <a:off x="548640" y="3035808"/>
-            <a:ext cx="1219200" cy="676656"/>
+            <a:off x="1088136" y="3163824"/>
+            <a:ext cx="1218895" cy="667512"/>
           </a:xfrm>
           <a:prstGeom prst="roundRect">
             <a:avLst>
@@ -36648,8 +36845,8 @@
         </p:nvSpPr>
         <p:spPr>
           <a:xfrm>
-            <a:off x="1914144" y="3035808"/>
-            <a:ext cx="1219200" cy="676656"/>
+            <a:off x="2453335" y="3163824"/>
+            <a:ext cx="1218895" cy="667512"/>
           </a:xfrm>
           <a:prstGeom prst="roundRect">
             <a:avLst>
@@ -36713,7 +36910,7 @@
         </p:nvCxnSpPr>
         <p:spPr>
           <a:xfrm>
-            <a:off x="1790700" y="3374136"/>
+            <a:off x="2329891" y="3497580"/>
             <a:ext cx="100584" cy="0"/>
           </a:xfrm>
           <a:prstGeom prst="line">
@@ -36749,8 +36946,8 @@
         </p:nvSpPr>
         <p:spPr>
           <a:xfrm>
-            <a:off x="3279648" y="3035808"/>
-            <a:ext cx="1219200" cy="676656"/>
+            <a:off x="3818534" y="3163824"/>
+            <a:ext cx="1218895" cy="667512"/>
           </a:xfrm>
           <a:prstGeom prst="roundRect">
             <a:avLst>
@@ -36827,8 +37024,8 @@
         </p:nvCxnSpPr>
         <p:spPr>
           <a:xfrm>
-            <a:off x="3156203" y="3374136"/>
-            <a:ext cx="100585" cy="0"/>
+            <a:off x="3695090" y="3497580"/>
+            <a:ext cx="100584" cy="0"/>
           </a:xfrm>
           <a:prstGeom prst="line">
             <a:avLst/>
@@ -36863,8 +37060,8 @@
         </p:nvSpPr>
         <p:spPr>
           <a:xfrm>
-            <a:off x="4645151" y="3035808"/>
-            <a:ext cx="1219200" cy="676656"/>
+            <a:off x="5183733" y="3163824"/>
+            <a:ext cx="1218895" cy="667512"/>
           </a:xfrm>
           <a:prstGeom prst="roundRect">
             <a:avLst>
@@ -36941,7 +37138,7 @@
         </p:nvCxnSpPr>
         <p:spPr>
           <a:xfrm>
-            <a:off x="4521707" y="3374136"/>
+            <a:off x="5060289" y="3497580"/>
             <a:ext cx="100584" cy="0"/>
           </a:xfrm>
           <a:prstGeom prst="line">
@@ -36977,8 +37174,8 @@
         </p:nvSpPr>
         <p:spPr>
           <a:xfrm>
-            <a:off x="6010655" y="3035808"/>
-            <a:ext cx="1219200" cy="676656"/>
+            <a:off x="6548932" y="3163824"/>
+            <a:ext cx="1218895" cy="667512"/>
           </a:xfrm>
           <a:prstGeom prst="roundRect">
             <a:avLst>
@@ -37042,122 +37239,8 @@
         </p:nvCxnSpPr>
         <p:spPr>
           <a:xfrm>
-            <a:off x="5887211" y="3374136"/>
+            <a:off x="6425488" y="3497580"/>
             <a:ext cx="100584" cy="0"/>
-          </a:xfrm>
-          <a:prstGeom prst="line">
-            <a:avLst/>
-          </a:prstGeom>
-          <a:ln w="15875">
-            <a:solidFill>
-              <a:srgbClr val="677078"/>
-            </a:solidFill>
-            <a:tailEnd type="triangle" w="med" len="med"/>
-          </a:ln>
-        </p:spPr>
-        <p:style>
-          <a:lnRef idx="2">
-            <a:schemeClr val="accent1"/>
-          </a:lnRef>
-          <a:fillRef idx="0">
-            <a:schemeClr val="accent1"/>
-          </a:fillRef>
-          <a:effectRef idx="1">
-            <a:schemeClr val="accent1"/>
-          </a:effectRef>
-          <a:fontRef idx="minor">
-            <a:schemeClr val="tx1"/>
-          </a:fontRef>
-        </p:style>
-      </p:cxnSp>
-      <p:sp>
-        <p:nvSpPr>
-          <p:cNvPr id="48" name="Rounded Rectangle 47"/>
-          <p:cNvSpPr/>
-          <p:nvPr/>
-        </p:nvSpPr>
-        <p:spPr>
-          <a:xfrm>
-            <a:off x="7376160" y="3035808"/>
-            <a:ext cx="1219200" cy="676656"/>
-          </a:xfrm>
-          <a:prstGeom prst="roundRect">
-            <a:avLst>
-              <a:gd name="adj" fmla="val 12000"/>
-            </a:avLst>
-          </a:prstGeom>
-          <a:solidFill>
-            <a:srgbClr val="FFFFFF"/>
-          </a:solidFill>
-          <a:ln w="12700">
-            <a:solidFill>
-              <a:srgbClr val="677078"/>
-            </a:solidFill>
-          </a:ln>
-          <a:effectLst/>
-        </p:spPr>
-        <p:style>
-          <a:lnRef idx="1">
-            <a:schemeClr val="accent1"/>
-          </a:lnRef>
-          <a:fillRef idx="3">
-            <a:schemeClr val="accent1"/>
-          </a:fillRef>
-          <a:effectRef idx="2">
-            <a:schemeClr val="accent1"/>
-          </a:effectRef>
-          <a:fontRef idx="minor">
-            <a:schemeClr val="lt1"/>
-          </a:fontRef>
-        </p:style>
-        <p:txBody>
-          <a:bodyPr rtlCol="0" anchor="ctr" wrap="square" lIns="36576" rIns="36576" tIns="18288" bIns="18288"/>
-          <a:lstStyle/>
-          <a:p>
-            <a:pPr algn="ctr"/>
-            <a:r>
-              <a:rPr sz="950" b="1">
-                <a:solidFill>
-                  <a:srgbClr val="171C1B"/>
-                </a:solidFill>
-              </a:rPr>
-              <a:t>Meilenstein-</a:t>
-            </a:r>
-          </a:p>
-          <a:p>
-            <a:pPr algn="ctr"/>
-            <a:r>
-              <a:rPr sz="950" b="1">
-                <a:solidFill>
-                  <a:srgbClr val="171C1B"/>
-                </a:solidFill>
-              </a:rPr>
-              <a:t>kontrolle</a:t>
-            </a:r>
-          </a:p>
-          <a:p>
-            <a:pPr algn="ctr"/>
-            <a:r>
-              <a:rPr sz="850" b="0">
-                <a:solidFill>
-                  <a:srgbClr val="677078"/>
-                </a:solidFill>
-              </a:rPr>
-              <a:t>dipl. Pflege</a:t>
-            </a:r>
-          </a:p>
-        </p:txBody>
-      </p:sp>
-      <p:cxnSp>
-        <p:nvCxnSpPr>
-          <p:cNvPr id="49" name="Connector 48"/>
-          <p:cNvCxnSpPr/>
-          <p:nvPr/>
-        </p:nvCxnSpPr>
-        <p:spPr>
-          <a:xfrm>
-            <a:off x="7252716" y="3374136"/>
-            <a:ext cx="100583" cy="0"/>
           </a:xfrm>
           <a:prstGeom prst="line">
             <a:avLst/>
@@ -37186,14 +37269,14 @@
       </p:cxnSp>
       <p:cxnSp>
         <p:nvCxnSpPr>
-          <p:cNvPr id="50" name="Connector 49"/>
+          <p:cNvPr id="48" name="Connector 47"/>
           <p:cNvCxnSpPr/>
           <p:nvPr/>
         </p:nvCxnSpPr>
         <p:spPr>
           <a:xfrm>
-            <a:off x="548640" y="3803903"/>
-            <a:ext cx="3950208" cy="0"/>
+            <a:off x="1088136" y="3931920"/>
+            <a:ext cx="2584094" cy="0"/>
           </a:xfrm>
           <a:prstGeom prst="line">
             <a:avLst/>
@@ -37221,14 +37304,14 @@
       </p:cxnSp>
       <p:sp>
         <p:nvSpPr>
-          <p:cNvPr id="51" name="TextBox 50"/>
+          <p:cNvPr id="49" name="TextBox 48"/>
           <p:cNvSpPr txBox="1"/>
           <p:nvPr/>
         </p:nvSpPr>
         <p:spPr>
           <a:xfrm>
-            <a:off x="548640" y="3858768"/>
-            <a:ext cx="3950208" cy="164592"/>
+            <a:off x="1088136" y="3986783"/>
+            <a:ext cx="2584094" cy="164592"/>
           </a:xfrm>
           <a:prstGeom prst="rect">
             <a:avLst/>
@@ -37255,14 +37338,14 @@
       </p:sp>
       <p:cxnSp>
         <p:nvCxnSpPr>
-          <p:cNvPr id="52" name="Connector 51"/>
+          <p:cNvPr id="50" name="Connector 49"/>
           <p:cNvCxnSpPr/>
           <p:nvPr/>
         </p:nvCxnSpPr>
         <p:spPr>
           <a:xfrm>
-            <a:off x="7985759" y="3712463"/>
-            <a:ext cx="0" cy="182881"/>
+            <a:off x="7158380" y="3831335"/>
+            <a:ext cx="0" cy="210313"/>
           </a:xfrm>
           <a:prstGeom prst="line">
             <a:avLst/>
@@ -37290,14 +37373,14 @@
       </p:cxnSp>
       <p:cxnSp>
         <p:nvCxnSpPr>
-          <p:cNvPr id="53" name="Connector 52"/>
+          <p:cNvPr id="51" name="Connector 50"/>
           <p:cNvCxnSpPr/>
           <p:nvPr/>
         </p:nvCxnSpPr>
         <p:spPr>
           <a:xfrm flipH="1">
-            <a:off x="5254751" y="3895344"/>
-            <a:ext cx="2731008" cy="0"/>
+            <a:off x="4427982" y="4041648"/>
+            <a:ext cx="2730398" cy="0"/>
           </a:xfrm>
           <a:prstGeom prst="line">
             <a:avLst/>
@@ -37325,14 +37408,14 @@
       </p:cxnSp>
       <p:cxnSp>
         <p:nvCxnSpPr>
-          <p:cNvPr id="54" name="Connector 53"/>
+          <p:cNvPr id="52" name="Connector 51"/>
           <p:cNvCxnSpPr/>
           <p:nvPr/>
         </p:nvCxnSpPr>
         <p:spPr>
           <a:xfrm flipV="1">
-            <a:off x="5254751" y="3721607"/>
-            <a:ext cx="0" cy="173737"/>
+            <a:off x="4427982" y="3840479"/>
+            <a:ext cx="0" cy="201169"/>
           </a:xfrm>
           <a:prstGeom prst="line">
             <a:avLst/>
@@ -37361,14 +37444,14 @@
       </p:cxnSp>
       <p:sp>
         <p:nvSpPr>
-          <p:cNvPr id="55" name="TextBox 54"/>
+          <p:cNvPr id="53" name="TextBox 52"/>
           <p:cNvSpPr txBox="1"/>
           <p:nvPr/>
         </p:nvSpPr>
         <p:spPr>
           <a:xfrm>
-            <a:off x="5254751" y="3941063"/>
-            <a:ext cx="2731007" cy="164592"/>
+            <a:off x="4153662" y="4096511"/>
+            <a:ext cx="3279038" cy="164592"/>
           </a:xfrm>
           <a:prstGeom prst="rect">
             <a:avLst/>
@@ -37388,41 +37471,7 @@
                   <a:srgbClr val="009670"/>
                 </a:solidFill>
               </a:rPr>
-              <a:t>jährlich wiederkehrend</a:t>
-            </a:r>
-          </a:p>
-        </p:txBody>
-      </p:sp>
-      <p:sp>
-        <p:nvSpPr>
-          <p:cNvPr id="56" name="TextBox 55"/>
-          <p:cNvSpPr txBox="1"/>
-          <p:nvPr/>
-        </p:nvSpPr>
-        <p:spPr>
-          <a:xfrm>
-            <a:off x="548640" y="4462272"/>
-            <a:ext cx="8046720" cy="274320"/>
-          </a:xfrm>
-          <a:prstGeom prst="rect">
-            <a:avLst/>
-          </a:prstGeom>
-          <a:noFill/>
-        </p:spPr>
-        <p:txBody>
-          <a:bodyPr wrap="square" lIns="0" rIns="0" tIns="0" bIns="0" anchor="t">
-            <a:spAutoFit/>
-          </a:bodyPr>
-          <a:lstStyle/>
-          <a:p>
-            <a:pPr algn="l"/>
-            <a:r>
-              <a:rPr sz="800" b="0" i="0">
-                <a:solidFill>
-                  <a:srgbClr val="677078"/>
-                </a:solidFill>
-              </a:rPr>
-              <a:t>Gerundete Monatswerte UDEM. Ärztliche Konsultationen = Erstkonsultationen und Jahreskontrollen; pro ärztliche Konsultation ein Metabolic Assessment.</a:t>
+              <a:t>jährlich wiederkehrend bis Behandlungsschluss</a:t>
             </a:r>
           </a:p>
         </p:txBody>

</xml_diff>

<commit_message>
Präsentation: Vergleichsfolie mit ≈ 50 postbariatrischen Terminen am ZSG
Die ≈ 130 Termine der Viszeralchirurgie werden wieder vollständig
dargestellt. Die postbariatrischen Termine von Patient:innen aus der
Viszeralchirurgie (≈ 50 pro Monat) erscheinen als eigener Abschnitt
beim ZSG; Summen in Merksatz und Kasten entsprechend angepasst.

Co-Authored-By: Claude Opus 5.5 <noreply@anthropic.com>
Claude-Session: https://claude.ai/code/session_01Y3aMFwC6xTttGKHnTQtGy4
</commit_message>
<xml_diff>
--- a/praesentation/Zusammenarbeit_Adipositas_UDEM_UVCM_Entwurf.pptx
+++ b/praesentation/Zusammenarbeit_Adipositas_UDEM_UVCM_Entwurf.pptx
@@ -23709,7 +23709,7 @@
         <p:spPr>
           <a:xfrm>
             <a:off x="2148840" y="1993392"/>
-            <a:ext cx="2414016" cy="384048"/>
+            <a:ext cx="2139696" cy="384048"/>
           </a:xfrm>
           <a:prstGeom prst="rect">
             <a:avLst/>
@@ -23746,230 +23746,14 @@
       </p:sp>
       <p:sp>
         <p:nvSpPr>
-          <p:cNvPr id="25" name="TextBox 24"/>
-          <p:cNvSpPr txBox="1"/>
-          <p:nvPr/>
-        </p:nvSpPr>
-        <p:spPr>
-          <a:xfrm>
-            <a:off x="4654296" y="2048256"/>
-            <a:ext cx="731520" cy="274320"/>
-          </a:xfrm>
-          <a:prstGeom prst="rect">
-            <a:avLst/>
-          </a:prstGeom>
-          <a:noFill/>
-        </p:spPr>
-        <p:txBody>
-          <a:bodyPr wrap="square" lIns="0" rIns="0" tIns="0" bIns="0" anchor="t">
-            <a:spAutoFit/>
-          </a:bodyPr>
-          <a:lstStyle/>
-          <a:p>
-            <a:pPr algn="l"/>
-            <a:r>
-              <a:rPr sz="1500" b="1" i="0">
-                <a:solidFill>
-                  <a:srgbClr val="171C1B"/>
-                </a:solidFill>
-              </a:rPr>
-              <a:t>≈ 300</a:t>
-            </a:r>
-          </a:p>
-        </p:txBody>
-      </p:sp>
-      <p:cxnSp>
-        <p:nvCxnSpPr>
-          <p:cNvPr id="26" name="Connector 25"/>
-          <p:cNvCxnSpPr/>
-          <p:nvPr/>
-        </p:nvCxnSpPr>
-        <p:spPr>
-          <a:xfrm flipV="1">
-            <a:off x="4654296" y="2423160"/>
-            <a:ext cx="146304" cy="109728"/>
-          </a:xfrm>
-          <a:prstGeom prst="line">
-            <a:avLst/>
-          </a:prstGeom>
-          <a:ln w="19050">
-            <a:solidFill>
-              <a:srgbClr val="009670"/>
-            </a:solidFill>
-            <a:tailEnd type="triangle" w="med" len="med"/>
-          </a:ln>
-        </p:spPr>
-        <p:style>
-          <a:lnRef idx="2">
-            <a:schemeClr val="accent1"/>
-          </a:lnRef>
-          <a:fillRef idx="0">
-            <a:schemeClr val="accent1"/>
-          </a:fillRef>
-          <a:effectRef idx="1">
-            <a:schemeClr val="accent1"/>
-          </a:effectRef>
-          <a:fontRef idx="minor">
-            <a:schemeClr val="tx1"/>
-          </a:fontRef>
-        </p:style>
-      </p:cxnSp>
-      <p:sp>
-        <p:nvSpPr>
-          <p:cNvPr id="27" name="TextBox 26"/>
-          <p:cNvSpPr txBox="1"/>
-          <p:nvPr/>
-        </p:nvSpPr>
-        <p:spPr>
-          <a:xfrm>
-            <a:off x="4855464" y="2404872"/>
-            <a:ext cx="914400" cy="146304"/>
-          </a:xfrm>
-          <a:prstGeom prst="rect">
-            <a:avLst/>
-          </a:prstGeom>
-          <a:noFill/>
-        </p:spPr>
-        <p:txBody>
-          <a:bodyPr wrap="square" lIns="0" rIns="0" tIns="0" bIns="0" anchor="t">
-            <a:spAutoFit/>
-          </a:bodyPr>
-          <a:lstStyle/>
-          <a:p>
-            <a:pPr algn="l"/>
-            <a:r>
-              <a:rPr sz="800" b="1" i="0">
-                <a:solidFill>
-                  <a:srgbClr val="009670"/>
-                </a:solidFill>
-              </a:rPr>
-              <a:t>Tendenz steigend</a:t>
-            </a:r>
-          </a:p>
-        </p:txBody>
-      </p:sp>
-      <p:sp>
-        <p:nvSpPr>
-          <p:cNvPr id="28" name="TextBox 27"/>
-          <p:cNvSpPr txBox="1"/>
-          <p:nvPr/>
-        </p:nvSpPr>
-        <p:spPr>
-          <a:xfrm>
-            <a:off x="548640" y="2743200"/>
-            <a:ext cx="1508760" cy="182880"/>
-          </a:xfrm>
-          <a:prstGeom prst="rect">
-            <a:avLst/>
-          </a:prstGeom>
-          <a:noFill/>
-        </p:spPr>
-        <p:txBody>
-          <a:bodyPr wrap="square" lIns="0" rIns="0" tIns="0" bIns="0" anchor="t">
-            <a:spAutoFit/>
-          </a:bodyPr>
-          <a:lstStyle/>
-          <a:p>
-            <a:pPr algn="l"/>
-            <a:r>
-              <a:rPr sz="1100" b="1" i="0">
-                <a:solidFill>
-                  <a:srgbClr val="171C1B"/>
-                </a:solidFill>
-              </a:rPr>
-              <a:t>Viszerale Chirurgie</a:t>
-            </a:r>
-          </a:p>
-        </p:txBody>
-      </p:sp>
-      <p:sp>
-        <p:nvSpPr>
-          <p:cNvPr id="29" name="TextBox 28"/>
-          <p:cNvSpPr txBox="1"/>
-          <p:nvPr/>
-        </p:nvSpPr>
-        <p:spPr>
-          <a:xfrm>
-            <a:off x="548640" y="2926080"/>
-            <a:ext cx="1508760" cy="310896"/>
-          </a:xfrm>
-          <a:prstGeom prst="rect">
-            <a:avLst/>
-          </a:prstGeom>
-          <a:noFill/>
-        </p:spPr>
-        <p:txBody>
-          <a:bodyPr wrap="square" lIns="0" rIns="0" tIns="0" bIns="0" anchor="t">
-            <a:spAutoFit/>
-          </a:bodyPr>
-          <a:lstStyle/>
-          <a:p>
-            <a:pPr algn="l"/>
-            <a:r>
-              <a:rPr sz="850" b="0" i="0">
-                <a:solidFill>
-                  <a:srgbClr val="677078"/>
-                </a:solidFill>
-              </a:rPr>
-              <a:t>UVCM · Besuchsgrund Adipositas</a:t>
-            </a:r>
-          </a:p>
-        </p:txBody>
-      </p:sp>
-      <p:sp>
-        <p:nvSpPr>
-          <p:cNvPr id="30" name="Rectangle 29"/>
+          <p:cNvPr id="25" name="Rectangle 24"/>
           <p:cNvSpPr/>
           <p:nvPr/>
         </p:nvSpPr>
         <p:spPr>
           <a:xfrm>
-            <a:off x="2148840" y="2724912"/>
-            <a:ext cx="627644" cy="384048"/>
-          </a:xfrm>
-          <a:prstGeom prst="rect">
-            <a:avLst/>
-          </a:prstGeom>
-          <a:solidFill>
-            <a:srgbClr val="009670"/>
-          </a:solidFill>
-          <a:ln>
-            <a:noFill/>
-          </a:ln>
-          <a:effectLst/>
-        </p:spPr>
-        <p:style>
-          <a:lnRef idx="1">
-            <a:schemeClr val="accent1"/>
-          </a:lnRef>
-          <a:fillRef idx="3">
-            <a:schemeClr val="accent1"/>
-          </a:fillRef>
-          <a:effectRef idx="2">
-            <a:schemeClr val="accent1"/>
-          </a:effectRef>
-          <a:fontRef idx="minor">
-            <a:schemeClr val="lt1"/>
-          </a:fontRef>
-        </p:style>
-        <p:txBody>
-          <a:bodyPr rtlCol="0" anchor="ctr"/>
-          <a:lstStyle/>
-          <a:p>
-            <a:pPr algn="ctr"/>
-          </a:p>
-        </p:txBody>
-      </p:sp>
-      <p:sp>
-        <p:nvSpPr>
-          <p:cNvPr id="31" name="Rectangle 30"/>
-          <p:cNvSpPr/>
-          <p:nvPr/>
-        </p:nvSpPr>
-        <p:spPr>
-          <a:xfrm>
-            <a:off x="2794772" y="2724912"/>
-            <a:ext cx="400141" cy="384048"/>
+            <a:off x="4306823" y="1993392"/>
+            <a:ext cx="356615" cy="384048"/>
           </a:xfrm>
           <a:prstGeom prst="rect">
             <a:avLst/>
@@ -24013,14 +23797,14 @@
       </p:sp>
       <p:sp>
         <p:nvSpPr>
-          <p:cNvPr id="32" name="TextBox 31"/>
+          <p:cNvPr id="26" name="TextBox 25"/>
           <p:cNvSpPr txBox="1"/>
           <p:nvPr/>
         </p:nvSpPr>
         <p:spPr>
           <a:xfrm>
-            <a:off x="3286353" y="2779776"/>
-            <a:ext cx="731520" cy="274320"/>
+            <a:off x="4754879" y="2048256"/>
+            <a:ext cx="1097280" cy="274320"/>
           </a:xfrm>
           <a:prstGeom prst="rect">
             <a:avLst/>
@@ -24040,21 +23824,21 @@
                   <a:srgbClr val="171C1B"/>
                 </a:solidFill>
               </a:rPr>
-              <a:t>≈ 130</a:t>
+              <a:t>≈ 300 + 50</a:t>
             </a:r>
           </a:p>
         </p:txBody>
       </p:sp>
       <p:cxnSp>
         <p:nvCxnSpPr>
-          <p:cNvPr id="33" name="Connector 32"/>
+          <p:cNvPr id="27" name="Connector 26"/>
           <p:cNvCxnSpPr/>
           <p:nvPr/>
         </p:nvCxnSpPr>
         <p:spPr>
           <a:xfrm flipV="1">
-            <a:off x="2994842" y="2404872"/>
-            <a:ext cx="0" cy="301752"/>
+            <a:off x="4754879" y="2423160"/>
+            <a:ext cx="146304" cy="109728"/>
           </a:xfrm>
           <a:prstGeom prst="line">
             <a:avLst/>
@@ -24083,14 +23867,14 @@
       </p:cxnSp>
       <p:sp>
         <p:nvSpPr>
-          <p:cNvPr id="34" name="TextBox 33"/>
+          <p:cNvPr id="28" name="TextBox 27"/>
           <p:cNvSpPr txBox="1"/>
           <p:nvPr/>
         </p:nvSpPr>
         <p:spPr>
           <a:xfrm>
-            <a:off x="3086282" y="2450592"/>
-            <a:ext cx="1737360" cy="274320"/>
+            <a:off x="4956047" y="2404872"/>
+            <a:ext cx="914400" cy="146304"/>
           </a:xfrm>
           <a:prstGeom prst="rect">
             <a:avLst/>
@@ -24110,39 +23894,174 @@
                   <a:srgbClr val="009670"/>
                 </a:solidFill>
               </a:rPr>
-              <a:t>Postbariatrische Termine</a:t>
-            </a:r>
-          </a:p>
+              <a:t>Tendenz steigend</a:t>
+            </a:r>
+          </a:p>
+        </p:txBody>
+      </p:sp>
+      <p:sp>
+        <p:nvSpPr>
+          <p:cNvPr id="29" name="TextBox 28"/>
+          <p:cNvSpPr txBox="1"/>
+          <p:nvPr/>
+        </p:nvSpPr>
+        <p:spPr>
+          <a:xfrm>
+            <a:off x="548640" y="2743200"/>
+            <a:ext cx="1508760" cy="182880"/>
+          </a:xfrm>
+          <a:prstGeom prst="rect">
+            <a:avLst/>
+          </a:prstGeom>
+          <a:noFill/>
+        </p:spPr>
+        <p:txBody>
+          <a:bodyPr wrap="square" lIns="0" rIns="0" tIns="0" bIns="0" anchor="t">
+            <a:spAutoFit/>
+          </a:bodyPr>
+          <a:lstStyle/>
           <a:p>
             <a:pPr algn="l"/>
             <a:r>
-              <a:rPr sz="800" b="0" i="0">
+              <a:rPr sz="1100" b="1" i="0">
                 <a:solidFill>
-                  <a:srgbClr val="009670"/>
+                  <a:srgbClr val="171C1B"/>
                 </a:solidFill>
               </a:rPr>
-              <a:t>Anteil ebenfalls am ZSG</a:t>
+              <a:t>Viszerale Chirurgie</a:t>
+            </a:r>
+          </a:p>
+        </p:txBody>
+      </p:sp>
+      <p:sp>
+        <p:nvSpPr>
+          <p:cNvPr id="30" name="TextBox 29"/>
+          <p:cNvSpPr txBox="1"/>
+          <p:nvPr/>
+        </p:nvSpPr>
+        <p:spPr>
+          <a:xfrm>
+            <a:off x="548640" y="2926080"/>
+            <a:ext cx="1508760" cy="310896"/>
+          </a:xfrm>
+          <a:prstGeom prst="rect">
+            <a:avLst/>
+          </a:prstGeom>
+          <a:noFill/>
+        </p:spPr>
+        <p:txBody>
+          <a:bodyPr wrap="square" lIns="0" rIns="0" tIns="0" bIns="0" anchor="t">
+            <a:spAutoFit/>
+          </a:bodyPr>
+          <a:lstStyle/>
+          <a:p>
+            <a:pPr algn="l"/>
+            <a:r>
+              <a:rPr sz="850" b="0" i="0">
+                <a:solidFill>
+                  <a:srgbClr val="677078"/>
+                </a:solidFill>
+              </a:rPr>
+              <a:t>UVCM · Besuchsgrund Adipositas</a:t>
+            </a:r>
+          </a:p>
+        </p:txBody>
+      </p:sp>
+      <p:sp>
+        <p:nvSpPr>
+          <p:cNvPr id="31" name="Rectangle 30"/>
+          <p:cNvSpPr/>
+          <p:nvPr/>
+        </p:nvSpPr>
+        <p:spPr>
+          <a:xfrm>
+            <a:off x="2148840" y="2724912"/>
+            <a:ext cx="927201" cy="384048"/>
+          </a:xfrm>
+          <a:prstGeom prst="rect">
+            <a:avLst/>
+          </a:prstGeom>
+          <a:solidFill>
+            <a:srgbClr val="009670"/>
+          </a:solidFill>
+          <a:ln>
+            <a:noFill/>
+          </a:ln>
+          <a:effectLst/>
+        </p:spPr>
+        <p:style>
+          <a:lnRef idx="1">
+            <a:schemeClr val="accent1"/>
+          </a:lnRef>
+          <a:fillRef idx="3">
+            <a:schemeClr val="accent1"/>
+          </a:fillRef>
+          <a:effectRef idx="2">
+            <a:schemeClr val="accent1"/>
+          </a:effectRef>
+          <a:fontRef idx="minor">
+            <a:schemeClr val="lt1"/>
+          </a:fontRef>
+        </p:style>
+        <p:txBody>
+          <a:bodyPr rtlCol="0" anchor="ctr"/>
+          <a:lstStyle/>
+          <a:p>
+            <a:pPr algn="ctr"/>
+          </a:p>
+        </p:txBody>
+      </p:sp>
+      <p:sp>
+        <p:nvSpPr>
+          <p:cNvPr id="32" name="TextBox 31"/>
+          <p:cNvSpPr txBox="1"/>
+          <p:nvPr/>
+        </p:nvSpPr>
+        <p:spPr>
+          <a:xfrm>
+            <a:off x="3167481" y="2779776"/>
+            <a:ext cx="731520" cy="274320"/>
+          </a:xfrm>
+          <a:prstGeom prst="rect">
+            <a:avLst/>
+          </a:prstGeom>
+          <a:noFill/>
+        </p:spPr>
+        <p:txBody>
+          <a:bodyPr wrap="square" lIns="0" rIns="0" tIns="0" bIns="0" anchor="t">
+            <a:spAutoFit/>
+          </a:bodyPr>
+          <a:lstStyle/>
+          <a:p>
+            <a:pPr algn="l"/>
+            <a:r>
+              <a:rPr sz="1500" b="1" i="0">
+                <a:solidFill>
+                  <a:srgbClr val="171C1B"/>
+                </a:solidFill>
+              </a:rPr>
+              <a:t>≈ 130</a:t>
             </a:r>
           </a:p>
         </p:txBody>
       </p:sp>
       <p:cxnSp>
         <p:nvCxnSpPr>
-          <p:cNvPr id="35" name="Connector 34"/>
+          <p:cNvPr id="33" name="Connector 32"/>
           <p:cNvCxnSpPr/>
           <p:nvPr/>
         </p:nvCxnSpPr>
         <p:spPr>
-          <a:xfrm>
-            <a:off x="2148840" y="1920240"/>
-            <a:ext cx="0" cy="1261872"/>
+          <a:xfrm flipV="1">
+            <a:off x="2893161" y="2551176"/>
+            <a:ext cx="0" cy="164592"/>
           </a:xfrm>
           <a:prstGeom prst="line">
             <a:avLst/>
           </a:prstGeom>
-          <a:ln w="12700">
+          <a:ln w="15875">
             <a:solidFill>
-              <a:srgbClr val="677078"/>
+              <a:srgbClr val="009670"/>
             </a:solidFill>
           </a:ln>
         </p:spPr>
@@ -24161,16 +24080,215 @@
           </a:fontRef>
         </p:style>
       </p:cxnSp>
-      <p:sp>
-        <p:nvSpPr>
-          <p:cNvPr id="36" name="Rounded Rectangle 35"/>
+      <p:cxnSp>
+        <p:nvCxnSpPr>
+          <p:cNvPr id="34" name="Connector 33"/>
+          <p:cNvCxnSpPr/>
+          <p:nvPr/>
+        </p:nvCxnSpPr>
+        <p:spPr>
+          <a:xfrm>
+            <a:off x="2893161" y="2551176"/>
+            <a:ext cx="1591970" cy="0"/>
+          </a:xfrm>
+          <a:prstGeom prst="line">
+            <a:avLst/>
+          </a:prstGeom>
+          <a:ln w="15875">
+            <a:solidFill>
+              <a:srgbClr val="009670"/>
+            </a:solidFill>
+          </a:ln>
+        </p:spPr>
+        <p:style>
+          <a:lnRef idx="2">
+            <a:schemeClr val="accent1"/>
+          </a:lnRef>
+          <a:fillRef idx="0">
+            <a:schemeClr val="accent1"/>
+          </a:fillRef>
+          <a:effectRef idx="1">
+            <a:schemeClr val="accent1"/>
+          </a:effectRef>
+          <a:fontRef idx="minor">
+            <a:schemeClr val="tx1"/>
+          </a:fontRef>
+        </p:style>
+      </p:cxnSp>
+      <p:cxnSp>
+        <p:nvCxnSpPr>
+          <p:cNvPr id="35" name="Connector 34"/>
+          <p:cNvCxnSpPr/>
+          <p:nvPr/>
+        </p:nvCxnSpPr>
+        <p:spPr>
+          <a:xfrm flipV="1">
+            <a:off x="4485131" y="2395728"/>
+            <a:ext cx="0" cy="155448"/>
+          </a:xfrm>
+          <a:prstGeom prst="line">
+            <a:avLst/>
+          </a:prstGeom>
+          <a:ln w="15875">
+            <a:solidFill>
+              <a:srgbClr val="009670"/>
+            </a:solidFill>
+            <a:tailEnd type="triangle" w="med" len="med"/>
+          </a:ln>
+        </p:spPr>
+        <p:style>
+          <a:lnRef idx="2">
+            <a:schemeClr val="accent1"/>
+          </a:lnRef>
+          <a:fillRef idx="0">
+            <a:schemeClr val="accent1"/>
+          </a:fillRef>
+          <a:effectRef idx="1">
+            <a:schemeClr val="accent1"/>
+          </a:effectRef>
+          <a:fontRef idx="minor">
+            <a:schemeClr val="tx1"/>
+          </a:fontRef>
+        </p:style>
+      </p:cxnSp>
+      <p:cxnSp>
+        <p:nvCxnSpPr>
+          <p:cNvPr id="36" name="Connector 35"/>
+          <p:cNvCxnSpPr/>
+          <p:nvPr/>
+        </p:nvCxnSpPr>
+        <p:spPr>
+          <a:xfrm>
+            <a:off x="2148840" y="1920240"/>
+            <a:ext cx="0" cy="1261872"/>
+          </a:xfrm>
+          <a:prstGeom prst="line">
+            <a:avLst/>
+          </a:prstGeom>
+          <a:ln w="12700">
+            <a:solidFill>
+              <a:srgbClr val="677078"/>
+            </a:solidFill>
+          </a:ln>
+        </p:spPr>
+        <p:style>
+          <a:lnRef idx="2">
+            <a:schemeClr val="accent1"/>
+          </a:lnRef>
+          <a:fillRef idx="0">
+            <a:schemeClr val="accent1"/>
+          </a:fillRef>
+          <a:effectRef idx="1">
+            <a:schemeClr val="accent1"/>
+          </a:effectRef>
+          <a:fontRef idx="minor">
+            <a:schemeClr val="tx1"/>
+          </a:fontRef>
+        </p:style>
+      </p:cxnSp>
+      <p:sp>
+        <p:nvSpPr>
+          <p:cNvPr id="37" name="Rectangle 36"/>
           <p:cNvSpPr/>
           <p:nvPr/>
         </p:nvSpPr>
         <p:spPr>
           <a:xfrm>
-            <a:off x="548640" y="3310128"/>
-            <a:ext cx="5120640" cy="274320"/>
+            <a:off x="2148840" y="3200400"/>
+            <a:ext cx="237744" cy="137160"/>
+          </a:xfrm>
+          <a:prstGeom prst="rect">
+            <a:avLst/>
+          </a:prstGeom>
+          <a:pattFill prst="wdUpDiag">
+            <a:fgClr>
+              <a:srgbClr val="009670"/>
+            </a:fgClr>
+            <a:bgClr>
+              <a:srgbClr val="FFFFFF"/>
+            </a:bgClr>
+          </a:pattFill>
+          <a:ln w="12700">
+            <a:solidFill>
+              <a:srgbClr val="009670"/>
+            </a:solidFill>
+          </a:ln>
+          <a:effectLst/>
+        </p:spPr>
+        <p:style>
+          <a:lnRef idx="1">
+            <a:schemeClr val="accent1"/>
+          </a:lnRef>
+          <a:fillRef idx="3">
+            <a:schemeClr val="accent1"/>
+          </a:fillRef>
+          <a:effectRef idx="2">
+            <a:schemeClr val="accent1"/>
+          </a:effectRef>
+          <a:fontRef idx="minor">
+            <a:schemeClr val="lt1"/>
+          </a:fontRef>
+        </p:style>
+        <p:txBody>
+          <a:bodyPr rtlCol="0" anchor="ctr"/>
+          <a:lstStyle/>
+          <a:p>
+            <a:pPr algn="ctr"/>
+          </a:p>
+        </p:txBody>
+      </p:sp>
+      <p:sp>
+        <p:nvSpPr>
+          <p:cNvPr id="38" name="TextBox 37"/>
+          <p:cNvSpPr txBox="1"/>
+          <p:nvPr/>
+        </p:nvSpPr>
+        <p:spPr>
+          <a:xfrm>
+            <a:off x="2478024" y="3191256"/>
+            <a:ext cx="3474720" cy="182880"/>
+          </a:xfrm>
+          <a:prstGeom prst="rect">
+            <a:avLst/>
+          </a:prstGeom>
+          <a:noFill/>
+        </p:spPr>
+        <p:txBody>
+          <a:bodyPr wrap="square" lIns="0" rIns="0" tIns="0" bIns="0" anchor="t">
+            <a:spAutoFit/>
+          </a:bodyPr>
+          <a:lstStyle/>
+          <a:p>
+            <a:pPr algn="l"/>
+            <a:r>
+              <a:rPr sz="800" b="1" i="0">
+                <a:solidFill>
+                  <a:srgbClr val="171C1B"/>
+                </a:solidFill>
+              </a:rPr>
+              <a:t>≈ 50 postbariatrische Termine am ZSG</a:t>
+            </a:r>
+            <a:r>
+              <a:rPr sz="800" b="0" i="0">
+                <a:solidFill>
+                  <a:srgbClr val="677078"/>
+                </a:solidFill>
+              </a:rPr>
+              <a:t> · nach OP Viszeralchirurgie</a:t>
+            </a:r>
+          </a:p>
+        </p:txBody>
+      </p:sp>
+      <p:sp>
+        <p:nvSpPr>
+          <p:cNvPr id="39" name="Rounded Rectangle 38"/>
+          <p:cNvSpPr/>
+          <p:nvPr/>
+        </p:nvSpPr>
+        <p:spPr>
+          <a:xfrm>
+            <a:off x="548640" y="3438144"/>
+            <a:ext cx="5120640" cy="246888"/>
           </a:xfrm>
           <a:prstGeom prst="roundRect">
             <a:avLst>
@@ -24228,14 +24346,14 @@
       </p:sp>
       <p:sp>
         <p:nvSpPr>
-          <p:cNvPr id="37" name="Rectangle 36"/>
+          <p:cNvPr id="40" name="Rectangle 39"/>
           <p:cNvSpPr/>
           <p:nvPr/>
         </p:nvSpPr>
         <p:spPr>
           <a:xfrm>
             <a:off x="5989320" y="1645920"/>
-            <a:ext cx="2606040" cy="1883664"/>
+            <a:ext cx="2606040" cy="2039112"/>
           </a:xfrm>
           <a:prstGeom prst="rect">
             <a:avLst/>
@@ -24272,14 +24390,14 @@
       </p:sp>
       <p:sp>
         <p:nvSpPr>
-          <p:cNvPr id="38" name="Rectangle 37"/>
+          <p:cNvPr id="41" name="Rectangle 40"/>
           <p:cNvSpPr/>
           <p:nvPr/>
         </p:nvSpPr>
         <p:spPr>
           <a:xfrm>
             <a:off x="5989320" y="1645920"/>
-            <a:ext cx="36576" cy="1883664"/>
+            <a:ext cx="36576" cy="2039112"/>
           </a:xfrm>
           <a:prstGeom prst="rect">
             <a:avLst/>
@@ -24316,7 +24434,7 @@
       </p:sp>
       <p:sp>
         <p:nvSpPr>
-          <p:cNvPr id="39" name="TextBox 38"/>
+          <p:cNvPr id="42" name="TextBox 41"/>
           <p:cNvSpPr txBox="1"/>
           <p:nvPr/>
         </p:nvSpPr>
@@ -24350,7 +24468,7 @@
       </p:sp>
       <p:sp>
         <p:nvSpPr>
-          <p:cNvPr id="40" name="TextBox 39"/>
+          <p:cNvPr id="43" name="TextBox 42"/>
           <p:cNvSpPr txBox="1"/>
           <p:nvPr/>
         </p:nvSpPr>
@@ -24384,7 +24502,7 @@
       </p:sp>
       <p:sp>
         <p:nvSpPr>
-          <p:cNvPr id="41" name="TextBox 40"/>
+          <p:cNvPr id="44" name="TextBox 43"/>
           <p:cNvSpPr txBox="1"/>
           <p:nvPr/>
         </p:nvSpPr>
@@ -24418,7 +24536,7 @@
       </p:sp>
       <p:sp>
         <p:nvSpPr>
-          <p:cNvPr id="42" name="TextBox 41"/>
+          <p:cNvPr id="45" name="TextBox 44"/>
           <p:cNvSpPr txBox="1"/>
           <p:nvPr/>
         </p:nvSpPr>
@@ -24452,7 +24570,7 @@
       </p:sp>
       <p:sp>
         <p:nvSpPr>
-          <p:cNvPr id="43" name="TextBox 42"/>
+          <p:cNvPr id="46" name="TextBox 45"/>
           <p:cNvSpPr txBox="1"/>
           <p:nvPr/>
         </p:nvSpPr>
@@ -24486,7 +24604,7 @@
       </p:sp>
       <p:sp>
         <p:nvSpPr>
-          <p:cNvPr id="44" name="TextBox 43"/>
+          <p:cNvPr id="47" name="TextBox 46"/>
           <p:cNvSpPr txBox="1"/>
           <p:nvPr/>
         </p:nvSpPr>
@@ -24520,7 +24638,7 @@
       </p:sp>
       <p:sp>
         <p:nvSpPr>
-          <p:cNvPr id="45" name="TextBox 44"/>
+          <p:cNvPr id="48" name="TextBox 47"/>
           <p:cNvSpPr txBox="1"/>
           <p:nvPr/>
         </p:nvSpPr>
@@ -24554,7 +24672,7 @@
       </p:sp>
       <p:cxnSp>
         <p:nvCxnSpPr>
-          <p:cNvPr id="46" name="Connector 45"/>
+          <p:cNvPr id="49" name="Connector 48"/>
           <p:cNvCxnSpPr/>
           <p:nvPr/>
         </p:nvCxnSpPr>
@@ -24589,14 +24707,14 @@
       </p:cxnSp>
       <p:sp>
         <p:nvSpPr>
-          <p:cNvPr id="47" name="TextBox 46"/>
+          <p:cNvPr id="50" name="TextBox 49"/>
           <p:cNvSpPr txBox="1"/>
           <p:nvPr/>
         </p:nvSpPr>
         <p:spPr>
           <a:xfrm>
             <a:off x="6172200" y="3200400"/>
-            <a:ext cx="2286000" cy="228600"/>
+            <a:ext cx="2286000" cy="384048"/>
           </a:xfrm>
           <a:prstGeom prst="rect">
             <a:avLst/>
@@ -24616,7 +24734,7 @@
                   <a:srgbClr val="171C1B"/>
                 </a:solidFill>
               </a:rPr>
-              <a:t>≈ 780</a:t>
+              <a:t>≈ 830</a:t>
             </a:r>
             <a:r>
               <a:rPr sz="1000" b="0" i="0">
@@ -24627,18 +24745,29 @@
               <a:t> Kontakte pro Monat gesamt</a:t>
             </a:r>
           </a:p>
-        </p:txBody>
-      </p:sp>
-      <p:sp>
-        <p:nvSpPr>
-          <p:cNvPr id="48" name="Rectangle 47"/>
+          <a:p>
+            <a:pPr algn="l"/>
+            <a:r>
+              <a:rPr sz="850" b="0" i="0">
+                <a:solidFill>
+                  <a:srgbClr val="677078"/>
+                </a:solidFill>
+              </a:rPr>
+              <a:t>inkl. ≈ 50 postbariatrische Termine</a:t>
+            </a:r>
+          </a:p>
+        </p:txBody>
+      </p:sp>
+      <p:sp>
+        <p:nvSpPr>
+          <p:cNvPr id="51" name="Rectangle 50"/>
           <p:cNvSpPr/>
           <p:nvPr/>
         </p:nvSpPr>
         <p:spPr>
           <a:xfrm>
-            <a:off x="548640" y="3675887"/>
-            <a:ext cx="8046720" cy="475488"/>
+            <a:off x="548640" y="3803904"/>
+            <a:ext cx="8046720" cy="420624"/>
           </a:xfrm>
           <a:prstGeom prst="rect">
             <a:avLst/>
@@ -24675,14 +24804,14 @@
       </p:sp>
       <p:sp>
         <p:nvSpPr>
-          <p:cNvPr id="49" name="Rectangle 48"/>
+          <p:cNvPr id="52" name="Rectangle 51"/>
           <p:cNvSpPr/>
           <p:nvPr/>
         </p:nvSpPr>
         <p:spPr>
           <a:xfrm>
-            <a:off x="548640" y="3675887"/>
-            <a:ext cx="36576" cy="475488"/>
+            <a:off x="548640" y="3803904"/>
+            <a:ext cx="36576" cy="420624"/>
           </a:xfrm>
           <a:prstGeom prst="rect">
             <a:avLst/>
@@ -24719,14 +24848,14 @@
       </p:sp>
       <p:sp>
         <p:nvSpPr>
-          <p:cNvPr id="50" name="TextBox 49"/>
+          <p:cNvPr id="53" name="TextBox 52"/>
           <p:cNvSpPr txBox="1"/>
           <p:nvPr/>
         </p:nvSpPr>
         <p:spPr>
           <a:xfrm>
-            <a:off x="685800" y="3675887"/>
-            <a:ext cx="7772400" cy="475488"/>
+            <a:off x="685800" y="3803904"/>
+            <a:ext cx="7772400" cy="420624"/>
           </a:xfrm>
           <a:prstGeom prst="rect">
             <a:avLst/>
@@ -24746,20 +24875,20 @@
                   <a:srgbClr val="171C1B"/>
                 </a:solidFill>
               </a:rPr>
-              <a:t>Zusammen rund 430 ärztliche Adipositas-Termine pro Monat – ein abgestimmter Pfad nützt beiden Kliniken.</a:t>
-            </a:r>
-          </a:p>
-        </p:txBody>
-      </p:sp>
-      <p:sp>
-        <p:nvSpPr>
-          <p:cNvPr id="51" name="TextBox 50"/>
+              <a:t>Zusammen rund 480 ärztliche Adipositas-Termine pro Monat – ein abgestimmter Pfad nützt beiden Kliniken.</a:t>
+            </a:r>
+          </a:p>
+        </p:txBody>
+      </p:sp>
+      <p:sp>
+        <p:nvSpPr>
+          <p:cNvPr id="54" name="TextBox 53"/>
           <p:cNvSpPr txBox="1"/>
           <p:nvPr/>
         </p:nvSpPr>
         <p:spPr>
           <a:xfrm>
-            <a:off x="548640" y="4297680"/>
+            <a:off x="548640" y="4315968"/>
             <a:ext cx="8046720" cy="365760"/>
           </a:xfrm>
           <a:prstGeom prst="rect">
@@ -24780,7 +24909,7 @@
                   <a:srgbClr val="677078"/>
                 </a:solidFill>
               </a:rPr>
-              <a:t>Viszerale Chirurgie: ärztliche Termine mit Besuchsgrund «Adipositas», Monatsdurchschnitt 1.4.–1.10.2026; Anteil postbariatrischer Termine nicht quantifiziert (schematisch). ZSG: gerundete Monatswerte; ärztlich = Erstkonsultationen und Jahreskontrollen.</a:t>
+              <a:t>Viszerale Chirurgie: ärztliche Termine mit Besuchsgrund «Adipositas», Monatsdurchschnitt 1.4.–1.10.2026. ZSG: gerundete Monatswerte; ärztlich = Erstkonsultationen und Jahreskontrollen, zusätzlich ≈ 50 postbariatrische Termine von Patient:innen aus der Viszeralchirurgie.</a:t>
             </a:r>
           </a:p>
         </p:txBody>

</xml_diff>

<commit_message>
Präsentation: Ernährungsberatung (≈ 280/Monat) beim UDEM, Wording UDEM
Folien 2 und 3 wieder mit UDEM statt ZSG. Die Ernährungsberatung zählt
zum UDEM und erscheint mit ≈ 280 Terminen pro Monat (Zuweisungen von
UDEM und Viszeralchirurgie); Gesamtkontakte auf ≈ 1'110 angepasst.

Co-Authored-By: Claude Opus 5.5 <noreply@anthropic.com>
Claude-Session: https://claude.ai/code/session_01Y3aMFwC6xTttGKHnTQtGy4
</commit_message>
<xml_diff>
--- a/praesentation/Zusammenarbeit_Adipositas_UDEM_UVCM_Entwurf.pptx
+++ b/praesentation/Zusammenarbeit_Adipositas_UDEM_UVCM_Entwurf.pptx
@@ -23537,7 +23537,7 @@
                   <a:srgbClr val="677078"/>
                 </a:solidFill>
               </a:rPr>
-              <a:t>Ärztliche Termine mit Adipositas pro Monat – ZSG und Viszerale Chirurgie</a:t>
+              <a:t>Ärztliche Termine mit Adipositas pro Monat – UDEM und Viszerale Chirurgie</a:t>
             </a:r>
           </a:p>
         </p:txBody>
@@ -23661,7 +23661,7 @@
                   <a:srgbClr val="171C1B"/>
                 </a:solidFill>
               </a:rPr>
-              <a:t>ZSG</a:t>
+              <a:t>UDEM</a:t>
             </a:r>
           </a:p>
         </p:txBody>
@@ -24266,7 +24266,7 @@
                   <a:srgbClr val="171C1B"/>
                 </a:solidFill>
               </a:rPr>
-              <a:t>≈ 50 postbariatrische Termine am ZSG</a:t>
+              <a:t>≈ 50 postbariatrische Termine am UDEM</a:t>
             </a:r>
             <a:r>
               <a:rPr sz="800" b="0" i="0">
@@ -24281,28 +24281,23 @@
       </p:sp>
       <p:sp>
         <p:nvSpPr>
-          <p:cNvPr id="39" name="Rounded Rectangle 38"/>
+          <p:cNvPr id="39" name="Rectangle 38"/>
           <p:cNvSpPr/>
           <p:nvPr/>
         </p:nvSpPr>
         <p:spPr>
           <a:xfrm>
-            <a:off x="548640" y="3438144"/>
-            <a:ext cx="5120640" cy="246888"/>
-          </a:xfrm>
-          <a:prstGeom prst="roundRect">
-            <a:avLst>
-              <a:gd name="adj" fmla="val 50000"/>
-            </a:avLst>
+            <a:off x="5989320" y="1645920"/>
+            <a:ext cx="2606040" cy="2103120"/>
+          </a:xfrm>
+          <a:prstGeom prst="rect">
+            <a:avLst/>
           </a:prstGeom>
           <a:solidFill>
-            <a:srgbClr val="FFFFFF"/>
+            <a:srgbClr val="F0F6F3"/>
           </a:solidFill>
-          <a:ln w="12700">
-            <a:solidFill>
-              <a:srgbClr val="009670"/>
-            </a:solidFill>
-            <a:prstDash val="dash"/>
+          <a:ln>
+            <a:noFill/>
           </a:ln>
           <a:effectLst/>
         </p:spPr>
@@ -24321,26 +24316,10 @@
           </a:fontRef>
         </p:style>
         <p:txBody>
-          <a:bodyPr rtlCol="0" anchor="ctr" wrap="square" lIns="146304" rIns="146304" tIns="18288" bIns="18288"/>
-          <a:lstStyle/>
-          <a:p>
-            <a:pPr algn="l"/>
-            <a:r>
-              <a:rPr sz="900" b="1">
-                <a:solidFill>
-                  <a:srgbClr val="171C1B"/>
-                </a:solidFill>
-              </a:rPr>
-              <a:t>Ernährungsberatung</a:t>
-            </a:r>
-            <a:r>
-              <a:rPr sz="900" b="0">
-                <a:solidFill>
-                  <a:srgbClr val="677078"/>
-                </a:solidFill>
-              </a:rPr>
-              <a:t>  ·  gemeinsam beansprucht von ZSG und Viszeraler Chirurgie</a:t>
-            </a:r>
+          <a:bodyPr rtlCol="0" anchor="ctr"/>
+          <a:lstStyle/>
+          <a:p>
+            <a:pPr algn="ctr"/>
           </a:p>
         </p:txBody>
       </p:sp>
@@ -24353,13 +24332,13 @@
         <p:spPr>
           <a:xfrm>
             <a:off x="5989320" y="1645920"/>
-            <a:ext cx="2606040" cy="2039112"/>
+            <a:ext cx="36576" cy="2103120"/>
           </a:xfrm>
           <a:prstGeom prst="rect">
             <a:avLst/>
           </a:prstGeom>
           <a:solidFill>
-            <a:srgbClr val="F0F6F3"/>
+            <a:srgbClr val="EE8F7A"/>
           </a:solidFill>
           <a:ln>
             <a:noFill/>
@@ -24390,51 +24369,7 @@
       </p:sp>
       <p:sp>
         <p:nvSpPr>
-          <p:cNvPr id="41" name="Rectangle 40"/>
-          <p:cNvSpPr/>
-          <p:nvPr/>
-        </p:nvSpPr>
-        <p:spPr>
-          <a:xfrm>
-            <a:off x="5989320" y="1645920"/>
-            <a:ext cx="36576" cy="2039112"/>
-          </a:xfrm>
-          <a:prstGeom prst="rect">
-            <a:avLst/>
-          </a:prstGeom>
-          <a:solidFill>
-            <a:srgbClr val="EE8F7A"/>
-          </a:solidFill>
-          <a:ln>
-            <a:noFill/>
-          </a:ln>
-          <a:effectLst/>
-        </p:spPr>
-        <p:style>
-          <a:lnRef idx="1">
-            <a:schemeClr val="accent1"/>
-          </a:lnRef>
-          <a:fillRef idx="3">
-            <a:schemeClr val="accent1"/>
-          </a:fillRef>
-          <a:effectRef idx="2">
-            <a:schemeClr val="accent1"/>
-          </a:effectRef>
-          <a:fontRef idx="minor">
-            <a:schemeClr val="lt1"/>
-          </a:fontRef>
-        </p:style>
-        <p:txBody>
-          <a:bodyPr rtlCol="0" anchor="ctr"/>
-          <a:lstStyle/>
-          <a:p>
-            <a:pPr algn="ctr"/>
-          </a:p>
-        </p:txBody>
-      </p:sp>
-      <p:sp>
-        <p:nvSpPr>
-          <p:cNvPr id="42" name="TextBox 41"/>
+          <p:cNvPr id="41" name="TextBox 40"/>
           <p:cNvSpPr txBox="1"/>
           <p:nvPr/>
         </p:nvSpPr>
@@ -24461,20 +24396,20 @@
                   <a:srgbClr val="009670"/>
                 </a:solidFill>
               </a:rPr>
-              <a:t>ZUSÄTZLICH AM ZSG</a:t>
-            </a:r>
-          </a:p>
-        </p:txBody>
-      </p:sp>
-      <p:sp>
-        <p:nvSpPr>
-          <p:cNvPr id="43" name="TextBox 42"/>
+              <a:t>ZUSÄTZLICH AM UDEM</a:t>
+            </a:r>
+          </a:p>
+        </p:txBody>
+      </p:sp>
+      <p:sp>
+        <p:nvSpPr>
+          <p:cNvPr id="42" name="TextBox 41"/>
           <p:cNvSpPr txBox="1"/>
           <p:nvPr/>
         </p:nvSpPr>
         <p:spPr>
           <a:xfrm>
-            <a:off x="6172200" y="2084832"/>
+            <a:off x="6172200" y="2029968"/>
             <a:ext cx="731520" cy="274320"/>
           </a:xfrm>
           <a:prstGeom prst="rect">
@@ -24502,13 +24437,13 @@
       </p:sp>
       <p:sp>
         <p:nvSpPr>
-          <p:cNvPr id="44" name="TextBox 43"/>
+          <p:cNvPr id="43" name="TextBox 42"/>
           <p:cNvSpPr txBox="1"/>
           <p:nvPr/>
         </p:nvSpPr>
         <p:spPr>
           <a:xfrm>
-            <a:off x="6903720" y="2093976"/>
+            <a:off x="6903720" y="2039112"/>
             <a:ext cx="1645920" cy="182880"/>
           </a:xfrm>
           <a:prstGeom prst="rect">
@@ -24536,13 +24471,13 @@
       </p:sp>
       <p:sp>
         <p:nvSpPr>
-          <p:cNvPr id="45" name="TextBox 44"/>
+          <p:cNvPr id="44" name="TextBox 43"/>
           <p:cNvSpPr txBox="1"/>
           <p:nvPr/>
         </p:nvSpPr>
         <p:spPr>
           <a:xfrm>
-            <a:off x="6903720" y="2267712"/>
+            <a:off x="6903720" y="2212848"/>
             <a:ext cx="1645920" cy="182880"/>
           </a:xfrm>
           <a:prstGeom prst="rect">
@@ -24570,13 +24505,13 @@
       </p:sp>
       <p:sp>
         <p:nvSpPr>
-          <p:cNvPr id="46" name="TextBox 45"/>
+          <p:cNvPr id="45" name="TextBox 44"/>
           <p:cNvSpPr txBox="1"/>
           <p:nvPr/>
         </p:nvSpPr>
         <p:spPr>
           <a:xfrm>
-            <a:off x="6172200" y="2587752"/>
+            <a:off x="6172200" y="2432304"/>
             <a:ext cx="731520" cy="274320"/>
           </a:xfrm>
           <a:prstGeom prst="rect">
@@ -24604,13 +24539,13 @@
       </p:sp>
       <p:sp>
         <p:nvSpPr>
-          <p:cNvPr id="47" name="TextBox 46"/>
+          <p:cNvPr id="46" name="TextBox 45"/>
           <p:cNvSpPr txBox="1"/>
           <p:nvPr/>
         </p:nvSpPr>
         <p:spPr>
           <a:xfrm>
-            <a:off x="6903720" y="2596896"/>
+            <a:off x="6903720" y="2441448"/>
             <a:ext cx="1645920" cy="182880"/>
           </a:xfrm>
           <a:prstGeom prst="rect">
@@ -24638,13 +24573,13 @@
       </p:sp>
       <p:sp>
         <p:nvSpPr>
-          <p:cNvPr id="48" name="TextBox 47"/>
+          <p:cNvPr id="47" name="TextBox 46"/>
           <p:cNvSpPr txBox="1"/>
           <p:nvPr/>
         </p:nvSpPr>
         <p:spPr>
           <a:xfrm>
-            <a:off x="6903720" y="2770632"/>
+            <a:off x="6903720" y="2615184"/>
             <a:ext cx="1645920" cy="182880"/>
           </a:xfrm>
           <a:prstGeom prst="rect">
@@ -24670,15 +24605,117 @@
           </a:p>
         </p:txBody>
       </p:sp>
+      <p:sp>
+        <p:nvSpPr>
+          <p:cNvPr id="48" name="TextBox 47"/>
+          <p:cNvSpPr txBox="1"/>
+          <p:nvPr/>
+        </p:nvSpPr>
+        <p:spPr>
+          <a:xfrm>
+            <a:off x="6172200" y="2834640"/>
+            <a:ext cx="731520" cy="274320"/>
+          </a:xfrm>
+          <a:prstGeom prst="rect">
+            <a:avLst/>
+          </a:prstGeom>
+          <a:noFill/>
+        </p:spPr>
+        <p:txBody>
+          <a:bodyPr wrap="square" lIns="0" rIns="0" tIns="0" bIns="0" anchor="t">
+            <a:spAutoFit/>
+          </a:bodyPr>
+          <a:lstStyle/>
+          <a:p>
+            <a:pPr algn="l"/>
+            <a:r>
+              <a:rPr sz="1500" b="1" i="0">
+                <a:solidFill>
+                  <a:srgbClr val="171C1B"/>
+                </a:solidFill>
+              </a:rPr>
+              <a:t>≈ 280</a:t>
+            </a:r>
+          </a:p>
+        </p:txBody>
+      </p:sp>
+      <p:sp>
+        <p:nvSpPr>
+          <p:cNvPr id="49" name="TextBox 48"/>
+          <p:cNvSpPr txBox="1"/>
+          <p:nvPr/>
+        </p:nvSpPr>
+        <p:spPr>
+          <a:xfrm>
+            <a:off x="6903720" y="2843784"/>
+            <a:ext cx="1645920" cy="182880"/>
+          </a:xfrm>
+          <a:prstGeom prst="rect">
+            <a:avLst/>
+          </a:prstGeom>
+          <a:noFill/>
+        </p:spPr>
+        <p:txBody>
+          <a:bodyPr wrap="square" lIns="0" rIns="0" tIns="0" bIns="0" anchor="t">
+            <a:spAutoFit/>
+          </a:bodyPr>
+          <a:lstStyle/>
+          <a:p>
+            <a:pPr algn="l"/>
+            <a:r>
+              <a:rPr sz="1000" b="1" i="0">
+                <a:solidFill>
+                  <a:srgbClr val="171C1B"/>
+                </a:solidFill>
+              </a:rPr>
+              <a:t>Ernährungsberatungen</a:t>
+            </a:r>
+          </a:p>
+        </p:txBody>
+      </p:sp>
+      <p:sp>
+        <p:nvSpPr>
+          <p:cNvPr id="50" name="TextBox 49"/>
+          <p:cNvSpPr txBox="1"/>
+          <p:nvPr/>
+        </p:nvSpPr>
+        <p:spPr>
+          <a:xfrm>
+            <a:off x="6903720" y="3017520"/>
+            <a:ext cx="1645920" cy="182880"/>
+          </a:xfrm>
+          <a:prstGeom prst="rect">
+            <a:avLst/>
+          </a:prstGeom>
+          <a:noFill/>
+        </p:spPr>
+        <p:txBody>
+          <a:bodyPr wrap="square" lIns="0" rIns="0" tIns="0" bIns="0" anchor="t">
+            <a:spAutoFit/>
+          </a:bodyPr>
+          <a:lstStyle/>
+          <a:p>
+            <a:pPr algn="l"/>
+            <a:r>
+              <a:rPr sz="850" b="0" i="0">
+                <a:solidFill>
+                  <a:srgbClr val="677078"/>
+                </a:solidFill>
+              </a:rPr>
+              <a:t>aus UDEM &amp; Viszeralchirurgie</a:t>
+            </a:r>
+          </a:p>
+        </p:txBody>
+      </p:sp>
       <p:cxnSp>
         <p:nvCxnSpPr>
-          <p:cNvPr id="49" name="Connector 48"/>
+          <p:cNvPr id="51" name="Connector 50"/>
           <p:cNvCxnSpPr/>
           <p:nvPr/>
         </p:nvCxnSpPr>
         <p:spPr>
           <a:xfrm>
-            <a:off x="6172200" y="3108960"/>
+            <a:off x="6172200" y="3282696"/>
             <a:ext cx="2240280" cy="0"/>
           </a:xfrm>
           <a:prstGeom prst="line">
@@ -24707,14 +24744,14 @@
       </p:cxnSp>
       <p:sp>
         <p:nvSpPr>
-          <p:cNvPr id="50" name="TextBox 49"/>
+          <p:cNvPr id="52" name="TextBox 51"/>
           <p:cNvSpPr txBox="1"/>
           <p:nvPr/>
         </p:nvSpPr>
         <p:spPr>
           <a:xfrm>
-            <a:off x="6172200" y="3200400"/>
-            <a:ext cx="2286000" cy="384048"/>
+            <a:off x="6172200" y="3346704"/>
+            <a:ext cx="2286000" cy="365760"/>
           </a:xfrm>
           <a:prstGeom prst="rect">
             <a:avLst/>
@@ -24734,7 +24771,7 @@
                   <a:srgbClr val="171C1B"/>
                 </a:solidFill>
               </a:rPr>
-              <a:t>≈ 830</a:t>
+              <a:t>≈ 1'110</a:t>
             </a:r>
             <a:r>
               <a:rPr sz="1000" b="0" i="0">
@@ -24760,14 +24797,14 @@
       </p:sp>
       <p:sp>
         <p:nvSpPr>
-          <p:cNvPr id="51" name="Rectangle 50"/>
+          <p:cNvPr id="53" name="Rectangle 52"/>
           <p:cNvSpPr/>
           <p:nvPr/>
         </p:nvSpPr>
         <p:spPr>
           <a:xfrm>
-            <a:off x="548640" y="3803904"/>
-            <a:ext cx="8046720" cy="420624"/>
+            <a:off x="548640" y="3858768"/>
+            <a:ext cx="8046720" cy="402336"/>
           </a:xfrm>
           <a:prstGeom prst="rect">
             <a:avLst/>
@@ -24804,14 +24841,14 @@
       </p:sp>
       <p:sp>
         <p:nvSpPr>
-          <p:cNvPr id="52" name="Rectangle 51"/>
+          <p:cNvPr id="54" name="Rectangle 53"/>
           <p:cNvSpPr/>
           <p:nvPr/>
         </p:nvSpPr>
         <p:spPr>
           <a:xfrm>
-            <a:off x="548640" y="3803904"/>
-            <a:ext cx="36576" cy="420624"/>
+            <a:off x="548640" y="3858768"/>
+            <a:ext cx="36576" cy="402336"/>
           </a:xfrm>
           <a:prstGeom prst="rect">
             <a:avLst/>
@@ -24848,14 +24885,14 @@
       </p:sp>
       <p:sp>
         <p:nvSpPr>
-          <p:cNvPr id="53" name="TextBox 52"/>
+          <p:cNvPr id="55" name="TextBox 54"/>
           <p:cNvSpPr txBox="1"/>
           <p:nvPr/>
         </p:nvSpPr>
         <p:spPr>
           <a:xfrm>
-            <a:off x="685800" y="3803904"/>
-            <a:ext cx="7772400" cy="420624"/>
+            <a:off x="685800" y="3858768"/>
+            <a:ext cx="7772400" cy="402336"/>
           </a:xfrm>
           <a:prstGeom prst="rect">
             <a:avLst/>
@@ -24882,13 +24919,13 @@
       </p:sp>
       <p:sp>
         <p:nvSpPr>
-          <p:cNvPr id="54" name="TextBox 53"/>
+          <p:cNvPr id="56" name="TextBox 55"/>
           <p:cNvSpPr txBox="1"/>
           <p:nvPr/>
         </p:nvSpPr>
         <p:spPr>
           <a:xfrm>
-            <a:off x="548640" y="4315968"/>
+            <a:off x="548640" y="4334256"/>
             <a:ext cx="8046720" cy="365760"/>
           </a:xfrm>
           <a:prstGeom prst="rect">
@@ -24909,7 +24946,7 @@
                   <a:srgbClr val="677078"/>
                 </a:solidFill>
               </a:rPr>
-              <a:t>Viszerale Chirurgie: ärztliche Termine mit Besuchsgrund «Adipositas», Monatsdurchschnitt 1.4.–1.10.2026. ZSG: gerundete Monatswerte; ärztlich = Erstkonsultationen und Jahreskontrollen, zusätzlich ≈ 50 postbariatrische Termine von Patient:innen aus der Viszeralchirurgie.</a:t>
+              <a:t>Viszerale Chirurgie: ärztliche Termine mit Besuchsgrund «Adipositas», Monatsdurchschnitt 1.4.–1.10.2026. UDEM: gerundete Monatswerte; ärztlich = Erstkonsultationen und Jahreskontrollen, zusätzlich postbariatrische Termine. Ernährungsberatung zählt zum UDEM.</a:t>
             </a:r>
           </a:p>
         </p:txBody>
@@ -36095,7 +36132,7 @@
                   <a:srgbClr val="171C1B"/>
                 </a:solidFill>
               </a:rPr>
-              <a:t>Adipositas-Sprechstunde am ZSG</a:t>
+              <a:t>Adipositas-Sprechstunde am UDEM</a:t>
             </a:r>
           </a:p>
         </p:txBody>

</xml_diff>

<commit_message>
Präsentation: Eckdaten der Swiss Obesity Study ergänzt
Platzhalter auf der Folie Qualität und Forschung durch die Angaben zur
SOS ersetzt: ≈ 2'500 Teilnehmende seit 2025, 10 Jahre Follow-up,
Real-World-Daten, Ziel und erhobene Daten.

Co-Authored-By: Claude Opus 5.5 <noreply@anthropic.com>
Claude-Session: https://claude.ai/code/session_01Y3aMFwC6xTttGKHnTQtGy4
</commit_message>
<xml_diff>
--- a/praesentation/Zusammenarbeit_Adipositas_UDEM_UVCM_Entwurf.pptx
+++ b/praesentation/Zusammenarbeit_Adipositas_UDEM_UVCM_Entwurf.pptx
@@ -25402,7 +25402,7 @@
         <p:spPr>
           <a:xfrm>
             <a:off x="548640" y="2898648"/>
-            <a:ext cx="3840480" cy="713232"/>
+            <a:ext cx="3840480" cy="804672"/>
           </a:xfrm>
           <a:prstGeom prst="rect">
             <a:avLst/>
@@ -25445,8 +25445,8 @@
         </p:nvSpPr>
         <p:spPr>
           <a:xfrm>
-            <a:off x="713232" y="3008376"/>
-            <a:ext cx="3566160" cy="502920"/>
+            <a:off x="713232" y="2898648"/>
+            <a:ext cx="3566160" cy="804672"/>
           </a:xfrm>
           <a:prstGeom prst="rect">
             <a:avLst/>
@@ -25454,7 +25454,7 @@
           <a:noFill/>
         </p:spPr>
         <p:txBody>
-          <a:bodyPr wrap="square" lIns="0" rIns="0" tIns="0" bIns="0" anchor="t">
+          <a:bodyPr wrap="square" lIns="0" rIns="0" tIns="0" bIns="0" anchor="ctr">
             <a:spAutoFit/>
           </a:bodyPr>
           <a:lstStyle/>
@@ -25529,7 +25529,7 @@
         <p:spPr>
           <a:xfrm>
             <a:off x="4754880" y="1874519"/>
-            <a:ext cx="3840480" cy="1737360"/>
+            <a:ext cx="3840480" cy="1828800"/>
           </a:xfrm>
           <a:prstGeom prst="rect">
             <a:avLst/>
@@ -25574,7 +25574,7 @@
         </p:nvSpPr>
         <p:spPr>
           <a:xfrm>
-            <a:off x="4919472" y="1984248"/>
+            <a:off x="4919472" y="1965960"/>
             <a:ext cx="2377440" cy="228600"/>
           </a:xfrm>
           <a:prstGeom prst="rect">
@@ -25608,7 +25608,7 @@
         </p:nvSpPr>
         <p:spPr>
           <a:xfrm>
-            <a:off x="7434072" y="1965960"/>
+            <a:off x="7434072" y="1956816"/>
             <a:ext cx="1005840" cy="219456"/>
           </a:xfrm>
           <a:prstGeom prst="roundRect">
@@ -25662,8 +25662,8 @@
         </p:nvSpPr>
         <p:spPr>
           <a:xfrm>
-            <a:off x="4919472" y="2359151"/>
-            <a:ext cx="2103120" cy="164592"/>
+            <a:off x="4919472" y="2203704"/>
+            <a:ext cx="3566160" cy="164592"/>
           </a:xfrm>
           <a:prstGeom prst="rect">
             <a:avLst/>
@@ -25678,26 +25678,239 @@
           <a:p>
             <a:pPr algn="l"/>
             <a:r>
-              <a:rPr sz="950" b="0" i="0">
+              <a:rPr sz="850" b="0" i="0">
+                <a:solidFill>
+                  <a:srgbClr val="677078"/>
+                </a:solidFill>
+              </a:rPr>
+              <a:t>Longitudinale Real-World-Daten zur Adipositasversorgung in der Schweiz</a:t>
+            </a:r>
+          </a:p>
+        </p:txBody>
+      </p:sp>
+      <p:sp>
+        <p:nvSpPr>
+          <p:cNvPr id="33" name="TextBox 32"/>
+          <p:cNvSpPr txBox="1"/>
+          <p:nvPr/>
+        </p:nvSpPr>
+        <p:spPr>
+          <a:xfrm>
+            <a:off x="4919472" y="2450592"/>
+            <a:ext cx="1737360" cy="274320"/>
+          </a:xfrm>
+          <a:prstGeom prst="rect">
+            <a:avLst/>
+          </a:prstGeom>
+          <a:noFill/>
+        </p:spPr>
+        <p:txBody>
+          <a:bodyPr wrap="square" lIns="0" rIns="0" tIns="0" bIns="0" anchor="t">
+            <a:spAutoFit/>
+          </a:bodyPr>
+          <a:lstStyle/>
+          <a:p>
+            <a:pPr algn="l"/>
+            <a:r>
+              <a:rPr sz="1600" b="1" i="0">
                 <a:solidFill>
                   <a:srgbClr val="171C1B"/>
                 </a:solidFill>
               </a:rPr>
-              <a:t>Ziel</a:t>
-            </a:r>
-          </a:p>
-        </p:txBody>
-      </p:sp>
-      <p:sp>
-        <p:nvSpPr>
-          <p:cNvPr id="33" name="Rounded Rectangle 32"/>
+              <a:t>≈ 2'500</a:t>
+            </a:r>
+          </a:p>
+        </p:txBody>
+      </p:sp>
+      <p:sp>
+        <p:nvSpPr>
+          <p:cNvPr id="34" name="TextBox 33"/>
+          <p:cNvSpPr txBox="1"/>
+          <p:nvPr/>
+        </p:nvSpPr>
+        <p:spPr>
+          <a:xfrm>
+            <a:off x="4919472" y="2724912"/>
+            <a:ext cx="1737360" cy="164592"/>
+          </a:xfrm>
+          <a:prstGeom prst="rect">
+            <a:avLst/>
+          </a:prstGeom>
+          <a:noFill/>
+        </p:spPr>
+        <p:txBody>
+          <a:bodyPr wrap="square" lIns="0" rIns="0" tIns="0" bIns="0" anchor="t">
+            <a:spAutoFit/>
+          </a:bodyPr>
+          <a:lstStyle/>
+          <a:p>
+            <a:pPr algn="l"/>
+            <a:r>
+              <a:rPr sz="850" b="0" i="0">
+                <a:solidFill>
+                  <a:srgbClr val="677078"/>
+                </a:solidFill>
+              </a:rPr>
+              <a:t>Teilnehmende seit 2025</a:t>
+            </a:r>
+          </a:p>
+        </p:txBody>
+      </p:sp>
+      <p:sp>
+        <p:nvSpPr>
+          <p:cNvPr id="35" name="TextBox 34"/>
+          <p:cNvSpPr txBox="1"/>
+          <p:nvPr/>
+        </p:nvSpPr>
+        <p:spPr>
+          <a:xfrm>
+            <a:off x="6675120" y="2450592"/>
+            <a:ext cx="1737360" cy="274320"/>
+          </a:xfrm>
+          <a:prstGeom prst="rect">
+            <a:avLst/>
+          </a:prstGeom>
+          <a:noFill/>
+        </p:spPr>
+        <p:txBody>
+          <a:bodyPr wrap="square" lIns="0" rIns="0" tIns="0" bIns="0" anchor="t">
+            <a:spAutoFit/>
+          </a:bodyPr>
+          <a:lstStyle/>
+          <a:p>
+            <a:pPr algn="l"/>
+            <a:r>
+              <a:rPr sz="1600" b="1" i="0">
+                <a:solidFill>
+                  <a:srgbClr val="171C1B"/>
+                </a:solidFill>
+              </a:rPr>
+              <a:t>10 Jahre</a:t>
+            </a:r>
+          </a:p>
+        </p:txBody>
+      </p:sp>
+      <p:sp>
+        <p:nvSpPr>
+          <p:cNvPr id="36" name="TextBox 35"/>
+          <p:cNvSpPr txBox="1"/>
+          <p:nvPr/>
+        </p:nvSpPr>
+        <p:spPr>
+          <a:xfrm>
+            <a:off x="6675120" y="2724912"/>
+            <a:ext cx="1737360" cy="164592"/>
+          </a:xfrm>
+          <a:prstGeom prst="rect">
+            <a:avLst/>
+          </a:prstGeom>
+          <a:noFill/>
+        </p:spPr>
+        <p:txBody>
+          <a:bodyPr wrap="square" lIns="0" rIns="0" tIns="0" bIns="0" anchor="t">
+            <a:spAutoFit/>
+          </a:bodyPr>
+          <a:lstStyle/>
+          <a:p>
+            <a:pPr algn="l"/>
+            <a:r>
+              <a:rPr sz="850" b="0" i="0">
+                <a:solidFill>
+                  <a:srgbClr val="677078"/>
+                </a:solidFill>
+              </a:rPr>
+              <a:t>Follow-up</a:t>
+            </a:r>
+          </a:p>
+        </p:txBody>
+      </p:sp>
+      <p:cxnSp>
+        <p:nvCxnSpPr>
+          <p:cNvPr id="37" name="Connector 36"/>
+          <p:cNvCxnSpPr/>
+          <p:nvPr/>
+        </p:nvCxnSpPr>
+        <p:spPr>
+          <a:xfrm>
+            <a:off x="6537960" y="2487168"/>
+            <a:ext cx="0" cy="384048"/>
+          </a:xfrm>
+          <a:prstGeom prst="line">
+            <a:avLst/>
+          </a:prstGeom>
+          <a:ln w="12700">
+            <a:solidFill>
+              <a:srgbClr val="CFD8D5"/>
+            </a:solidFill>
+          </a:ln>
+        </p:spPr>
+        <p:style>
+          <a:lnRef idx="2">
+            <a:schemeClr val="accent1"/>
+          </a:lnRef>
+          <a:fillRef idx="0">
+            <a:schemeClr val="accent1"/>
+          </a:fillRef>
+          <a:effectRef idx="1">
+            <a:schemeClr val="accent1"/>
+          </a:effectRef>
+          <a:fontRef idx="minor">
+            <a:schemeClr val="tx1"/>
+          </a:fontRef>
+        </p:style>
+      </p:cxnSp>
+      <p:sp>
+        <p:nvSpPr>
+          <p:cNvPr id="38" name="TextBox 37"/>
+          <p:cNvSpPr txBox="1"/>
+          <p:nvPr/>
+        </p:nvSpPr>
+        <p:spPr>
+          <a:xfrm>
+            <a:off x="4919472" y="2990088"/>
+            <a:ext cx="3566160" cy="329184"/>
+          </a:xfrm>
+          <a:prstGeom prst="rect">
+            <a:avLst/>
+          </a:prstGeom>
+          <a:noFill/>
+        </p:spPr>
+        <p:txBody>
+          <a:bodyPr wrap="square" lIns="0" rIns="0" tIns="0" bIns="0" anchor="t">
+            <a:spAutoFit/>
+          </a:bodyPr>
+          <a:lstStyle/>
+          <a:p>
+            <a:pPr algn="l"/>
+            <a:r>
+              <a:rPr sz="900" b="1" i="0">
+                <a:solidFill>
+                  <a:srgbClr val="171C1B"/>
+                </a:solidFill>
+              </a:rPr>
+              <a:t>Ziel: </a:t>
+            </a:r>
+            <a:r>
+              <a:rPr sz="900" b="0" i="0">
+                <a:solidFill>
+                  <a:srgbClr val="171C1B"/>
+                </a:solidFill>
+              </a:rPr>
+              <a:t>Auswirkungen der sich wandelnden Adipositastherapie auf Gesundheitsoutcomes und Lebensstil evaluieren</a:t>
+            </a:r>
+          </a:p>
+        </p:txBody>
+      </p:sp>
+      <p:sp>
+        <p:nvSpPr>
+          <p:cNvPr id="39" name="Rounded Rectangle 38"/>
           <p:cNvSpPr/>
           <p:nvPr/>
         </p:nvSpPr>
         <p:spPr>
           <a:xfrm>
-            <a:off x="7159752" y="2331720"/>
-            <a:ext cx="1280160" cy="192024"/>
+            <a:off x="4919472" y="3401568"/>
+            <a:ext cx="1051560" cy="201168"/>
           </a:xfrm>
           <a:prstGeom prst="roundRect">
             <a:avLst>
@@ -25705,13 +25918,10 @@
             </a:avLst>
           </a:prstGeom>
           <a:solidFill>
-            <a:srgbClr val="FFFFFF"/>
+            <a:srgbClr val="F0F6F3"/>
           </a:solidFill>
-          <a:ln w="12700">
-            <a:solidFill>
-              <a:srgbClr val="EE8F7A"/>
-            </a:solidFill>
-            <a:prstDash val="dash"/>
+          <a:ln>
+            <a:noFill/>
           </a:ln>
           <a:effectLst/>
         </p:spPr>
@@ -25730,65 +25940,31 @@
           </a:fontRef>
         </p:style>
         <p:txBody>
-          <a:bodyPr rtlCol="0" anchor="ctr" wrap="square" lIns="128016" rIns="128016" tIns="18288" bIns="18288"/>
+          <a:bodyPr rtlCol="0" anchor="ctr" wrap="square" lIns="27432" rIns="27432" tIns="18288" bIns="18288"/>
           <a:lstStyle/>
           <a:p>
             <a:pPr algn="ctr"/>
             <a:r>
-              <a:rPr sz="850" b="0">
-                <a:solidFill>
-                  <a:srgbClr val="EE8F7A"/>
-                </a:solidFill>
-              </a:rPr>
-              <a:t>Platzhalter</a:t>
-            </a:r>
-          </a:p>
-        </p:txBody>
-      </p:sp>
-      <p:sp>
-        <p:nvSpPr>
-          <p:cNvPr id="34" name="TextBox 33"/>
-          <p:cNvSpPr txBox="1"/>
-          <p:nvPr/>
-        </p:nvSpPr>
-        <p:spPr>
-          <a:xfrm>
-            <a:off x="4919472" y="2606039"/>
-            <a:ext cx="2103120" cy="164592"/>
-          </a:xfrm>
-          <a:prstGeom prst="rect">
-            <a:avLst/>
-          </a:prstGeom>
-          <a:noFill/>
-        </p:spPr>
-        <p:txBody>
-          <a:bodyPr wrap="square" lIns="0" rIns="0" tIns="0" bIns="0" anchor="t">
-            <a:spAutoFit/>
-          </a:bodyPr>
-          <a:lstStyle/>
-          <a:p>
-            <a:pPr algn="l"/>
-            <a:r>
-              <a:rPr sz="950" b="0" i="0">
+              <a:rPr sz="800" b="0">
                 <a:solidFill>
                   <a:srgbClr val="171C1B"/>
                 </a:solidFill>
               </a:rPr>
-              <a:t>Design</a:t>
-            </a:r>
-          </a:p>
-        </p:txBody>
-      </p:sp>
-      <p:sp>
-        <p:nvSpPr>
-          <p:cNvPr id="35" name="Rounded Rectangle 34"/>
+              <a:t>Krankengeschichte</a:t>
+            </a:r>
+          </a:p>
+        </p:txBody>
+      </p:sp>
+      <p:sp>
+        <p:nvSpPr>
+          <p:cNvPr id="40" name="Rounded Rectangle 39"/>
           <p:cNvSpPr/>
           <p:nvPr/>
         </p:nvSpPr>
         <p:spPr>
           <a:xfrm>
-            <a:off x="7159752" y="2578608"/>
-            <a:ext cx="1280160" cy="192024"/>
+            <a:off x="6044183" y="3401568"/>
+            <a:ext cx="548640" cy="201168"/>
           </a:xfrm>
           <a:prstGeom prst="roundRect">
             <a:avLst>
@@ -25796,13 +25972,10 @@
             </a:avLst>
           </a:prstGeom>
           <a:solidFill>
-            <a:srgbClr val="FFFFFF"/>
+            <a:srgbClr val="F0F6F3"/>
           </a:solidFill>
-          <a:ln w="12700">
-            <a:solidFill>
-              <a:srgbClr val="EE8F7A"/>
-            </a:solidFill>
-            <a:prstDash val="dash"/>
+          <a:ln>
+            <a:noFill/>
           </a:ln>
           <a:effectLst/>
         </p:spPr>
@@ -25821,65 +25994,31 @@
           </a:fontRef>
         </p:style>
         <p:txBody>
-          <a:bodyPr rtlCol="0" anchor="ctr" wrap="square" lIns="128016" rIns="128016" tIns="18288" bIns="18288"/>
+          <a:bodyPr rtlCol="0" anchor="ctr" wrap="square" lIns="27432" rIns="27432" tIns="18288" bIns="18288"/>
           <a:lstStyle/>
           <a:p>
             <a:pPr algn="ctr"/>
             <a:r>
-              <a:rPr sz="850" b="0">
-                <a:solidFill>
-                  <a:srgbClr val="EE8F7A"/>
-                </a:solidFill>
-              </a:rPr>
-              <a:t>Platzhalter</a:t>
-            </a:r>
-          </a:p>
-        </p:txBody>
-      </p:sp>
-      <p:sp>
-        <p:nvSpPr>
-          <p:cNvPr id="36" name="TextBox 35"/>
-          <p:cNvSpPr txBox="1"/>
-          <p:nvPr/>
-        </p:nvSpPr>
-        <p:spPr>
-          <a:xfrm>
-            <a:off x="4919472" y="2852927"/>
-            <a:ext cx="2103120" cy="164592"/>
-          </a:xfrm>
-          <a:prstGeom prst="rect">
-            <a:avLst/>
-          </a:prstGeom>
-          <a:noFill/>
-        </p:spPr>
-        <p:txBody>
-          <a:bodyPr wrap="square" lIns="0" rIns="0" tIns="0" bIns="0" anchor="t">
-            <a:spAutoFit/>
-          </a:bodyPr>
-          <a:lstStyle/>
-          <a:p>
-            <a:pPr algn="l"/>
-            <a:r>
-              <a:rPr sz="950" b="0" i="0">
+              <a:rPr sz="800" b="0">
                 <a:solidFill>
                   <a:srgbClr val="171C1B"/>
                 </a:solidFill>
               </a:rPr>
-              <a:t>Beteiligte Zentren</a:t>
-            </a:r>
-          </a:p>
-        </p:txBody>
-      </p:sp>
-      <p:sp>
-        <p:nvSpPr>
-          <p:cNvPr id="37" name="Rounded Rectangle 36"/>
+              <a:t>PROMs</a:t>
+            </a:r>
+          </a:p>
+        </p:txBody>
+      </p:sp>
+      <p:sp>
+        <p:nvSpPr>
+          <p:cNvPr id="41" name="Rounded Rectangle 40"/>
           <p:cNvSpPr/>
           <p:nvPr/>
         </p:nvSpPr>
         <p:spPr>
           <a:xfrm>
-            <a:off x="7159752" y="2825496"/>
-            <a:ext cx="1280160" cy="192024"/>
+            <a:off x="6665975" y="3401568"/>
+            <a:ext cx="713232" cy="201168"/>
           </a:xfrm>
           <a:prstGeom prst="roundRect">
             <a:avLst>
@@ -25887,13 +26026,10 @@
             </a:avLst>
           </a:prstGeom>
           <a:solidFill>
-            <a:srgbClr val="FFFFFF"/>
+            <a:srgbClr val="F0F6F3"/>
           </a:solidFill>
-          <a:ln w="12700">
-            <a:solidFill>
-              <a:srgbClr val="EE8F7A"/>
-            </a:solidFill>
-            <a:prstDash val="dash"/>
+          <a:ln>
+            <a:noFill/>
           </a:ln>
           <a:effectLst/>
         </p:spPr>
@@ -25912,65 +26048,31 @@
           </a:fontRef>
         </p:style>
         <p:txBody>
-          <a:bodyPr rtlCol="0" anchor="ctr" wrap="square" lIns="128016" rIns="128016" tIns="18288" bIns="18288"/>
+          <a:bodyPr rtlCol="0" anchor="ctr" wrap="square" lIns="27432" rIns="27432" tIns="18288" bIns="18288"/>
           <a:lstStyle/>
           <a:p>
             <a:pPr algn="ctr"/>
             <a:r>
-              <a:rPr sz="850" b="0">
-                <a:solidFill>
-                  <a:srgbClr val="EE8F7A"/>
-                </a:solidFill>
-              </a:rPr>
-              <a:t>Platzhalter</a:t>
-            </a:r>
-          </a:p>
-        </p:txBody>
-      </p:sp>
-      <p:sp>
-        <p:nvSpPr>
-          <p:cNvPr id="38" name="TextBox 37"/>
-          <p:cNvSpPr txBox="1"/>
-          <p:nvPr/>
-        </p:nvSpPr>
-        <p:spPr>
-          <a:xfrm>
-            <a:off x="4919472" y="3099815"/>
-            <a:ext cx="2103120" cy="164592"/>
-          </a:xfrm>
-          <a:prstGeom prst="rect">
-            <a:avLst/>
-          </a:prstGeom>
-          <a:noFill/>
-        </p:spPr>
-        <p:txBody>
-          <a:bodyPr wrap="square" lIns="0" rIns="0" tIns="0" bIns="0" anchor="t">
-            <a:spAutoFit/>
-          </a:bodyPr>
-          <a:lstStyle/>
-          <a:p>
-            <a:pPr algn="l"/>
-            <a:r>
-              <a:rPr sz="950" b="0" i="0">
+              <a:rPr sz="800" b="0">
                 <a:solidFill>
                   <a:srgbClr val="171C1B"/>
                 </a:solidFill>
               </a:rPr>
-              <a:t>Eingeschlossene Patient:innen</a:t>
-            </a:r>
-          </a:p>
-        </p:txBody>
-      </p:sp>
-      <p:sp>
-        <p:nvSpPr>
-          <p:cNvPr id="39" name="Rounded Rectangle 38"/>
+              <a:t>Biomarker</a:t>
+            </a:r>
+          </a:p>
+        </p:txBody>
+      </p:sp>
+      <p:sp>
+        <p:nvSpPr>
+          <p:cNvPr id="42" name="Rounded Rectangle 41"/>
           <p:cNvSpPr/>
           <p:nvPr/>
         </p:nvSpPr>
         <p:spPr>
           <a:xfrm>
-            <a:off x="7159752" y="3072384"/>
-            <a:ext cx="1280160" cy="192024"/>
+            <a:off x="7452359" y="3401568"/>
+            <a:ext cx="960120" cy="201168"/>
           </a:xfrm>
           <a:prstGeom prst="roundRect">
             <a:avLst>
@@ -25978,13 +26080,10 @@
             </a:avLst>
           </a:prstGeom>
           <a:solidFill>
-            <a:srgbClr val="FFFFFF"/>
+            <a:srgbClr val="F0F6F3"/>
           </a:solidFill>
-          <a:ln w="12700">
-            <a:solidFill>
-              <a:srgbClr val="EE8F7A"/>
-            </a:solidFill>
-            <a:prstDash val="dash"/>
+          <a:ln>
+            <a:noFill/>
           </a:ln>
           <a:effectLst/>
         </p:spPr>
@@ -26003,79 +26102,40 @@
           </a:fontRef>
         </p:style>
         <p:txBody>
-          <a:bodyPr rtlCol="0" anchor="ctr" wrap="square" lIns="128016" rIns="128016" tIns="18288" bIns="18288"/>
+          <a:bodyPr rtlCol="0" anchor="ctr" wrap="square" lIns="27432" rIns="27432" tIns="18288" bIns="18288"/>
           <a:lstStyle/>
           <a:p>
             <a:pPr algn="ctr"/>
             <a:r>
-              <a:rPr sz="850" b="0">
-                <a:solidFill>
-                  <a:srgbClr val="EE8F7A"/>
-                </a:solidFill>
-              </a:rPr>
-              <a:t>Platzhalter</a:t>
-            </a:r>
-          </a:p>
-        </p:txBody>
-      </p:sp>
-      <p:sp>
-        <p:nvSpPr>
-          <p:cNvPr id="40" name="TextBox 39"/>
-          <p:cNvSpPr txBox="1"/>
-          <p:nvPr/>
-        </p:nvSpPr>
-        <p:spPr>
-          <a:xfrm>
-            <a:off x="4919472" y="3346703"/>
-            <a:ext cx="2103120" cy="164592"/>
-          </a:xfrm>
-          <a:prstGeom prst="rect">
-            <a:avLst/>
-          </a:prstGeom>
-          <a:noFill/>
-        </p:spPr>
-        <p:txBody>
-          <a:bodyPr wrap="square" lIns="0" rIns="0" tIns="0" bIns="0" anchor="t">
-            <a:spAutoFit/>
-          </a:bodyPr>
-          <a:lstStyle/>
-          <a:p>
-            <a:pPr algn="l"/>
-            <a:r>
-              <a:rPr sz="950" b="0" i="0">
+              <a:rPr sz="800" b="0">
                 <a:solidFill>
                   <a:srgbClr val="171C1B"/>
                 </a:solidFill>
               </a:rPr>
-              <a:t>Start / Laufzeit</a:t>
-            </a:r>
-          </a:p>
-        </p:txBody>
-      </p:sp>
-      <p:sp>
-        <p:nvSpPr>
-          <p:cNvPr id="41" name="Rounded Rectangle 40"/>
+              <a:t>Soziodemografie</a:t>
+            </a:r>
+          </a:p>
+        </p:txBody>
+      </p:sp>
+      <p:sp>
+        <p:nvSpPr>
+          <p:cNvPr id="43" name="Rectangle 42"/>
           <p:cNvSpPr/>
           <p:nvPr/>
         </p:nvSpPr>
         <p:spPr>
           <a:xfrm>
-            <a:off x="7159752" y="3319272"/>
-            <a:ext cx="1280160" cy="192024"/>
-          </a:xfrm>
-          <a:prstGeom prst="roundRect">
-            <a:avLst>
-              <a:gd name="adj" fmla="val 50000"/>
-            </a:avLst>
+            <a:off x="548640" y="3858768"/>
+            <a:ext cx="8046720" cy="402336"/>
+          </a:xfrm>
+          <a:prstGeom prst="rect">
+            <a:avLst/>
           </a:prstGeom>
           <a:solidFill>
-            <a:srgbClr val="FFFFFF"/>
+            <a:srgbClr val="F0F6F3"/>
           </a:solidFill>
-          <a:ln w="12700">
-            <a:solidFill>
-              <a:srgbClr val="EE8F7A"/>
-            </a:solidFill>
-            <a:prstDash val="dash"/>
+          <a:ln>
+            <a:noFill/>
           </a:ln>
           <a:effectLst/>
         </p:spPr>
@@ -26094,37 +26154,29 @@
           </a:fontRef>
         </p:style>
         <p:txBody>
-          <a:bodyPr rtlCol="0" anchor="ctr" wrap="square" lIns="128016" rIns="128016" tIns="18288" bIns="18288"/>
+          <a:bodyPr rtlCol="0" anchor="ctr"/>
           <a:lstStyle/>
           <a:p>
             <a:pPr algn="ctr"/>
-            <a:r>
-              <a:rPr sz="850" b="0">
-                <a:solidFill>
-                  <a:srgbClr val="EE8F7A"/>
-                </a:solidFill>
-              </a:rPr>
-              <a:t>Platzhalter</a:t>
-            </a:r>
-          </a:p>
-        </p:txBody>
-      </p:sp>
-      <p:sp>
-        <p:nvSpPr>
-          <p:cNvPr id="42" name="Rectangle 41"/>
+          </a:p>
+        </p:txBody>
+      </p:sp>
+      <p:sp>
+        <p:nvSpPr>
+          <p:cNvPr id="44" name="Rectangle 43"/>
           <p:cNvSpPr/>
           <p:nvPr/>
         </p:nvSpPr>
         <p:spPr>
           <a:xfrm>
-            <a:off x="548640" y="3794760"/>
-            <a:ext cx="8046720" cy="457200"/>
+            <a:off x="548640" y="3858768"/>
+            <a:ext cx="36576" cy="402336"/>
           </a:xfrm>
           <a:prstGeom prst="rect">
             <a:avLst/>
           </a:prstGeom>
           <a:solidFill>
-            <a:srgbClr val="F0F6F3"/>
+            <a:srgbClr val="009670"/>
           </a:solidFill>
           <a:ln>
             <a:noFill/>
@@ -26155,58 +26207,14 @@
       </p:sp>
       <p:sp>
         <p:nvSpPr>
-          <p:cNvPr id="43" name="Rectangle 42"/>
-          <p:cNvSpPr/>
-          <p:nvPr/>
-        </p:nvSpPr>
-        <p:spPr>
-          <a:xfrm>
-            <a:off x="548640" y="3794760"/>
-            <a:ext cx="36576" cy="457200"/>
-          </a:xfrm>
-          <a:prstGeom prst="rect">
-            <a:avLst/>
-          </a:prstGeom>
-          <a:solidFill>
-            <a:srgbClr val="009670"/>
-          </a:solidFill>
-          <a:ln>
-            <a:noFill/>
-          </a:ln>
-          <a:effectLst/>
-        </p:spPr>
-        <p:style>
-          <a:lnRef idx="1">
-            <a:schemeClr val="accent1"/>
-          </a:lnRef>
-          <a:fillRef idx="3">
-            <a:schemeClr val="accent1"/>
-          </a:fillRef>
-          <a:effectRef idx="2">
-            <a:schemeClr val="accent1"/>
-          </a:effectRef>
-          <a:fontRef idx="minor">
-            <a:schemeClr val="lt1"/>
-          </a:fontRef>
-        </p:style>
-        <p:txBody>
-          <a:bodyPr rtlCol="0" anchor="ctr"/>
-          <a:lstStyle/>
-          <a:p>
-            <a:pPr algn="ctr"/>
-          </a:p>
-        </p:txBody>
-      </p:sp>
-      <p:sp>
-        <p:nvSpPr>
-          <p:cNvPr id="44" name="TextBox 43"/>
+          <p:cNvPr id="45" name="TextBox 44"/>
           <p:cNvSpPr txBox="1"/>
           <p:nvPr/>
         </p:nvSpPr>
         <p:spPr>
           <a:xfrm>
-            <a:off x="685800" y="3794760"/>
-            <a:ext cx="7772400" cy="457200"/>
+            <a:off x="685800" y="3858768"/>
+            <a:ext cx="7772400" cy="402336"/>
           </a:xfrm>
           <a:prstGeom prst="rect">
             <a:avLst/>

</xml_diff>

<commit_message>
Präsentation: Zielbild mit Qualität und Forschung auf einer Folie
Zielbild und «Qualität und Forschung am ZSG» zusammengeführt: vier
Therapiesäulen unter einem gemeinsamen Dach, darunter Qualität
(bariatrisches Referenzzentrum der UVCM, anerkannt durch die SMOB, mit
Logo; EASO COMs und Swiss Medical Obesity Center des ZSG) und Forschung
(Swiss Obesity Study, Lead UDEM). Präsentation neu mit 10 Folien.

Co-Authored-By: Claude Opus 5.5 <noreply@anthropic.com>
Claude-Session: https://claude.ai/code/session_01Y3aMFwC6xTttGKHnTQtGy4
</commit_message>
<xml_diff>
--- a/praesentation/Zusammenarbeit_Adipositas_UDEM_UVCM_Entwurf.pptx
+++ b/praesentation/Zusammenarbeit_Adipositas_UDEM_UVCM_Entwurf.pptx
@@ -16,10 +16,9 @@
     <p:sldId id="397" r:id="rId10"/>
     <p:sldId id="481" r:id="rId23"/>
     <p:sldId id="482" r:id="rId24"/>
-    <p:sldId id="483" r:id="rId25"/>
     <p:sldId id="476" r:id="rId11"/>
     <p:sldId id="479" r:id="rId12"/>
-    <p:sldId id="477" r:id="rId13"/>
+    <p:sldId id="483" r:id="rId25"/>
     <p:sldId id="475" r:id="rId14"/>
     <p:sldId id="478" r:id="rId15"/>
     <p:sldId id="480" r:id="rId16"/>
@@ -25078,7 +25077,7 @@
                   <a:srgbClr val="677078"/>
                 </a:solidFill>
               </a:rPr>
-              <a:t>Qualität &amp; Forschung</a:t>
+              <a:t>Zielbild</a:t>
             </a:r>
           </a:p>
         </p:txBody>
@@ -25112,7 +25111,7 @@
                   <a:srgbClr val="171C1B"/>
                 </a:solidFill>
               </a:rPr>
-              <a:t>Qualität und Forschung am ZSG</a:t>
+              <a:t>Zielbild: ein Zentrum, alle Therapien</a:t>
             </a:r>
           </a:p>
         </p:txBody>
@@ -25146,7 +25145,7 @@
                   <a:srgbClr val="677078"/>
                 </a:solidFill>
               </a:rPr>
-              <a:t>Zentrum für Stoffwechsel und Gewichtsregulation, UDEM</a:t>
+              <a:t>Interdisziplinär aus einer Hand – mit zertifizierter Qualität und eigener Forschung</a:t>
             </a:r>
           </a:p>
         </p:txBody>
@@ -25209,54 +25208,22 @@
       </p:sp>
       <p:sp>
         <p:nvSpPr>
-          <p:cNvPr id="21" name="TextBox 20"/>
-          <p:cNvSpPr txBox="1"/>
-          <p:nvPr/>
-        </p:nvSpPr>
-        <p:spPr>
-          <a:xfrm>
-            <a:off x="548640" y="1645920"/>
-            <a:ext cx="3657600" cy="164592"/>
-          </a:xfrm>
-          <a:prstGeom prst="rect">
-            <a:avLst/>
-          </a:prstGeom>
-          <a:noFill/>
-        </p:spPr>
-        <p:txBody>
-          <a:bodyPr wrap="square" lIns="0" rIns="0" tIns="0" bIns="0" anchor="t">
-            <a:spAutoFit/>
-          </a:bodyPr>
-          <a:lstStyle/>
-          <a:p>
-            <a:pPr algn="l"/>
-            <a:r>
-              <a:rPr sz="980" b="1" i="0">
-                <a:solidFill>
-                  <a:srgbClr val="009670"/>
-                </a:solidFill>
-              </a:rPr>
-              <a:t>QUALITÄT</a:t>
-            </a:r>
-          </a:p>
-        </p:txBody>
-      </p:sp>
-      <p:sp>
-        <p:nvSpPr>
-          <p:cNvPr id="22" name="Rectangle 21"/>
+          <p:cNvPr id="21" name="Trapezoid 20"/>
           <p:cNvSpPr/>
           <p:nvPr/>
         </p:nvSpPr>
         <p:spPr>
           <a:xfrm>
-            <a:off x="548640" y="1874519"/>
-            <a:ext cx="3840480" cy="932688"/>
-          </a:xfrm>
-          <a:prstGeom prst="rect">
-            <a:avLst/>
+            <a:off x="548640" y="1572768"/>
+            <a:ext cx="8046720" cy="365760"/>
+          </a:xfrm>
+          <a:prstGeom prst="trapezoid">
+            <a:avLst>
+              <a:gd name="adj" fmla="val 60000"/>
+            </a:avLst>
           </a:prstGeom>
           <a:solidFill>
-            <a:srgbClr val="F0F6F3"/>
+            <a:srgbClr val="009670"/>
           </a:solidFill>
           <a:ln>
             <a:noFill/>
@@ -25278,16 +25245,732 @@
           </a:fontRef>
         </p:style>
         <p:txBody>
+          <a:bodyPr rtlCol="0" anchor="ctr" wrap="square" lIns="54864" rIns="54864" tIns="18288" bIns="18288"/>
+          <a:lstStyle/>
+          <a:p>
+            <a:pPr algn="ctr"/>
+            <a:r>
+              <a:rPr sz="1150" b="1">
+                <a:solidFill>
+                  <a:srgbClr val="FFFFFF"/>
+                </a:solidFill>
+              </a:rPr>
+              <a:t>Gemeinsames Adipositaszentrum UDEM &amp; UVCM</a:t>
+            </a:r>
+          </a:p>
+        </p:txBody>
+      </p:sp>
+      <p:sp>
+        <p:nvSpPr>
+          <p:cNvPr id="22" name="Rectangle 21"/>
+          <p:cNvSpPr/>
+          <p:nvPr/>
+        </p:nvSpPr>
+        <p:spPr>
+          <a:xfrm>
+            <a:off x="731520" y="2011680"/>
+            <a:ext cx="1796796" cy="1115568"/>
+          </a:xfrm>
+          <a:prstGeom prst="rect">
+            <a:avLst/>
+          </a:prstGeom>
+          <a:solidFill>
+            <a:srgbClr val="F0F6F3"/>
+          </a:solidFill>
+          <a:ln>
+            <a:noFill/>
+          </a:ln>
+          <a:effectLst/>
+        </p:spPr>
+        <p:style>
+          <a:lnRef idx="1">
+            <a:schemeClr val="accent1"/>
+          </a:lnRef>
+          <a:fillRef idx="3">
+            <a:schemeClr val="accent1"/>
+          </a:fillRef>
+          <a:effectRef idx="2">
+            <a:schemeClr val="accent1"/>
+          </a:effectRef>
+          <a:fontRef idx="minor">
+            <a:schemeClr val="lt1"/>
+          </a:fontRef>
+        </p:style>
+        <p:txBody>
           <a:bodyPr rtlCol="0" anchor="ctr"/>
           <a:lstStyle/>
           <a:p>
             <a:pPr algn="ctr"/>
+          </a:p>
+        </p:txBody>
+      </p:sp>
+      <p:sp>
+        <p:nvSpPr>
+          <p:cNvPr id="23" name="TextBox 22"/>
+          <p:cNvSpPr txBox="1"/>
+          <p:nvPr/>
+        </p:nvSpPr>
+        <p:spPr>
+          <a:xfrm>
+            <a:off x="868680" y="2112264"/>
+            <a:ext cx="1522476" cy="146304"/>
+          </a:xfrm>
+          <a:prstGeom prst="rect">
+            <a:avLst/>
+          </a:prstGeom>
+          <a:noFill/>
+        </p:spPr>
+        <p:txBody>
+          <a:bodyPr wrap="square" lIns="0" rIns="0" tIns="0" bIns="0" anchor="t">
+            <a:spAutoFit/>
+          </a:bodyPr>
+          <a:lstStyle/>
+          <a:p>
+            <a:pPr algn="l"/>
+            <a:r>
+              <a:rPr sz="850" b="1" i="0">
+                <a:solidFill>
+                  <a:srgbClr val="009670"/>
+                </a:solidFill>
+              </a:rPr>
+              <a:t>UDEM</a:t>
+            </a:r>
+          </a:p>
+        </p:txBody>
+      </p:sp>
+      <p:sp>
+        <p:nvSpPr>
+          <p:cNvPr id="24" name="TextBox 23"/>
+          <p:cNvSpPr txBox="1"/>
+          <p:nvPr/>
+        </p:nvSpPr>
+        <p:spPr>
+          <a:xfrm>
+            <a:off x="868680" y="2286000"/>
+            <a:ext cx="1522476" cy="384048"/>
+          </a:xfrm>
+          <a:prstGeom prst="rect">
+            <a:avLst/>
+          </a:prstGeom>
+          <a:noFill/>
+        </p:spPr>
+        <p:txBody>
+          <a:bodyPr wrap="square" lIns="0" rIns="0" tIns="0" bIns="0" anchor="t">
+            <a:spAutoFit/>
+          </a:bodyPr>
+          <a:lstStyle/>
+          <a:p>
+            <a:pPr algn="l"/>
+            <a:r>
+              <a:rPr sz="1150" b="1" i="0">
+                <a:solidFill>
+                  <a:srgbClr val="171C1B"/>
+                </a:solidFill>
+              </a:rPr>
+              <a:t>Ernährung</a:t>
+            </a:r>
+          </a:p>
+        </p:txBody>
+      </p:sp>
+      <p:sp>
+        <p:nvSpPr>
+          <p:cNvPr id="25" name="TextBox 24"/>
+          <p:cNvSpPr txBox="1"/>
+          <p:nvPr/>
+        </p:nvSpPr>
+        <p:spPr>
+          <a:xfrm>
+            <a:off x="868680" y="2743200"/>
+            <a:ext cx="1522476" cy="310896"/>
+          </a:xfrm>
+          <a:prstGeom prst="rect">
+            <a:avLst/>
+          </a:prstGeom>
+          <a:noFill/>
+        </p:spPr>
+        <p:txBody>
+          <a:bodyPr wrap="square" lIns="0" rIns="0" tIns="0" bIns="0" anchor="b">
+            <a:spAutoFit/>
+          </a:bodyPr>
+          <a:lstStyle/>
+          <a:p>
+            <a:pPr algn="l"/>
+            <a:r>
+              <a:rPr sz="850" b="0" i="0">
+                <a:solidFill>
+                  <a:srgbClr val="677078"/>
+                </a:solidFill>
+              </a:rPr>
+              <a:t>Ernährungsmedizin &amp; Ernährungsberatung</a:t>
+            </a:r>
+          </a:p>
+        </p:txBody>
+      </p:sp>
+      <p:sp>
+        <p:nvSpPr>
+          <p:cNvPr id="26" name="Rectangle 25"/>
+          <p:cNvSpPr/>
+          <p:nvPr/>
+        </p:nvSpPr>
+        <p:spPr>
+          <a:xfrm>
+            <a:off x="2692908" y="2011680"/>
+            <a:ext cx="1796796" cy="1115568"/>
+          </a:xfrm>
+          <a:prstGeom prst="rect">
+            <a:avLst/>
+          </a:prstGeom>
+          <a:solidFill>
+            <a:srgbClr val="F0F6F3"/>
+          </a:solidFill>
+          <a:ln>
+            <a:noFill/>
+          </a:ln>
+          <a:effectLst/>
+        </p:spPr>
+        <p:style>
+          <a:lnRef idx="1">
+            <a:schemeClr val="accent1"/>
+          </a:lnRef>
+          <a:fillRef idx="3">
+            <a:schemeClr val="accent1"/>
+          </a:fillRef>
+          <a:effectRef idx="2">
+            <a:schemeClr val="accent1"/>
+          </a:effectRef>
+          <a:fontRef idx="minor">
+            <a:schemeClr val="lt1"/>
+          </a:fontRef>
+        </p:style>
+        <p:txBody>
+          <a:bodyPr rtlCol="0" anchor="ctr"/>
+          <a:lstStyle/>
+          <a:p>
+            <a:pPr algn="ctr"/>
+          </a:p>
+        </p:txBody>
+      </p:sp>
+      <p:sp>
+        <p:nvSpPr>
+          <p:cNvPr id="27" name="TextBox 26"/>
+          <p:cNvSpPr txBox="1"/>
+          <p:nvPr/>
+        </p:nvSpPr>
+        <p:spPr>
+          <a:xfrm>
+            <a:off x="2830068" y="2112264"/>
+            <a:ext cx="1522476" cy="146304"/>
+          </a:xfrm>
+          <a:prstGeom prst="rect">
+            <a:avLst/>
+          </a:prstGeom>
+          <a:noFill/>
+        </p:spPr>
+        <p:txBody>
+          <a:bodyPr wrap="square" lIns="0" rIns="0" tIns="0" bIns="0" anchor="t">
+            <a:spAutoFit/>
+          </a:bodyPr>
+          <a:lstStyle/>
+          <a:p>
+            <a:pPr algn="l"/>
+            <a:r>
+              <a:rPr sz="850" b="1" i="0">
+                <a:solidFill>
+                  <a:srgbClr val="009670"/>
+                </a:solidFill>
+              </a:rPr>
+              <a:t>UDEM</a:t>
+            </a:r>
+          </a:p>
+        </p:txBody>
+      </p:sp>
+      <p:sp>
+        <p:nvSpPr>
+          <p:cNvPr id="28" name="TextBox 27"/>
+          <p:cNvSpPr txBox="1"/>
+          <p:nvPr/>
+        </p:nvSpPr>
+        <p:spPr>
+          <a:xfrm>
+            <a:off x="2830068" y="2286000"/>
+            <a:ext cx="1522476" cy="384048"/>
+          </a:xfrm>
+          <a:prstGeom prst="rect">
+            <a:avLst/>
+          </a:prstGeom>
+          <a:noFill/>
+        </p:spPr>
+        <p:txBody>
+          <a:bodyPr wrap="square" lIns="0" rIns="0" tIns="0" bIns="0" anchor="t">
+            <a:spAutoFit/>
+          </a:bodyPr>
+          <a:lstStyle/>
+          <a:p>
+            <a:pPr algn="l"/>
+            <a:r>
+              <a:rPr sz="1150" b="1" i="0">
+                <a:solidFill>
+                  <a:srgbClr val="171C1B"/>
+                </a:solidFill>
+              </a:rPr>
+              <a:t>Medikamentöse Therapie</a:t>
+            </a:r>
+          </a:p>
+        </p:txBody>
+      </p:sp>
+      <p:sp>
+        <p:nvSpPr>
+          <p:cNvPr id="29" name="TextBox 28"/>
+          <p:cNvSpPr txBox="1"/>
+          <p:nvPr/>
+        </p:nvSpPr>
+        <p:spPr>
+          <a:xfrm>
+            <a:off x="2830068" y="2743200"/>
+            <a:ext cx="1522476" cy="310896"/>
+          </a:xfrm>
+          <a:prstGeom prst="rect">
+            <a:avLst/>
+          </a:prstGeom>
+          <a:noFill/>
+        </p:spPr>
+        <p:txBody>
+          <a:bodyPr wrap="square" lIns="0" rIns="0" tIns="0" bIns="0" anchor="b">
+            <a:spAutoFit/>
+          </a:bodyPr>
+          <a:lstStyle/>
+          <a:p>
+            <a:pPr algn="l"/>
+            <a:r>
+              <a:rPr sz="850" b="0" i="0">
+                <a:solidFill>
+                  <a:srgbClr val="677078"/>
+                </a:solidFill>
+              </a:rPr>
+              <a:t>Abklärung, Behandlung und Verlauf</a:t>
+            </a:r>
+          </a:p>
+        </p:txBody>
+      </p:sp>
+      <p:sp>
+        <p:nvSpPr>
+          <p:cNvPr id="30" name="Rectangle 29"/>
+          <p:cNvSpPr/>
+          <p:nvPr/>
+        </p:nvSpPr>
+        <p:spPr>
+          <a:xfrm>
+            <a:off x="4654296" y="2011680"/>
+            <a:ext cx="1796796" cy="1115568"/>
+          </a:xfrm>
+          <a:prstGeom prst="rect">
+            <a:avLst/>
+          </a:prstGeom>
+          <a:solidFill>
+            <a:srgbClr val="F0F6F3"/>
+          </a:solidFill>
+          <a:ln>
+            <a:noFill/>
+          </a:ln>
+          <a:effectLst/>
+        </p:spPr>
+        <p:style>
+          <a:lnRef idx="1">
+            <a:schemeClr val="accent1"/>
+          </a:lnRef>
+          <a:fillRef idx="3">
+            <a:schemeClr val="accent1"/>
+          </a:fillRef>
+          <a:effectRef idx="2">
+            <a:schemeClr val="accent1"/>
+          </a:effectRef>
+          <a:fontRef idx="minor">
+            <a:schemeClr val="lt1"/>
+          </a:fontRef>
+        </p:style>
+        <p:txBody>
+          <a:bodyPr rtlCol="0" anchor="ctr"/>
+          <a:lstStyle/>
+          <a:p>
+            <a:pPr algn="ctr"/>
+          </a:p>
+        </p:txBody>
+      </p:sp>
+      <p:sp>
+        <p:nvSpPr>
+          <p:cNvPr id="31" name="TextBox 30"/>
+          <p:cNvSpPr txBox="1"/>
+          <p:nvPr/>
+        </p:nvSpPr>
+        <p:spPr>
+          <a:xfrm>
+            <a:off x="4791456" y="2112264"/>
+            <a:ext cx="1522476" cy="146304"/>
+          </a:xfrm>
+          <a:prstGeom prst="rect">
+            <a:avLst/>
+          </a:prstGeom>
+          <a:noFill/>
+        </p:spPr>
+        <p:txBody>
+          <a:bodyPr wrap="square" lIns="0" rIns="0" tIns="0" bIns="0" anchor="t">
+            <a:spAutoFit/>
+          </a:bodyPr>
+          <a:lstStyle/>
+          <a:p>
+            <a:pPr algn="l"/>
+            <a:r>
+              <a:rPr sz="850" b="1" i="0">
+                <a:solidFill>
+                  <a:srgbClr val="009670"/>
+                </a:solidFill>
+              </a:rPr>
+              <a:t>UVCM</a:t>
+            </a:r>
+          </a:p>
+        </p:txBody>
+      </p:sp>
+      <p:sp>
+        <p:nvSpPr>
+          <p:cNvPr id="32" name="TextBox 31"/>
+          <p:cNvSpPr txBox="1"/>
+          <p:nvPr/>
+        </p:nvSpPr>
+        <p:spPr>
+          <a:xfrm>
+            <a:off x="4791456" y="2286000"/>
+            <a:ext cx="1522476" cy="384048"/>
+          </a:xfrm>
+          <a:prstGeom prst="rect">
+            <a:avLst/>
+          </a:prstGeom>
+          <a:noFill/>
+        </p:spPr>
+        <p:txBody>
+          <a:bodyPr wrap="square" lIns="0" rIns="0" tIns="0" bIns="0" anchor="t">
+            <a:spAutoFit/>
+          </a:bodyPr>
+          <a:lstStyle/>
+          <a:p>
+            <a:pPr algn="l"/>
+            <a:r>
+              <a:rPr sz="1150" b="1" i="0">
+                <a:solidFill>
+                  <a:srgbClr val="171C1B"/>
+                </a:solidFill>
+              </a:rPr>
+              <a:t>Bariatrische Chirurgie</a:t>
+            </a:r>
+          </a:p>
+        </p:txBody>
+      </p:sp>
+      <p:sp>
+        <p:nvSpPr>
+          <p:cNvPr id="33" name="TextBox 32"/>
+          <p:cNvSpPr txBox="1"/>
+          <p:nvPr/>
+        </p:nvSpPr>
+        <p:spPr>
+          <a:xfrm>
+            <a:off x="4791456" y="2743200"/>
+            <a:ext cx="1522476" cy="310896"/>
+          </a:xfrm>
+          <a:prstGeom prst="rect">
+            <a:avLst/>
+          </a:prstGeom>
+          <a:noFill/>
+        </p:spPr>
+        <p:txBody>
+          <a:bodyPr wrap="square" lIns="0" rIns="0" tIns="0" bIns="0" anchor="b">
+            <a:spAutoFit/>
+          </a:bodyPr>
+          <a:lstStyle/>
+          <a:p>
+            <a:pPr algn="l"/>
+            <a:r>
+              <a:rPr sz="850" b="0" i="0">
+                <a:solidFill>
+                  <a:srgbClr val="677078"/>
+                </a:solidFill>
+              </a:rPr>
+              <a:t>Operative und endoskopische Verfahren</a:t>
+            </a:r>
+          </a:p>
+        </p:txBody>
+      </p:sp>
+      <p:sp>
+        <p:nvSpPr>
+          <p:cNvPr id="34" name="Rectangle 33"/>
+          <p:cNvSpPr/>
+          <p:nvPr/>
+        </p:nvSpPr>
+        <p:spPr>
+          <a:xfrm>
+            <a:off x="6615684" y="2011680"/>
+            <a:ext cx="1796796" cy="1115568"/>
+          </a:xfrm>
+          <a:prstGeom prst="rect">
+            <a:avLst/>
+          </a:prstGeom>
+          <a:solidFill>
+            <a:srgbClr val="F0F6F3"/>
+          </a:solidFill>
+          <a:ln>
+            <a:noFill/>
+          </a:ln>
+          <a:effectLst/>
+        </p:spPr>
+        <p:style>
+          <a:lnRef idx="1">
+            <a:schemeClr val="accent1"/>
+          </a:lnRef>
+          <a:fillRef idx="3">
+            <a:schemeClr val="accent1"/>
+          </a:fillRef>
+          <a:effectRef idx="2">
+            <a:schemeClr val="accent1"/>
+          </a:effectRef>
+          <a:fontRef idx="minor">
+            <a:schemeClr val="lt1"/>
+          </a:fontRef>
+        </p:style>
+        <p:txBody>
+          <a:bodyPr rtlCol="0" anchor="ctr"/>
+          <a:lstStyle/>
+          <a:p>
+            <a:pPr algn="ctr"/>
+          </a:p>
+        </p:txBody>
+      </p:sp>
+      <p:sp>
+        <p:nvSpPr>
+          <p:cNvPr id="35" name="TextBox 34"/>
+          <p:cNvSpPr txBox="1"/>
+          <p:nvPr/>
+        </p:nvSpPr>
+        <p:spPr>
+          <a:xfrm>
+            <a:off x="6752844" y="2112264"/>
+            <a:ext cx="1522476" cy="146304"/>
+          </a:xfrm>
+          <a:prstGeom prst="rect">
+            <a:avLst/>
+          </a:prstGeom>
+          <a:noFill/>
+        </p:spPr>
+        <p:txBody>
+          <a:bodyPr wrap="square" lIns="0" rIns="0" tIns="0" bIns="0" anchor="t">
+            <a:spAutoFit/>
+          </a:bodyPr>
+          <a:lstStyle/>
+          <a:p>
+            <a:pPr algn="l"/>
+            <a:r>
+              <a:rPr sz="850" b="1" i="0">
+                <a:solidFill>
+                  <a:srgbClr val="009670"/>
+                </a:solidFill>
+              </a:rPr>
+              <a:t>UDEM</a:t>
+            </a:r>
+          </a:p>
+        </p:txBody>
+      </p:sp>
+      <p:sp>
+        <p:nvSpPr>
+          <p:cNvPr id="36" name="TextBox 35"/>
+          <p:cNvSpPr txBox="1"/>
+          <p:nvPr/>
+        </p:nvSpPr>
+        <p:spPr>
+          <a:xfrm>
+            <a:off x="6752844" y="2286000"/>
+            <a:ext cx="1522476" cy="384048"/>
+          </a:xfrm>
+          <a:prstGeom prst="rect">
+            <a:avLst/>
+          </a:prstGeom>
+          <a:noFill/>
+        </p:spPr>
+        <p:txBody>
+          <a:bodyPr wrap="square" lIns="0" rIns="0" tIns="0" bIns="0" anchor="t">
+            <a:spAutoFit/>
+          </a:bodyPr>
+          <a:lstStyle/>
+          <a:p>
+            <a:pPr algn="l"/>
+            <a:r>
+              <a:rPr sz="1150" b="1" i="0">
+                <a:solidFill>
+                  <a:srgbClr val="171C1B"/>
+                </a:solidFill>
+              </a:rPr>
+              <a:t>Postbariatrische Chirurgie</a:t>
+            </a:r>
+          </a:p>
+        </p:txBody>
+      </p:sp>
+      <p:sp>
+        <p:nvSpPr>
+          <p:cNvPr id="37" name="TextBox 36"/>
+          <p:cNvSpPr txBox="1"/>
+          <p:nvPr/>
+        </p:nvSpPr>
+        <p:spPr>
+          <a:xfrm>
+            <a:off x="6752844" y="2743200"/>
+            <a:ext cx="1522476" cy="310896"/>
+          </a:xfrm>
+          <a:prstGeom prst="rect">
+            <a:avLst/>
+          </a:prstGeom>
+          <a:noFill/>
+        </p:spPr>
+        <p:txBody>
+          <a:bodyPr wrap="square" lIns="0" rIns="0" tIns="0" bIns="0" anchor="b">
+            <a:spAutoFit/>
+          </a:bodyPr>
+          <a:lstStyle/>
+          <a:p>
+            <a:pPr algn="l"/>
+            <a:r>
+              <a:rPr sz="850" b="0" i="0">
+                <a:solidFill>
+                  <a:srgbClr val="677078"/>
+                </a:solidFill>
+              </a:rPr>
+              <a:t>Nachsorge</a:t>
+            </a:r>
+          </a:p>
+        </p:txBody>
+      </p:sp>
+      <p:sp>
+        <p:nvSpPr>
+          <p:cNvPr id="38" name="Rectangle 37"/>
+          <p:cNvSpPr/>
+          <p:nvPr/>
+        </p:nvSpPr>
+        <p:spPr>
+          <a:xfrm>
+            <a:off x="548640" y="3191256"/>
+            <a:ext cx="8046720" cy="36576"/>
+          </a:xfrm>
+          <a:prstGeom prst="rect">
+            <a:avLst/>
+          </a:prstGeom>
+          <a:solidFill>
+            <a:srgbClr val="009670"/>
+          </a:solidFill>
+          <a:ln>
+            <a:noFill/>
+          </a:ln>
+          <a:effectLst/>
+        </p:spPr>
+        <p:style>
+          <a:lnRef idx="1">
+            <a:schemeClr val="accent1"/>
+          </a:lnRef>
+          <a:fillRef idx="3">
+            <a:schemeClr val="accent1"/>
+          </a:fillRef>
+          <a:effectRef idx="2">
+            <a:schemeClr val="accent1"/>
+          </a:effectRef>
+          <a:fontRef idx="minor">
+            <a:schemeClr val="lt1"/>
+          </a:fontRef>
+        </p:style>
+        <p:txBody>
+          <a:bodyPr rtlCol="0" anchor="ctr"/>
+          <a:lstStyle/>
+          <a:p>
+            <a:pPr algn="ctr"/>
+          </a:p>
+        </p:txBody>
+      </p:sp>
+      <p:sp>
+        <p:nvSpPr>
+          <p:cNvPr id="39" name="Rectangle 38"/>
+          <p:cNvSpPr/>
+          <p:nvPr/>
+        </p:nvSpPr>
+        <p:spPr>
+          <a:xfrm>
+            <a:off x="548640" y="3291840"/>
+            <a:ext cx="3977639" cy="1389888"/>
+          </a:xfrm>
+          <a:prstGeom prst="rect">
+            <a:avLst/>
+          </a:prstGeom>
+          <a:solidFill>
+            <a:srgbClr val="FFFFFF"/>
+          </a:solidFill>
+          <a:ln w="12700">
+            <a:solidFill>
+              <a:srgbClr val="CFD8D5"/>
+            </a:solidFill>
+          </a:ln>
+          <a:effectLst/>
+        </p:spPr>
+        <p:style>
+          <a:lnRef idx="1">
+            <a:schemeClr val="accent1"/>
+          </a:lnRef>
+          <a:fillRef idx="3">
+            <a:schemeClr val="accent1"/>
+          </a:fillRef>
+          <a:effectRef idx="2">
+            <a:schemeClr val="accent1"/>
+          </a:effectRef>
+          <a:fontRef idx="minor">
+            <a:schemeClr val="lt1"/>
+          </a:fontRef>
+        </p:style>
+        <p:txBody>
+          <a:bodyPr rtlCol="0" anchor="ctr"/>
+          <a:lstStyle/>
+          <a:p>
+            <a:pPr algn="ctr"/>
+          </a:p>
+        </p:txBody>
+      </p:sp>
+      <p:sp>
+        <p:nvSpPr>
+          <p:cNvPr id="40" name="TextBox 39"/>
+          <p:cNvSpPr txBox="1"/>
+          <p:nvPr/>
+        </p:nvSpPr>
+        <p:spPr>
+          <a:xfrm>
+            <a:off x="713232" y="3383280"/>
+            <a:ext cx="2743200" cy="164592"/>
+          </a:xfrm>
+          <a:prstGeom prst="rect">
+            <a:avLst/>
+          </a:prstGeom>
+          <a:noFill/>
+        </p:spPr>
+        <p:txBody>
+          <a:bodyPr wrap="square" lIns="0" rIns="0" tIns="0" bIns="0" anchor="t">
+            <a:spAutoFit/>
+          </a:bodyPr>
+          <a:lstStyle/>
+          <a:p>
+            <a:pPr algn="l"/>
+            <a:r>
+              <a:rPr sz="980" b="1" i="0">
+                <a:solidFill>
+                  <a:srgbClr val="009670"/>
+                </a:solidFill>
+              </a:rPr>
+              <a:t>QUALITÄT</a:t>
+            </a:r>
           </a:p>
         </p:txBody>
       </p:sp>
       <p:pic>
         <p:nvPicPr>
-          <p:cNvPr id="23" name="Picture 22" descr="image.png"/>
+          <p:cNvPr id="41" name="Picture 40" descr="smob.png"/>
           <p:cNvPicPr>
             <a:picLocks noChangeAspect="1"/>
           </p:cNvPicPr>
@@ -25301,24 +25984,123 @@
         </p:blipFill>
         <p:spPr>
           <a:xfrm>
-            <a:off x="713232" y="2011680"/>
-            <a:ext cx="1691640" cy="346017"/>
+            <a:off x="731520" y="3621024"/>
+            <a:ext cx="475488" cy="475488"/>
           </a:xfrm>
           <a:prstGeom prst="rect">
             <a:avLst/>
           </a:prstGeom>
         </p:spPr>
       </p:pic>
+      <p:sp>
+        <p:nvSpPr>
+          <p:cNvPr id="42" name="TextBox 41"/>
+          <p:cNvSpPr txBox="1"/>
+          <p:nvPr/>
+        </p:nvSpPr>
+        <p:spPr>
+          <a:xfrm>
+            <a:off x="1325880" y="3703320"/>
+            <a:ext cx="2468880" cy="365760"/>
+          </a:xfrm>
+          <a:prstGeom prst="rect">
+            <a:avLst/>
+          </a:prstGeom>
+          <a:noFill/>
+        </p:spPr>
+        <p:txBody>
+          <a:bodyPr wrap="square" lIns="0" rIns="0" tIns="0" bIns="0" anchor="t">
+            <a:spAutoFit/>
+          </a:bodyPr>
+          <a:lstStyle/>
+          <a:p>
+            <a:pPr algn="l"/>
+            <a:r>
+              <a:rPr sz="1000" b="1" i="0">
+                <a:solidFill>
+                  <a:srgbClr val="171C1B"/>
+                </a:solidFill>
+              </a:rPr>
+              <a:t>Bariatrisches Referenzzentrum</a:t>
+            </a:r>
+          </a:p>
+          <a:p>
+            <a:pPr algn="l"/>
+            <a:r>
+              <a:rPr sz="850" b="0" i="0">
+                <a:solidFill>
+                  <a:srgbClr val="677078"/>
+                </a:solidFill>
+              </a:rPr>
+              <a:t>anerkannt durch die SMOB</a:t>
+            </a:r>
+          </a:p>
+        </p:txBody>
+      </p:sp>
+      <p:sp>
+        <p:nvSpPr>
+          <p:cNvPr id="43" name="Rounded Rectangle 42"/>
+          <p:cNvSpPr/>
+          <p:nvPr/>
+        </p:nvSpPr>
+        <p:spPr>
+          <a:xfrm>
+            <a:off x="3840480" y="3730752"/>
+            <a:ext cx="566928" cy="173736"/>
+          </a:xfrm>
+          <a:prstGeom prst="roundRect">
+            <a:avLst>
+              <a:gd name="adj" fmla="val 50000"/>
+            </a:avLst>
+          </a:prstGeom>
+          <a:solidFill>
+            <a:srgbClr val="009670"/>
+          </a:solidFill>
+          <a:ln>
+            <a:noFill/>
+          </a:ln>
+          <a:effectLst/>
+        </p:spPr>
+        <p:style>
+          <a:lnRef idx="1">
+            <a:schemeClr val="accent1"/>
+          </a:lnRef>
+          <a:fillRef idx="3">
+            <a:schemeClr val="accent1"/>
+          </a:fillRef>
+          <a:effectRef idx="2">
+            <a:schemeClr val="accent1"/>
+          </a:effectRef>
+          <a:fontRef idx="minor">
+            <a:schemeClr val="lt1"/>
+          </a:fontRef>
+        </p:style>
+        <p:txBody>
+          <a:bodyPr rtlCol="0" anchor="ctr" wrap="square" lIns="18288" rIns="18288" tIns="18288" bIns="18288"/>
+          <a:lstStyle/>
+          <a:p>
+            <a:pPr algn="ctr"/>
+            <a:r>
+              <a:rPr sz="750" b="1">
+                <a:solidFill>
+                  <a:srgbClr val="FFFFFF"/>
+                </a:solidFill>
+              </a:rPr>
+              <a:t>UVCM</a:t>
+            </a:r>
+          </a:p>
+        </p:txBody>
+      </p:sp>
       <p:cxnSp>
         <p:nvCxnSpPr>
-          <p:cNvPr id="24" name="Connector 23"/>
+          <p:cNvPr id="44" name="Connector 43"/>
           <p:cNvCxnSpPr/>
           <p:nvPr/>
         </p:nvCxnSpPr>
         <p:spPr>
           <a:xfrm>
-            <a:off x="2578608" y="2011680"/>
-            <a:ext cx="0" cy="658368"/>
+            <a:off x="713232" y="4178808"/>
+            <a:ext cx="3648456" cy="0"/>
           </a:xfrm>
           <a:prstGeom prst="line">
             <a:avLst/>
@@ -25344,16 +26126,40 @@
           </a:fontRef>
         </p:style>
       </p:cxnSp>
-      <p:sp>
-        <p:nvSpPr>
-          <p:cNvPr id="25" name="TextBox 24"/>
+      <p:pic>
+        <p:nvPicPr>
+          <p:cNvPr id="45" name="Picture 44" descr="image.png"/>
+          <p:cNvPicPr>
+            <a:picLocks noChangeAspect="1"/>
+          </p:cNvPicPr>
+          <p:nvPr/>
+        </p:nvPicPr>
+        <p:blipFill>
+          <a:blip r:embed="rId3"/>
+          <a:stretch>
+            <a:fillRect/>
+          </a:stretch>
+        </p:blipFill>
+        <p:spPr>
+          <a:xfrm>
+            <a:off x="713232" y="4270248"/>
+            <a:ext cx="1371600" cy="280555"/>
+          </a:xfrm>
+          <a:prstGeom prst="rect">
+            <a:avLst/>
+          </a:prstGeom>
+        </p:spPr>
+      </p:pic>
+      <p:sp>
+        <p:nvSpPr>
+          <p:cNvPr id="46" name="TextBox 45"/>
           <p:cNvSpPr txBox="1"/>
           <p:nvPr/>
         </p:nvSpPr>
         <p:spPr>
           <a:xfrm>
-            <a:off x="2715768" y="2011680"/>
-            <a:ext cx="1600200" cy="685800"/>
+            <a:off x="2240280" y="4242816"/>
+            <a:ext cx="1554480" cy="365760"/>
           </a:xfrm>
           <a:prstGeom prst="rect">
             <a:avLst/>
@@ -25368,7 +26174,7 @@
           <a:p>
             <a:pPr algn="l"/>
             <a:r>
-              <a:rPr sz="1100" b="1" i="0">
+              <a:rPr sz="1000" b="1" i="0">
                 <a:solidFill>
                   <a:srgbClr val="171C1B"/>
                 </a:solidFill>
@@ -25377,38 +26183,36 @@
             </a:r>
           </a:p>
           <a:p>
-            <a:pPr algn="l">
-              <a:spcBef>
-                <a:spcPts val="200"/>
-              </a:spcBef>
-            </a:pPr>
+            <a:pPr algn="l"/>
             <a:r>
               <a:rPr sz="850" b="0" i="0">
                 <a:solidFill>
                   <a:srgbClr val="677078"/>
                 </a:solidFill>
               </a:rPr>
-              <a:t>Zertifiziert durch die European Association for the Study of Obesity</a:t>
-            </a:r>
-          </a:p>
-        </p:txBody>
-      </p:sp>
-      <p:sp>
-        <p:nvSpPr>
-          <p:cNvPr id="26" name="Rectangle 25"/>
+              <a:t>Swiss Medical Obesity Center</a:t>
+            </a:r>
+          </a:p>
+        </p:txBody>
+      </p:sp>
+      <p:sp>
+        <p:nvSpPr>
+          <p:cNvPr id="47" name="Rounded Rectangle 46"/>
           <p:cNvSpPr/>
           <p:nvPr/>
         </p:nvSpPr>
         <p:spPr>
           <a:xfrm>
-            <a:off x="548640" y="2898648"/>
-            <a:ext cx="3840480" cy="804672"/>
-          </a:xfrm>
-          <a:prstGeom prst="rect">
-            <a:avLst/>
+            <a:off x="3840480" y="4279392"/>
+            <a:ext cx="566928" cy="173736"/>
+          </a:xfrm>
+          <a:prstGeom prst="roundRect">
+            <a:avLst>
+              <a:gd name="adj" fmla="val 50000"/>
+            </a:avLst>
           </a:prstGeom>
           <a:solidFill>
-            <a:srgbClr val="F0F6F3"/>
+            <a:srgbClr val="009670"/>
           </a:solidFill>
           <a:ln>
             <a:noFill/>
@@ -25430,106 +26234,31 @@
           </a:fontRef>
         </p:style>
         <p:txBody>
-          <a:bodyPr rtlCol="0" anchor="ctr"/>
+          <a:bodyPr rtlCol="0" anchor="ctr" wrap="square" lIns="18288" rIns="18288" tIns="18288" bIns="18288"/>
           <a:lstStyle/>
           <a:p>
             <a:pPr algn="ctr"/>
-          </a:p>
-        </p:txBody>
-      </p:sp>
-      <p:sp>
-        <p:nvSpPr>
-          <p:cNvPr id="27" name="TextBox 26"/>
-          <p:cNvSpPr txBox="1"/>
-          <p:nvPr/>
-        </p:nvSpPr>
-        <p:spPr>
-          <a:xfrm>
-            <a:off x="713232" y="2898648"/>
-            <a:ext cx="3566160" cy="804672"/>
-          </a:xfrm>
-          <a:prstGeom prst="rect">
-            <a:avLst/>
-          </a:prstGeom>
-          <a:noFill/>
-        </p:spPr>
-        <p:txBody>
-          <a:bodyPr wrap="square" lIns="0" rIns="0" tIns="0" bIns="0" anchor="ctr">
-            <a:spAutoFit/>
-          </a:bodyPr>
-          <a:lstStyle/>
-          <a:p>
-            <a:pPr algn="l"/>
-            <a:r>
-              <a:rPr sz="1100" b="1" i="0">
+            <a:r>
+              <a:rPr sz="750" b="1">
                 <a:solidFill>
-                  <a:srgbClr val="171C1B"/>
+                  <a:srgbClr val="FFFFFF"/>
                 </a:solidFill>
               </a:rPr>
-              <a:t>Swiss Medical Obesity Center</a:t>
-            </a:r>
-          </a:p>
-          <a:p>
-            <a:pPr algn="l">
-              <a:spcBef>
-                <a:spcPts val="200"/>
-              </a:spcBef>
-            </a:pPr>
-            <a:r>
-              <a:rPr sz="850" b="0" i="0">
-                <a:solidFill>
-                  <a:srgbClr val="677078"/>
-                </a:solidFill>
-              </a:rPr>
-              <a:t>Anerkennung als medizinisches Adipositaszentrum</a:t>
-            </a:r>
-          </a:p>
-        </p:txBody>
-      </p:sp>
-      <p:sp>
-        <p:nvSpPr>
-          <p:cNvPr id="28" name="TextBox 27"/>
-          <p:cNvSpPr txBox="1"/>
-          <p:nvPr/>
-        </p:nvSpPr>
-        <p:spPr>
-          <a:xfrm>
-            <a:off x="4754880" y="1645920"/>
-            <a:ext cx="3657600" cy="164592"/>
-          </a:xfrm>
-          <a:prstGeom prst="rect">
-            <a:avLst/>
-          </a:prstGeom>
-          <a:noFill/>
-        </p:spPr>
-        <p:txBody>
-          <a:bodyPr wrap="square" lIns="0" rIns="0" tIns="0" bIns="0" anchor="t">
-            <a:spAutoFit/>
-          </a:bodyPr>
-          <a:lstStyle/>
-          <a:p>
-            <a:pPr algn="l"/>
-            <a:r>
-              <a:rPr sz="980" b="1" i="0">
-                <a:solidFill>
-                  <a:srgbClr val="009670"/>
-                </a:solidFill>
-              </a:rPr>
-              <a:t>FORSCHUNG</a:t>
-            </a:r>
-          </a:p>
-        </p:txBody>
-      </p:sp>
-      <p:sp>
-        <p:nvSpPr>
-          <p:cNvPr id="29" name="Rectangle 28"/>
+              <a:t>ZSG</a:t>
+            </a:r>
+          </a:p>
+        </p:txBody>
+      </p:sp>
+      <p:sp>
+        <p:nvSpPr>
+          <p:cNvPr id="48" name="Rectangle 47"/>
           <p:cNvSpPr/>
           <p:nvPr/>
         </p:nvSpPr>
         <p:spPr>
           <a:xfrm>
-            <a:off x="4754880" y="1874519"/>
-            <a:ext cx="3840480" cy="1828800"/>
+            <a:off x="4617720" y="3291840"/>
+            <a:ext cx="3977639" cy="1389888"/>
           </a:xfrm>
           <a:prstGeom prst="rect">
             <a:avLst/>
@@ -25539,7 +26268,7 @@
           </a:solidFill>
           <a:ln w="12700">
             <a:solidFill>
-              <a:srgbClr val="009670"/>
+              <a:srgbClr val="CFD8D5"/>
             </a:solidFill>
           </a:ln>
           <a:effectLst/>
@@ -25568,14 +26297,14 @@
       </p:sp>
       <p:sp>
         <p:nvSpPr>
-          <p:cNvPr id="30" name="TextBox 29"/>
+          <p:cNvPr id="49" name="TextBox 48"/>
           <p:cNvSpPr txBox="1"/>
           <p:nvPr/>
         </p:nvSpPr>
         <p:spPr>
           <a:xfrm>
-            <a:off x="4919472" y="1965960"/>
-            <a:ext cx="2377440" cy="228600"/>
+            <a:off x="4782312" y="3383280"/>
+            <a:ext cx="2743200" cy="164592"/>
           </a:xfrm>
           <a:prstGeom prst="rect">
             <a:avLst/>
@@ -25590,7 +26319,41 @@
           <a:p>
             <a:pPr algn="l"/>
             <a:r>
-              <a:rPr sz="1200" b="1" i="0">
+              <a:rPr sz="980" b="1" i="0">
+                <a:solidFill>
+                  <a:srgbClr val="009670"/>
+                </a:solidFill>
+              </a:rPr>
+              <a:t>FORSCHUNG</a:t>
+            </a:r>
+          </a:p>
+        </p:txBody>
+      </p:sp>
+      <p:sp>
+        <p:nvSpPr>
+          <p:cNvPr id="50" name="TextBox 49"/>
+          <p:cNvSpPr txBox="1"/>
+          <p:nvPr/>
+        </p:nvSpPr>
+        <p:spPr>
+          <a:xfrm>
+            <a:off x="4782312" y="3675888"/>
+            <a:ext cx="2926080" cy="201168"/>
+          </a:xfrm>
+          <a:prstGeom prst="rect">
+            <a:avLst/>
+          </a:prstGeom>
+          <a:noFill/>
+        </p:spPr>
+        <p:txBody>
+          <a:bodyPr wrap="square" lIns="0" rIns="0" tIns="0" bIns="0" anchor="t">
+            <a:spAutoFit/>
+          </a:bodyPr>
+          <a:lstStyle/>
+          <a:p>
+            <a:pPr algn="l"/>
+            <a:r>
+              <a:rPr sz="1100" b="1" i="0">
                 <a:solidFill>
                   <a:srgbClr val="171C1B"/>
                 </a:solidFill>
@@ -25602,14 +26365,14 @@
       </p:sp>
       <p:sp>
         <p:nvSpPr>
-          <p:cNvPr id="31" name="Rounded Rectangle 30"/>
+          <p:cNvPr id="51" name="Rounded Rectangle 50"/>
           <p:cNvSpPr/>
           <p:nvPr/>
         </p:nvSpPr>
         <p:spPr>
           <a:xfrm>
-            <a:off x="7434072" y="1956816"/>
-            <a:ext cx="1005840" cy="219456"/>
+            <a:off x="7726679" y="3685032"/>
+            <a:ext cx="713232" cy="173736"/>
           </a:xfrm>
           <a:prstGeom prst="roundRect">
             <a:avLst>
@@ -25639,12 +26402,12 @@
           </a:fontRef>
         </p:style>
         <p:txBody>
-          <a:bodyPr rtlCol="0" anchor="ctr" wrap="square" lIns="128016" rIns="128016" tIns="18288" bIns="18288"/>
+          <a:bodyPr rtlCol="0" anchor="ctr" wrap="square" lIns="18288" rIns="18288" tIns="18288" bIns="18288"/>
           <a:lstStyle/>
           <a:p>
             <a:pPr algn="ctr"/>
             <a:r>
-              <a:rPr sz="900" b="1">
+              <a:rPr sz="750" b="1">
                 <a:solidFill>
                   <a:srgbClr val="FFFFFF"/>
                 </a:solidFill>
@@ -25656,14 +26419,14 @@
       </p:sp>
       <p:sp>
         <p:nvSpPr>
-          <p:cNvPr id="32" name="TextBox 31"/>
+          <p:cNvPr id="52" name="TextBox 51"/>
           <p:cNvSpPr txBox="1"/>
           <p:nvPr/>
         </p:nvSpPr>
         <p:spPr>
           <a:xfrm>
-            <a:off x="4919472" y="2203704"/>
-            <a:ext cx="3566160" cy="164592"/>
+            <a:off x="4782312" y="3913632"/>
+            <a:ext cx="3657600" cy="164592"/>
           </a:xfrm>
           <a:prstGeom prst="rect">
             <a:avLst/>
@@ -25690,14 +26453,14 @@
       </p:sp>
       <p:sp>
         <p:nvSpPr>
-          <p:cNvPr id="33" name="TextBox 32"/>
+          <p:cNvPr id="53" name="TextBox 52"/>
           <p:cNvSpPr txBox="1"/>
           <p:nvPr/>
         </p:nvSpPr>
         <p:spPr>
           <a:xfrm>
-            <a:off x="4919472" y="2450592"/>
-            <a:ext cx="1737360" cy="274320"/>
+            <a:off x="4782312" y="4187952"/>
+            <a:ext cx="3657600" cy="256032"/>
           </a:xfrm>
           <a:prstGeom prst="rect">
             <a:avLst/>
@@ -25712,529 +26475,36 @@
           <a:p>
             <a:pPr algn="l"/>
             <a:r>
-              <a:rPr sz="1600" b="1" i="0">
+              <a:rPr sz="1300" b="1" i="0">
                 <a:solidFill>
                   <a:srgbClr val="171C1B"/>
                 </a:solidFill>
               </a:rPr>
               <a:t>≈ 2'500</a:t>
             </a:r>
-          </a:p>
-        </p:txBody>
-      </p:sp>
-      <p:sp>
-        <p:nvSpPr>
-          <p:cNvPr id="34" name="TextBox 33"/>
-          <p:cNvSpPr txBox="1"/>
-          <p:nvPr/>
-        </p:nvSpPr>
-        <p:spPr>
-          <a:xfrm>
-            <a:off x="4919472" y="2724912"/>
-            <a:ext cx="1737360" cy="164592"/>
-          </a:xfrm>
-          <a:prstGeom prst="rect">
-            <a:avLst/>
-          </a:prstGeom>
-          <a:noFill/>
-        </p:spPr>
-        <p:txBody>
-          <a:bodyPr wrap="square" lIns="0" rIns="0" tIns="0" bIns="0" anchor="t">
-            <a:spAutoFit/>
-          </a:bodyPr>
-          <a:lstStyle/>
-          <a:p>
-            <a:pPr algn="l"/>
-            <a:r>
-              <a:rPr sz="850" b="0" i="0">
+            <a:r>
+              <a:rPr sz="900" b="0" i="0">
                 <a:solidFill>
                   <a:srgbClr val="677078"/>
                 </a:solidFill>
               </a:rPr>
-              <a:t>Teilnehmende seit 2025</a:t>
-            </a:r>
-          </a:p>
-        </p:txBody>
-      </p:sp>
-      <p:sp>
-        <p:nvSpPr>
-          <p:cNvPr id="35" name="TextBox 34"/>
-          <p:cNvSpPr txBox="1"/>
-          <p:nvPr/>
-        </p:nvSpPr>
-        <p:spPr>
-          <a:xfrm>
-            <a:off x="6675120" y="2450592"/>
-            <a:ext cx="1737360" cy="274320"/>
-          </a:xfrm>
-          <a:prstGeom prst="rect">
-            <a:avLst/>
-          </a:prstGeom>
-          <a:noFill/>
-        </p:spPr>
-        <p:txBody>
-          <a:bodyPr wrap="square" lIns="0" rIns="0" tIns="0" bIns="0" anchor="t">
-            <a:spAutoFit/>
-          </a:bodyPr>
-          <a:lstStyle/>
-          <a:p>
-            <a:pPr algn="l"/>
-            <a:r>
-              <a:rPr sz="1600" b="1" i="0">
+              <a:t> Teilnehmende seit 2025</a:t>
+            </a:r>
+            <a:r>
+              <a:rPr sz="1300" b="1" i="0">
                 <a:solidFill>
                   <a:srgbClr val="171C1B"/>
                 </a:solidFill>
               </a:rPr>
-              <a:t>10 Jahre</a:t>
-            </a:r>
-          </a:p>
-        </p:txBody>
-      </p:sp>
-      <p:sp>
-        <p:nvSpPr>
-          <p:cNvPr id="36" name="TextBox 35"/>
-          <p:cNvSpPr txBox="1"/>
-          <p:nvPr/>
-        </p:nvSpPr>
-        <p:spPr>
-          <a:xfrm>
-            <a:off x="6675120" y="2724912"/>
-            <a:ext cx="1737360" cy="164592"/>
-          </a:xfrm>
-          <a:prstGeom prst="rect">
-            <a:avLst/>
-          </a:prstGeom>
-          <a:noFill/>
-        </p:spPr>
-        <p:txBody>
-          <a:bodyPr wrap="square" lIns="0" rIns="0" tIns="0" bIns="0" anchor="t">
-            <a:spAutoFit/>
-          </a:bodyPr>
-          <a:lstStyle/>
-          <a:p>
-            <a:pPr algn="l"/>
-            <a:r>
-              <a:rPr sz="850" b="0" i="0">
+              <a:t>     10 Jahre</a:t>
+            </a:r>
+            <a:r>
+              <a:rPr sz="900" b="0" i="0">
                 <a:solidFill>
                   <a:srgbClr val="677078"/>
                 </a:solidFill>
               </a:rPr>
-              <a:t>Follow-up</a:t>
-            </a:r>
-          </a:p>
-        </p:txBody>
-      </p:sp>
-      <p:cxnSp>
-        <p:nvCxnSpPr>
-          <p:cNvPr id="37" name="Connector 36"/>
-          <p:cNvCxnSpPr/>
-          <p:nvPr/>
-        </p:nvCxnSpPr>
-        <p:spPr>
-          <a:xfrm>
-            <a:off x="6537960" y="2487168"/>
-            <a:ext cx="0" cy="384048"/>
-          </a:xfrm>
-          <a:prstGeom prst="line">
-            <a:avLst/>
-          </a:prstGeom>
-          <a:ln w="12700">
-            <a:solidFill>
-              <a:srgbClr val="CFD8D5"/>
-            </a:solidFill>
-          </a:ln>
-        </p:spPr>
-        <p:style>
-          <a:lnRef idx="2">
-            <a:schemeClr val="accent1"/>
-          </a:lnRef>
-          <a:fillRef idx="0">
-            <a:schemeClr val="accent1"/>
-          </a:fillRef>
-          <a:effectRef idx="1">
-            <a:schemeClr val="accent1"/>
-          </a:effectRef>
-          <a:fontRef idx="minor">
-            <a:schemeClr val="tx1"/>
-          </a:fontRef>
-        </p:style>
-      </p:cxnSp>
-      <p:sp>
-        <p:nvSpPr>
-          <p:cNvPr id="38" name="TextBox 37"/>
-          <p:cNvSpPr txBox="1"/>
-          <p:nvPr/>
-        </p:nvSpPr>
-        <p:spPr>
-          <a:xfrm>
-            <a:off x="4919472" y="2990088"/>
-            <a:ext cx="3566160" cy="329184"/>
-          </a:xfrm>
-          <a:prstGeom prst="rect">
-            <a:avLst/>
-          </a:prstGeom>
-          <a:noFill/>
-        </p:spPr>
-        <p:txBody>
-          <a:bodyPr wrap="square" lIns="0" rIns="0" tIns="0" bIns="0" anchor="t">
-            <a:spAutoFit/>
-          </a:bodyPr>
-          <a:lstStyle/>
-          <a:p>
-            <a:pPr algn="l"/>
-            <a:r>
-              <a:rPr sz="900" b="1" i="0">
-                <a:solidFill>
-                  <a:srgbClr val="171C1B"/>
-                </a:solidFill>
-              </a:rPr>
-              <a:t>Ziel: </a:t>
-            </a:r>
-            <a:r>
-              <a:rPr sz="900" b="0" i="0">
-                <a:solidFill>
-                  <a:srgbClr val="171C1B"/>
-                </a:solidFill>
-              </a:rPr>
-              <a:t>Auswirkungen der sich wandelnden Adipositastherapie auf Gesundheitsoutcomes und Lebensstil evaluieren</a:t>
-            </a:r>
-          </a:p>
-        </p:txBody>
-      </p:sp>
-      <p:sp>
-        <p:nvSpPr>
-          <p:cNvPr id="39" name="Rounded Rectangle 38"/>
-          <p:cNvSpPr/>
-          <p:nvPr/>
-        </p:nvSpPr>
-        <p:spPr>
-          <a:xfrm>
-            <a:off x="4919472" y="3401568"/>
-            <a:ext cx="1051560" cy="201168"/>
-          </a:xfrm>
-          <a:prstGeom prst="roundRect">
-            <a:avLst>
-              <a:gd name="adj" fmla="val 50000"/>
-            </a:avLst>
-          </a:prstGeom>
-          <a:solidFill>
-            <a:srgbClr val="F0F6F3"/>
-          </a:solidFill>
-          <a:ln>
-            <a:noFill/>
-          </a:ln>
-          <a:effectLst/>
-        </p:spPr>
-        <p:style>
-          <a:lnRef idx="1">
-            <a:schemeClr val="accent1"/>
-          </a:lnRef>
-          <a:fillRef idx="3">
-            <a:schemeClr val="accent1"/>
-          </a:fillRef>
-          <a:effectRef idx="2">
-            <a:schemeClr val="accent1"/>
-          </a:effectRef>
-          <a:fontRef idx="minor">
-            <a:schemeClr val="lt1"/>
-          </a:fontRef>
-        </p:style>
-        <p:txBody>
-          <a:bodyPr rtlCol="0" anchor="ctr" wrap="square" lIns="27432" rIns="27432" tIns="18288" bIns="18288"/>
-          <a:lstStyle/>
-          <a:p>
-            <a:pPr algn="ctr"/>
-            <a:r>
-              <a:rPr sz="800" b="0">
-                <a:solidFill>
-                  <a:srgbClr val="171C1B"/>
-                </a:solidFill>
-              </a:rPr>
-              <a:t>Krankengeschichte</a:t>
-            </a:r>
-          </a:p>
-        </p:txBody>
-      </p:sp>
-      <p:sp>
-        <p:nvSpPr>
-          <p:cNvPr id="40" name="Rounded Rectangle 39"/>
-          <p:cNvSpPr/>
-          <p:nvPr/>
-        </p:nvSpPr>
-        <p:spPr>
-          <a:xfrm>
-            <a:off x="6044183" y="3401568"/>
-            <a:ext cx="548640" cy="201168"/>
-          </a:xfrm>
-          <a:prstGeom prst="roundRect">
-            <a:avLst>
-              <a:gd name="adj" fmla="val 50000"/>
-            </a:avLst>
-          </a:prstGeom>
-          <a:solidFill>
-            <a:srgbClr val="F0F6F3"/>
-          </a:solidFill>
-          <a:ln>
-            <a:noFill/>
-          </a:ln>
-          <a:effectLst/>
-        </p:spPr>
-        <p:style>
-          <a:lnRef idx="1">
-            <a:schemeClr val="accent1"/>
-          </a:lnRef>
-          <a:fillRef idx="3">
-            <a:schemeClr val="accent1"/>
-          </a:fillRef>
-          <a:effectRef idx="2">
-            <a:schemeClr val="accent1"/>
-          </a:effectRef>
-          <a:fontRef idx="minor">
-            <a:schemeClr val="lt1"/>
-          </a:fontRef>
-        </p:style>
-        <p:txBody>
-          <a:bodyPr rtlCol="0" anchor="ctr" wrap="square" lIns="27432" rIns="27432" tIns="18288" bIns="18288"/>
-          <a:lstStyle/>
-          <a:p>
-            <a:pPr algn="ctr"/>
-            <a:r>
-              <a:rPr sz="800" b="0">
-                <a:solidFill>
-                  <a:srgbClr val="171C1B"/>
-                </a:solidFill>
-              </a:rPr>
-              <a:t>PROMs</a:t>
-            </a:r>
-          </a:p>
-        </p:txBody>
-      </p:sp>
-      <p:sp>
-        <p:nvSpPr>
-          <p:cNvPr id="41" name="Rounded Rectangle 40"/>
-          <p:cNvSpPr/>
-          <p:nvPr/>
-        </p:nvSpPr>
-        <p:spPr>
-          <a:xfrm>
-            <a:off x="6665975" y="3401568"/>
-            <a:ext cx="713232" cy="201168"/>
-          </a:xfrm>
-          <a:prstGeom prst="roundRect">
-            <a:avLst>
-              <a:gd name="adj" fmla="val 50000"/>
-            </a:avLst>
-          </a:prstGeom>
-          <a:solidFill>
-            <a:srgbClr val="F0F6F3"/>
-          </a:solidFill>
-          <a:ln>
-            <a:noFill/>
-          </a:ln>
-          <a:effectLst/>
-        </p:spPr>
-        <p:style>
-          <a:lnRef idx="1">
-            <a:schemeClr val="accent1"/>
-          </a:lnRef>
-          <a:fillRef idx="3">
-            <a:schemeClr val="accent1"/>
-          </a:fillRef>
-          <a:effectRef idx="2">
-            <a:schemeClr val="accent1"/>
-          </a:effectRef>
-          <a:fontRef idx="minor">
-            <a:schemeClr val="lt1"/>
-          </a:fontRef>
-        </p:style>
-        <p:txBody>
-          <a:bodyPr rtlCol="0" anchor="ctr" wrap="square" lIns="27432" rIns="27432" tIns="18288" bIns="18288"/>
-          <a:lstStyle/>
-          <a:p>
-            <a:pPr algn="ctr"/>
-            <a:r>
-              <a:rPr sz="800" b="0">
-                <a:solidFill>
-                  <a:srgbClr val="171C1B"/>
-                </a:solidFill>
-              </a:rPr>
-              <a:t>Biomarker</a:t>
-            </a:r>
-          </a:p>
-        </p:txBody>
-      </p:sp>
-      <p:sp>
-        <p:nvSpPr>
-          <p:cNvPr id="42" name="Rounded Rectangle 41"/>
-          <p:cNvSpPr/>
-          <p:nvPr/>
-        </p:nvSpPr>
-        <p:spPr>
-          <a:xfrm>
-            <a:off x="7452359" y="3401568"/>
-            <a:ext cx="960120" cy="201168"/>
-          </a:xfrm>
-          <a:prstGeom prst="roundRect">
-            <a:avLst>
-              <a:gd name="adj" fmla="val 50000"/>
-            </a:avLst>
-          </a:prstGeom>
-          <a:solidFill>
-            <a:srgbClr val="F0F6F3"/>
-          </a:solidFill>
-          <a:ln>
-            <a:noFill/>
-          </a:ln>
-          <a:effectLst/>
-        </p:spPr>
-        <p:style>
-          <a:lnRef idx="1">
-            <a:schemeClr val="accent1"/>
-          </a:lnRef>
-          <a:fillRef idx="3">
-            <a:schemeClr val="accent1"/>
-          </a:fillRef>
-          <a:effectRef idx="2">
-            <a:schemeClr val="accent1"/>
-          </a:effectRef>
-          <a:fontRef idx="minor">
-            <a:schemeClr val="lt1"/>
-          </a:fontRef>
-        </p:style>
-        <p:txBody>
-          <a:bodyPr rtlCol="0" anchor="ctr" wrap="square" lIns="27432" rIns="27432" tIns="18288" bIns="18288"/>
-          <a:lstStyle/>
-          <a:p>
-            <a:pPr algn="ctr"/>
-            <a:r>
-              <a:rPr sz="800" b="0">
-                <a:solidFill>
-                  <a:srgbClr val="171C1B"/>
-                </a:solidFill>
-              </a:rPr>
-              <a:t>Soziodemografie</a:t>
-            </a:r>
-          </a:p>
-        </p:txBody>
-      </p:sp>
-      <p:sp>
-        <p:nvSpPr>
-          <p:cNvPr id="43" name="Rectangle 42"/>
-          <p:cNvSpPr/>
-          <p:nvPr/>
-        </p:nvSpPr>
-        <p:spPr>
-          <a:xfrm>
-            <a:off x="548640" y="3858768"/>
-            <a:ext cx="8046720" cy="402336"/>
-          </a:xfrm>
-          <a:prstGeom prst="rect">
-            <a:avLst/>
-          </a:prstGeom>
-          <a:solidFill>
-            <a:srgbClr val="F0F6F3"/>
-          </a:solidFill>
-          <a:ln>
-            <a:noFill/>
-          </a:ln>
-          <a:effectLst/>
-        </p:spPr>
-        <p:style>
-          <a:lnRef idx="1">
-            <a:schemeClr val="accent1"/>
-          </a:lnRef>
-          <a:fillRef idx="3">
-            <a:schemeClr val="accent1"/>
-          </a:fillRef>
-          <a:effectRef idx="2">
-            <a:schemeClr val="accent1"/>
-          </a:effectRef>
-          <a:fontRef idx="minor">
-            <a:schemeClr val="lt1"/>
-          </a:fontRef>
-        </p:style>
-        <p:txBody>
-          <a:bodyPr rtlCol="0" anchor="ctr"/>
-          <a:lstStyle/>
-          <a:p>
-            <a:pPr algn="ctr"/>
-          </a:p>
-        </p:txBody>
-      </p:sp>
-      <p:sp>
-        <p:nvSpPr>
-          <p:cNvPr id="44" name="Rectangle 43"/>
-          <p:cNvSpPr/>
-          <p:nvPr/>
-        </p:nvSpPr>
-        <p:spPr>
-          <a:xfrm>
-            <a:off x="548640" y="3858768"/>
-            <a:ext cx="36576" cy="402336"/>
-          </a:xfrm>
-          <a:prstGeom prst="rect">
-            <a:avLst/>
-          </a:prstGeom>
-          <a:solidFill>
-            <a:srgbClr val="009670"/>
-          </a:solidFill>
-          <a:ln>
-            <a:noFill/>
-          </a:ln>
-          <a:effectLst/>
-        </p:spPr>
-        <p:style>
-          <a:lnRef idx="1">
-            <a:schemeClr val="accent1"/>
-          </a:lnRef>
-          <a:fillRef idx="3">
-            <a:schemeClr val="accent1"/>
-          </a:fillRef>
-          <a:effectRef idx="2">
-            <a:schemeClr val="accent1"/>
-          </a:effectRef>
-          <a:fontRef idx="minor">
-            <a:schemeClr val="lt1"/>
-          </a:fontRef>
-        </p:style>
-        <p:txBody>
-          <a:bodyPr rtlCol="0" anchor="ctr"/>
-          <a:lstStyle/>
-          <a:p>
-            <a:pPr algn="ctr"/>
-          </a:p>
-        </p:txBody>
-      </p:sp>
-      <p:sp>
-        <p:nvSpPr>
-          <p:cNvPr id="45" name="TextBox 44"/>
-          <p:cNvSpPr txBox="1"/>
-          <p:nvPr/>
-        </p:nvSpPr>
-        <p:spPr>
-          <a:xfrm>
-            <a:off x="685800" y="3858768"/>
-            <a:ext cx="7772400" cy="402336"/>
-          </a:xfrm>
-          <a:prstGeom prst="rect">
-            <a:avLst/>
-          </a:prstGeom>
-          <a:noFill/>
-        </p:spPr>
-        <p:txBody>
-          <a:bodyPr wrap="square" lIns="0" rIns="0" tIns="0" bIns="0" anchor="ctr">
-            <a:spAutoFit/>
-          </a:bodyPr>
-          <a:lstStyle/>
-          <a:p>
-            <a:pPr algn="l"/>
-            <a:r>
-              <a:rPr sz="1250" b="0" i="0">
-                <a:solidFill>
-                  <a:srgbClr val="171C1B"/>
-                </a:solidFill>
-              </a:rPr>
-              <a:t>Zertifizierte Qualität und eigene Forschung als Basis für das gemeinsame Zentrum.</a:t>
+              <a:t> Follow-up</a:t>
             </a:r>
           </a:p>
         </p:txBody>
@@ -30941,1147 +31211,6 @@
       <p:bldP spid="36" grpId="0" animBg="1"/>
     </p:bldLst>
   </p:timing>
-</p:sld>
-</file>
-
-<file path=ppt/slides/slide4.xml><?xml version="1.0" encoding="utf-8"?>
-<p:sld xmlns:a="http://schemas.openxmlformats.org/drawingml/2006/main" xmlns:r="http://schemas.openxmlformats.org/officeDocument/2006/relationships" xmlns:p="http://schemas.openxmlformats.org/presentationml/2006/main">
-  <p:cSld>
-    <p:spTree>
-      <p:nvGrpSpPr>
-        <p:cNvPr id="1" name=""/>
-        <p:cNvGrpSpPr/>
-        <p:nvPr/>
-      </p:nvGrpSpPr>
-      <p:grpSpPr>
-        <a:xfrm>
-          <a:off x="0" y="0"/>
-          <a:ext cx="0" cy="0"/>
-          <a:chOff x="0" y="0"/>
-          <a:chExt cx="0" cy="0"/>
-        </a:xfrm>
-      </p:grpSpPr>
-      <p:sp>
-        <p:nvSpPr>
-          <p:cNvPr id="2" name="Foliennummernplatzhalter 1"/>
-          <p:cNvSpPr>
-            <a:spLocks noGrp="1"/>
-          </p:cNvSpPr>
-          <p:nvPr>
-            <p:ph type="sldNum" sz="quarter" idx="10"/>
-          </p:nvPr>
-        </p:nvSpPr>
-        <p:spPr/>
-        <p:txBody>
-          <a:bodyPr/>
-          <a:lstStyle/>
-          <a:p>
-            <a:fld id="{22C43A00-C0E5-F64E-B7F3-B20E065A2C7A}" type="slidenum">
-              <a:rPr lang="de-DE" smtClean="0"/>
-              <a:pPr/>
-              <a:t>4</a:t>
-            </a:fld>
-            <a:endParaRPr lang="de-DE" dirty="0"/>
-          </a:p>
-        </p:txBody>
-      </p:sp>
-      <p:sp>
-        <p:nvSpPr>
-          <p:cNvPr id="3" name="Fußzeilenplatzhalter 2"/>
-          <p:cNvSpPr>
-            <a:spLocks noGrp="1"/>
-          </p:cNvSpPr>
-          <p:nvPr>
-            <p:ph type="ftr" sz="quarter" idx="11"/>
-          </p:nvPr>
-        </p:nvSpPr>
-        <p:spPr/>
-        <p:txBody>
-          <a:bodyPr/>
-          <a:lstStyle/>
-          <a:p>
-            <a:r>
-              <a:rPr lang="de-DE" dirty="0"/>
-              <a:t>Zusammenarbeit Adipositasbereich UDEM &amp; UVCM</a:t>
-            </a:r>
-          </a:p>
-        </p:txBody>
-      </p:sp>
-      <p:sp>
-        <p:nvSpPr>
-          <p:cNvPr id="16" name="Datumsplatzhalter 3">
-            <a:extLst>
-              <a:ext uri="{FF2B5EF4-FFF2-40B4-BE49-F238E27FC236}">
-                <a16:creationId xmlns:a16="http://schemas.microsoft.com/office/drawing/2014/main" id="{2EC89CAB-DC3A-3450-EDA0-401A7D12A58D}"/>
-              </a:ext>
-            </a:extLst>
-          </p:cNvPr>
-          <p:cNvSpPr>
-            <a:spLocks noGrp="1"/>
-          </p:cNvSpPr>
-          <p:nvPr>
-            <p:ph type="dt" sz="half" idx="12"/>
-          </p:nvPr>
-        </p:nvSpPr>
-        <p:spPr>
-          <a:xfrm>
-            <a:off x="7477128" y="4888800"/>
-            <a:ext cx="824487" cy="103465"/>
-          </a:xfrm>
-        </p:spPr>
-        <p:txBody>
-          <a:bodyPr/>
-          <a:lstStyle/>
-          <a:p>
-            <a:r>
-              <a:rPr lang="de-DE"/>
-              <a:t>27.10.2026</a:t>
-            </a:r>
-            <a:endParaRPr lang="de-DE" dirty="0"/>
-          </a:p>
-        </p:txBody>
-      </p:sp>
-      <p:sp>
-        <p:nvSpPr>
-          <p:cNvPr id="17" name="TextBox 16"/>
-          <p:cNvSpPr txBox="1"/>
-          <p:nvPr/>
-        </p:nvSpPr>
-        <p:spPr>
-          <a:xfrm>
-            <a:off x="5212080" y="347472"/>
-            <a:ext cx="3364992" cy="201168"/>
-          </a:xfrm>
-          <a:prstGeom prst="rect">
-            <a:avLst/>
-          </a:prstGeom>
-          <a:noFill/>
-        </p:spPr>
-        <p:txBody>
-          <a:bodyPr wrap="square" lIns="0" tIns="0" rIns="0" bIns="0" anchor="t">
-            <a:spAutoFit/>
-          </a:bodyPr>
-          <a:lstStyle/>
-          <a:p>
-            <a:pPr algn="r"/>
-            <a:r>
-              <a:rPr sz="960" b="0" i="0">
-                <a:solidFill>
-                  <a:srgbClr val="677078"/>
-                </a:solidFill>
-              </a:rPr>
-              <a:t>Zielbild</a:t>
-            </a:r>
-          </a:p>
-        </p:txBody>
-      </p:sp>
-      <p:sp>
-        <p:nvSpPr>
-          <p:cNvPr id="18" name="TextBox 17"/>
-          <p:cNvSpPr txBox="1"/>
-          <p:nvPr/>
-        </p:nvSpPr>
-        <p:spPr>
-          <a:xfrm>
-            <a:off x="548640" y="822960"/>
-            <a:ext cx="8046720" cy="393192"/>
-          </a:xfrm>
-          <a:prstGeom prst="rect">
-            <a:avLst/>
-          </a:prstGeom>
-          <a:noFill/>
-        </p:spPr>
-        <p:txBody>
-          <a:bodyPr wrap="square" lIns="0" tIns="0" rIns="0" bIns="0" anchor="t">
-            <a:spAutoFit/>
-          </a:bodyPr>
-          <a:lstStyle/>
-          <a:p>
-            <a:pPr algn="l"/>
-            <a:r>
-              <a:rPr sz="2150" b="1" i="0">
-                <a:solidFill>
-                  <a:srgbClr val="171C1B"/>
-                </a:solidFill>
-              </a:rPr>
-              <a:t>Zielbild: ein Zentrum, alle Therapien</a:t>
-            </a:r>
-          </a:p>
-        </p:txBody>
-      </p:sp>
-      <p:sp>
-        <p:nvSpPr>
-          <p:cNvPr id="19" name="TextBox 18"/>
-          <p:cNvSpPr txBox="1"/>
-          <p:nvPr/>
-        </p:nvSpPr>
-        <p:spPr>
-          <a:xfrm>
-            <a:off x="548640" y="1216152"/>
-            <a:ext cx="8046720" cy="210312"/>
-          </a:xfrm>
-          <a:prstGeom prst="rect">
-            <a:avLst/>
-          </a:prstGeom>
-          <a:noFill/>
-        </p:spPr>
-        <p:txBody>
-          <a:bodyPr wrap="square" lIns="0" tIns="0" rIns="0" bIns="0" anchor="t">
-            <a:spAutoFit/>
-          </a:bodyPr>
-          <a:lstStyle/>
-          <a:p>
-            <a:pPr algn="l"/>
-            <a:r>
-              <a:rPr sz="1170" b="0" i="0">
-                <a:solidFill>
-                  <a:srgbClr val="677078"/>
-                </a:solidFill>
-              </a:rPr>
-              <a:t>Interdisziplinär aus einer Hand – UDEM und UVCM gemeinsam</a:t>
-            </a:r>
-          </a:p>
-        </p:txBody>
-      </p:sp>
-      <p:sp>
-        <p:nvSpPr>
-          <p:cNvPr id="20" name="Entwurf"/>
-          <p:cNvSpPr/>
-          <p:nvPr/>
-        </p:nvSpPr>
-        <p:spPr>
-          <a:xfrm>
-            <a:off x="7662672" y="91440"/>
-            <a:ext cx="932688" cy="228600"/>
-          </a:xfrm>
-          <a:prstGeom prst="roundRect">
-            <a:avLst>
-              <a:gd name="adj" fmla="val 30000"/>
-            </a:avLst>
-          </a:prstGeom>
-          <a:solidFill>
-            <a:srgbClr val="FFFFFF"/>
-          </a:solidFill>
-          <a:ln w="19050">
-            <a:solidFill>
-              <a:srgbClr val="EE8F7A"/>
-            </a:solidFill>
-          </a:ln>
-          <a:effectLst/>
-        </p:spPr>
-        <p:style>
-          <a:lnRef idx="1">
-            <a:schemeClr val="accent1"/>
-          </a:lnRef>
-          <a:fillRef idx="3">
-            <a:schemeClr val="accent1"/>
-          </a:fillRef>
-          <a:effectRef idx="2">
-            <a:schemeClr val="accent1"/>
-          </a:effectRef>
-          <a:fontRef idx="minor">
-            <a:schemeClr val="lt1"/>
-          </a:fontRef>
-        </p:style>
-        <p:txBody>
-          <a:bodyPr wrap="square" lIns="18288" tIns="18288" rIns="18288" bIns="18288" rtlCol="0" anchor="ctr"/>
-          <a:lstStyle/>
-          <a:p>
-            <a:pPr algn="ctr"/>
-            <a:r>
-              <a:rPr sz="900" b="1">
-                <a:solidFill>
-                  <a:srgbClr val="EE8F7A"/>
-                </a:solidFill>
-              </a:rPr>
-              <a:t>ENTWURF</a:t>
-            </a:r>
-          </a:p>
-        </p:txBody>
-      </p:sp>
-      <p:sp>
-        <p:nvSpPr>
-          <p:cNvPr id="21" name="Rectangle 20"/>
-          <p:cNvSpPr/>
-          <p:nvPr/>
-        </p:nvSpPr>
-        <p:spPr>
-          <a:xfrm>
-            <a:off x="576072" y="1645920"/>
-            <a:ext cx="1865376" cy="1572768"/>
-          </a:xfrm>
-          <a:prstGeom prst="rect">
-            <a:avLst/>
-          </a:prstGeom>
-          <a:solidFill>
-            <a:srgbClr val="F0F6F3"/>
-          </a:solidFill>
-          <a:ln>
-            <a:noFill/>
-          </a:ln>
-          <a:effectLst/>
-        </p:spPr>
-        <p:style>
-          <a:lnRef idx="1">
-            <a:schemeClr val="accent1"/>
-          </a:lnRef>
-          <a:fillRef idx="3">
-            <a:schemeClr val="accent1"/>
-          </a:fillRef>
-          <a:effectRef idx="2">
-            <a:schemeClr val="accent1"/>
-          </a:effectRef>
-          <a:fontRef idx="minor">
-            <a:schemeClr val="lt1"/>
-          </a:fontRef>
-        </p:style>
-        <p:txBody>
-          <a:bodyPr rtlCol="0" anchor="ctr"/>
-          <a:lstStyle/>
-          <a:p>
-            <a:pPr algn="ctr"/>
-            <a:endParaRPr/>
-          </a:p>
-        </p:txBody>
-      </p:sp>
-      <p:sp>
-        <p:nvSpPr>
-          <p:cNvPr id="22" name="TextBox 21"/>
-          <p:cNvSpPr txBox="1"/>
-          <p:nvPr/>
-        </p:nvSpPr>
-        <p:spPr>
-          <a:xfrm>
-            <a:off x="713232" y="1783080"/>
-            <a:ext cx="1591056" cy="182880"/>
-          </a:xfrm>
-          <a:prstGeom prst="rect">
-            <a:avLst/>
-          </a:prstGeom>
-          <a:noFill/>
-        </p:spPr>
-        <p:txBody>
-          <a:bodyPr wrap="square" lIns="0" tIns="0" rIns="0" bIns="0" anchor="t">
-            <a:spAutoFit/>
-          </a:bodyPr>
-          <a:lstStyle/>
-          <a:p>
-            <a:pPr algn="l"/>
-            <a:r>
-              <a:rPr sz="980" b="1" i="0">
-                <a:solidFill>
-                  <a:srgbClr val="009670"/>
-                </a:solidFill>
-              </a:rPr>
-              <a:t>UDEM</a:t>
-            </a:r>
-          </a:p>
-        </p:txBody>
-      </p:sp>
-      <p:sp>
-        <p:nvSpPr>
-          <p:cNvPr id="23" name="TextBox 22"/>
-          <p:cNvSpPr txBox="1"/>
-          <p:nvPr/>
-        </p:nvSpPr>
-        <p:spPr>
-          <a:xfrm>
-            <a:off x="713232" y="2029968"/>
-            <a:ext cx="1591056" cy="215444"/>
-          </a:xfrm>
-          <a:prstGeom prst="rect">
-            <a:avLst/>
-          </a:prstGeom>
-          <a:noFill/>
-        </p:spPr>
-        <p:txBody>
-          <a:bodyPr wrap="square" lIns="0" tIns="0" rIns="0" bIns="0" anchor="t">
-            <a:spAutoFit/>
-          </a:bodyPr>
-          <a:lstStyle/>
-          <a:p>
-            <a:pPr algn="l"/>
-            <a:r>
-              <a:rPr sz="1400" b="1" i="0" dirty="0" err="1">
-                <a:solidFill>
-                  <a:srgbClr val="171C1B"/>
-                </a:solidFill>
-              </a:rPr>
-              <a:t>Ernährung</a:t>
-            </a:r>
-            <a:r>
-              <a:rPr sz="1400" b="1" i="0" dirty="0">
-                <a:solidFill>
-                  <a:srgbClr val="171C1B"/>
-                </a:solidFill>
-              </a:rPr>
-              <a:t> </a:t>
-            </a:r>
-          </a:p>
-        </p:txBody>
-      </p:sp>
-      <p:sp>
-        <p:nvSpPr>
-          <p:cNvPr id="24" name="TextBox 23"/>
-          <p:cNvSpPr txBox="1"/>
-          <p:nvPr/>
-        </p:nvSpPr>
-        <p:spPr>
-          <a:xfrm>
-            <a:off x="713232" y="2578608"/>
-            <a:ext cx="1609344" cy="338554"/>
-          </a:xfrm>
-          <a:prstGeom prst="rect">
-            <a:avLst/>
-          </a:prstGeom>
-          <a:noFill/>
-        </p:spPr>
-        <p:txBody>
-          <a:bodyPr wrap="square" lIns="0" tIns="0" rIns="0" bIns="0" anchor="t">
-            <a:spAutoFit/>
-          </a:bodyPr>
-          <a:lstStyle/>
-          <a:p>
-            <a:pPr algn="l"/>
-            <a:r>
-              <a:rPr lang="de-CH" sz="1100" b="0" i="0" dirty="0">
-                <a:solidFill>
-                  <a:srgbClr val="171C1B"/>
-                </a:solidFill>
-              </a:rPr>
-              <a:t>Ernährungsmedizin &amp; </a:t>
-            </a:r>
-            <a:r>
-              <a:rPr sz="1100" b="0" i="0" dirty="0" err="1">
-                <a:solidFill>
-                  <a:srgbClr val="171C1B"/>
-                </a:solidFill>
-              </a:rPr>
-              <a:t>Ernährungsberatung</a:t>
-            </a:r>
-            <a:r>
-              <a:rPr lang="de-CH" sz="1100" b="0" i="0" dirty="0">
-                <a:solidFill>
-                  <a:srgbClr val="171C1B"/>
-                </a:solidFill>
-              </a:rPr>
-              <a:t> </a:t>
-            </a:r>
-            <a:endParaRPr sz="1100" b="0" i="0" dirty="0">
-              <a:solidFill>
-                <a:srgbClr val="171C1B"/>
-              </a:solidFill>
-            </a:endParaRPr>
-          </a:p>
-        </p:txBody>
-      </p:sp>
-      <p:sp>
-        <p:nvSpPr>
-          <p:cNvPr id="29" name="Rectangle 28"/>
-          <p:cNvSpPr/>
-          <p:nvPr/>
-        </p:nvSpPr>
-        <p:spPr>
-          <a:xfrm>
-            <a:off x="2578608" y="1656848"/>
-            <a:ext cx="1865376" cy="1572768"/>
-          </a:xfrm>
-          <a:prstGeom prst="rect">
-            <a:avLst/>
-          </a:prstGeom>
-          <a:solidFill>
-            <a:srgbClr val="F0F6F3"/>
-          </a:solidFill>
-          <a:ln>
-            <a:noFill/>
-          </a:ln>
-          <a:effectLst/>
-        </p:spPr>
-        <p:style>
-          <a:lnRef idx="1">
-            <a:schemeClr val="accent1"/>
-          </a:lnRef>
-          <a:fillRef idx="3">
-            <a:schemeClr val="accent1"/>
-          </a:fillRef>
-          <a:effectRef idx="2">
-            <a:schemeClr val="accent1"/>
-          </a:effectRef>
-          <a:fontRef idx="minor">
-            <a:schemeClr val="lt1"/>
-          </a:fontRef>
-        </p:style>
-        <p:txBody>
-          <a:bodyPr rtlCol="0" anchor="ctr"/>
-          <a:lstStyle/>
-          <a:p>
-            <a:pPr algn="ctr"/>
-            <a:endParaRPr/>
-          </a:p>
-        </p:txBody>
-      </p:sp>
-      <p:sp>
-        <p:nvSpPr>
-          <p:cNvPr id="30" name="TextBox 29"/>
-          <p:cNvSpPr txBox="1"/>
-          <p:nvPr/>
-        </p:nvSpPr>
-        <p:spPr>
-          <a:xfrm>
-            <a:off x="2715768" y="1794008"/>
-            <a:ext cx="1591056" cy="182880"/>
-          </a:xfrm>
-          <a:prstGeom prst="rect">
-            <a:avLst/>
-          </a:prstGeom>
-          <a:noFill/>
-        </p:spPr>
-        <p:txBody>
-          <a:bodyPr wrap="square" lIns="0" tIns="0" rIns="0" bIns="0" anchor="t">
-            <a:spAutoFit/>
-          </a:bodyPr>
-          <a:lstStyle/>
-          <a:p>
-            <a:pPr algn="l"/>
-            <a:r>
-              <a:rPr sz="980" b="1" i="0">
-                <a:solidFill>
-                  <a:srgbClr val="009670"/>
-                </a:solidFill>
-              </a:rPr>
-              <a:t>UDEM</a:t>
-            </a:r>
-          </a:p>
-        </p:txBody>
-      </p:sp>
-      <p:sp>
-        <p:nvSpPr>
-          <p:cNvPr id="31" name="TextBox 30"/>
-          <p:cNvSpPr txBox="1"/>
-          <p:nvPr/>
-        </p:nvSpPr>
-        <p:spPr>
-          <a:xfrm>
-            <a:off x="2715768" y="2040896"/>
-            <a:ext cx="1591056" cy="502920"/>
-          </a:xfrm>
-          <a:prstGeom prst="rect">
-            <a:avLst/>
-          </a:prstGeom>
-          <a:noFill/>
-        </p:spPr>
-        <p:txBody>
-          <a:bodyPr wrap="square" lIns="0" tIns="0" rIns="0" bIns="0" anchor="t">
-            <a:spAutoFit/>
-          </a:bodyPr>
-          <a:lstStyle/>
-          <a:p>
-            <a:pPr algn="l"/>
-            <a:r>
-              <a:rPr sz="1400" b="1" i="0">
-                <a:solidFill>
-                  <a:srgbClr val="171C1B"/>
-                </a:solidFill>
-              </a:rPr>
-              <a:t>Medikamentöse Therapie</a:t>
-            </a:r>
-          </a:p>
-        </p:txBody>
-      </p:sp>
-      <p:sp>
-        <p:nvSpPr>
-          <p:cNvPr id="32" name="TextBox 31"/>
-          <p:cNvSpPr txBox="1"/>
-          <p:nvPr/>
-        </p:nvSpPr>
-        <p:spPr>
-          <a:xfrm>
-            <a:off x="2715768" y="2589536"/>
-            <a:ext cx="1609344" cy="548640"/>
-          </a:xfrm>
-          <a:prstGeom prst="rect">
-            <a:avLst/>
-          </a:prstGeom>
-          <a:noFill/>
-        </p:spPr>
-        <p:txBody>
-          <a:bodyPr wrap="square" lIns="0" tIns="0" rIns="0" bIns="0" anchor="t">
-            <a:spAutoFit/>
-          </a:bodyPr>
-          <a:lstStyle/>
-          <a:p>
-            <a:pPr algn="l"/>
-            <a:r>
-              <a:rPr sz="1100" b="0" i="0">
-                <a:solidFill>
-                  <a:srgbClr val="171C1B"/>
-                </a:solidFill>
-              </a:rPr>
-              <a:t>Abklärung, Behandlung und Verlauf</a:t>
-            </a:r>
-          </a:p>
-        </p:txBody>
-      </p:sp>
-      <p:sp>
-        <p:nvSpPr>
-          <p:cNvPr id="33" name="Rectangle 32"/>
-          <p:cNvSpPr/>
-          <p:nvPr/>
-        </p:nvSpPr>
-        <p:spPr>
-          <a:xfrm>
-            <a:off x="4572000" y="1640865"/>
-            <a:ext cx="1865376" cy="1572768"/>
-          </a:xfrm>
-          <a:prstGeom prst="rect">
-            <a:avLst/>
-          </a:prstGeom>
-          <a:solidFill>
-            <a:srgbClr val="F0F6F3"/>
-          </a:solidFill>
-          <a:ln>
-            <a:noFill/>
-          </a:ln>
-          <a:effectLst/>
-        </p:spPr>
-        <p:style>
-          <a:lnRef idx="1">
-            <a:schemeClr val="accent1"/>
-          </a:lnRef>
-          <a:fillRef idx="3">
-            <a:schemeClr val="accent1"/>
-          </a:fillRef>
-          <a:effectRef idx="2">
-            <a:schemeClr val="accent1"/>
-          </a:effectRef>
-          <a:fontRef idx="minor">
-            <a:schemeClr val="lt1"/>
-          </a:fontRef>
-        </p:style>
-        <p:txBody>
-          <a:bodyPr rtlCol="0" anchor="ctr"/>
-          <a:lstStyle/>
-          <a:p>
-            <a:pPr algn="ctr"/>
-            <a:endParaRPr/>
-          </a:p>
-        </p:txBody>
-      </p:sp>
-      <p:sp>
-        <p:nvSpPr>
-          <p:cNvPr id="34" name="TextBox 33"/>
-          <p:cNvSpPr txBox="1"/>
-          <p:nvPr/>
-        </p:nvSpPr>
-        <p:spPr>
-          <a:xfrm>
-            <a:off x="4709160" y="1778025"/>
-            <a:ext cx="1591056" cy="182880"/>
-          </a:xfrm>
-          <a:prstGeom prst="rect">
-            <a:avLst/>
-          </a:prstGeom>
-          <a:noFill/>
-        </p:spPr>
-        <p:txBody>
-          <a:bodyPr wrap="square" lIns="0" tIns="0" rIns="0" bIns="0" anchor="t">
-            <a:spAutoFit/>
-          </a:bodyPr>
-          <a:lstStyle/>
-          <a:p>
-            <a:pPr algn="l"/>
-            <a:r>
-              <a:rPr sz="980" b="1" i="0">
-                <a:solidFill>
-                  <a:srgbClr val="009670"/>
-                </a:solidFill>
-              </a:rPr>
-              <a:t>UVCM</a:t>
-            </a:r>
-          </a:p>
-        </p:txBody>
-      </p:sp>
-      <p:sp>
-        <p:nvSpPr>
-          <p:cNvPr id="35" name="TextBox 34"/>
-          <p:cNvSpPr txBox="1"/>
-          <p:nvPr/>
-        </p:nvSpPr>
-        <p:spPr>
-          <a:xfrm>
-            <a:off x="4709160" y="2024913"/>
-            <a:ext cx="1591056" cy="502920"/>
-          </a:xfrm>
-          <a:prstGeom prst="rect">
-            <a:avLst/>
-          </a:prstGeom>
-          <a:noFill/>
-        </p:spPr>
-        <p:txBody>
-          <a:bodyPr wrap="square" lIns="0" tIns="0" rIns="0" bIns="0" anchor="t">
-            <a:spAutoFit/>
-          </a:bodyPr>
-          <a:lstStyle/>
-          <a:p>
-            <a:pPr algn="l"/>
-            <a:r>
-              <a:rPr sz="1400" b="1" i="0">
-                <a:solidFill>
-                  <a:srgbClr val="171C1B"/>
-                </a:solidFill>
-              </a:rPr>
-              <a:t>Bariatrische Chirurgie</a:t>
-            </a:r>
-          </a:p>
-        </p:txBody>
-      </p:sp>
-      <p:sp>
-        <p:nvSpPr>
-          <p:cNvPr id="36" name="TextBox 35"/>
-          <p:cNvSpPr txBox="1"/>
-          <p:nvPr/>
-        </p:nvSpPr>
-        <p:spPr>
-          <a:xfrm>
-            <a:off x="4709160" y="2573553"/>
-            <a:ext cx="1609344" cy="548640"/>
-          </a:xfrm>
-          <a:prstGeom prst="rect">
-            <a:avLst/>
-          </a:prstGeom>
-          <a:noFill/>
-        </p:spPr>
-        <p:txBody>
-          <a:bodyPr wrap="square" lIns="0" tIns="0" rIns="0" bIns="0" anchor="t">
-            <a:spAutoFit/>
-          </a:bodyPr>
-          <a:lstStyle/>
-          <a:p>
-            <a:pPr algn="l"/>
-            <a:r>
-              <a:rPr sz="1100" b="0" i="0">
-                <a:solidFill>
-                  <a:srgbClr val="171C1B"/>
-                </a:solidFill>
-              </a:rPr>
-              <a:t>Operative und endoskopische Verfahren</a:t>
-            </a:r>
-          </a:p>
-        </p:txBody>
-      </p:sp>
-      <p:sp>
-        <p:nvSpPr>
-          <p:cNvPr id="37" name="Rectangle 36"/>
-          <p:cNvSpPr/>
-          <p:nvPr/>
-        </p:nvSpPr>
-        <p:spPr>
-          <a:xfrm>
-            <a:off x="548640" y="3474720"/>
-            <a:ext cx="8046720" cy="1188720"/>
-          </a:xfrm>
-          <a:prstGeom prst="rect">
-            <a:avLst/>
-          </a:prstGeom>
-          <a:solidFill>
-            <a:srgbClr val="F0F6F3"/>
-          </a:solidFill>
-          <a:ln>
-            <a:noFill/>
-          </a:ln>
-          <a:effectLst/>
-        </p:spPr>
-        <p:style>
-          <a:lnRef idx="1">
-            <a:schemeClr val="accent1"/>
-          </a:lnRef>
-          <a:fillRef idx="3">
-            <a:schemeClr val="accent1"/>
-          </a:fillRef>
-          <a:effectRef idx="2">
-            <a:schemeClr val="accent1"/>
-          </a:effectRef>
-          <a:fontRef idx="minor">
-            <a:schemeClr val="lt1"/>
-          </a:fontRef>
-        </p:style>
-        <p:txBody>
-          <a:bodyPr rtlCol="0" anchor="ctr"/>
-          <a:lstStyle/>
-          <a:p>
-            <a:pPr algn="ctr"/>
-            <a:endParaRPr/>
-          </a:p>
-        </p:txBody>
-      </p:sp>
-      <p:sp>
-        <p:nvSpPr>
-          <p:cNvPr id="38" name="Rectangle 37"/>
-          <p:cNvSpPr/>
-          <p:nvPr/>
-        </p:nvSpPr>
-        <p:spPr>
-          <a:xfrm>
-            <a:off x="548640" y="3474720"/>
-            <a:ext cx="36576" cy="1188720"/>
-          </a:xfrm>
-          <a:prstGeom prst="rect">
-            <a:avLst/>
-          </a:prstGeom>
-          <a:solidFill>
-            <a:srgbClr val="009670"/>
-          </a:solidFill>
-          <a:ln>
-            <a:noFill/>
-          </a:ln>
-          <a:effectLst/>
-        </p:spPr>
-        <p:style>
-          <a:lnRef idx="1">
-            <a:schemeClr val="accent1"/>
-          </a:lnRef>
-          <a:fillRef idx="3">
-            <a:schemeClr val="accent1"/>
-          </a:fillRef>
-          <a:effectRef idx="2">
-            <a:schemeClr val="accent1"/>
-          </a:effectRef>
-          <a:fontRef idx="minor">
-            <a:schemeClr val="lt1"/>
-          </a:fontRef>
-        </p:style>
-        <p:txBody>
-          <a:bodyPr rtlCol="0" anchor="ctr"/>
-          <a:lstStyle/>
-          <a:p>
-            <a:pPr algn="ctr"/>
-            <a:endParaRPr/>
-          </a:p>
-        </p:txBody>
-      </p:sp>
-      <p:pic>
-        <p:nvPicPr>
-          <p:cNvPr id="39" name="Picture 38" descr="easo.png"/>
-          <p:cNvPicPr>
-            <a:picLocks noChangeAspect="1"/>
-          </p:cNvPicPr>
-          <p:nvPr/>
-        </p:nvPicPr>
-        <p:blipFill>
-          <a:blip r:embed="rId2"/>
-          <a:stretch>
-            <a:fillRect/>
-          </a:stretch>
-        </p:blipFill>
-        <p:spPr>
-          <a:xfrm>
-            <a:off x="822960" y="3840480"/>
-            <a:ext cx="2377440" cy="486295"/>
-          </a:xfrm>
-          <a:prstGeom prst="rect">
-            <a:avLst/>
-          </a:prstGeom>
-        </p:spPr>
-      </p:pic>
-      <p:cxnSp>
-        <p:nvCxnSpPr>
-          <p:cNvPr id="40" name="Connector 39"/>
-          <p:cNvCxnSpPr/>
-          <p:nvPr/>
-        </p:nvCxnSpPr>
-        <p:spPr>
-          <a:xfrm>
-            <a:off x="3520440" y="3657600"/>
-            <a:ext cx="0" cy="822960"/>
-          </a:xfrm>
-          <a:prstGeom prst="line">
-            <a:avLst/>
-          </a:prstGeom>
-          <a:ln w="12700">
-            <a:solidFill>
-              <a:srgbClr val="CFD8D5"/>
-            </a:solidFill>
-          </a:ln>
-        </p:spPr>
-        <p:style>
-          <a:lnRef idx="2">
-            <a:schemeClr val="accent1"/>
-          </a:lnRef>
-          <a:fillRef idx="0">
-            <a:schemeClr val="accent1"/>
-          </a:fillRef>
-          <a:effectRef idx="1">
-            <a:schemeClr val="accent1"/>
-          </a:effectRef>
-          <a:fontRef idx="minor">
-            <a:schemeClr val="tx1"/>
-          </a:fontRef>
-        </p:style>
-      </p:cxnSp>
-      <p:sp>
-        <p:nvSpPr>
-          <p:cNvPr id="42" name="TextBox 41"/>
-          <p:cNvSpPr txBox="1"/>
-          <p:nvPr/>
-        </p:nvSpPr>
-        <p:spPr>
-          <a:xfrm>
-            <a:off x="4123945" y="3695623"/>
-            <a:ext cx="4315967" cy="436017"/>
-          </a:xfrm>
-          <a:prstGeom prst="rect">
-            <a:avLst/>
-          </a:prstGeom>
-          <a:noFill/>
-        </p:spPr>
-        <p:txBody>
-          <a:bodyPr wrap="square" lIns="0" tIns="0" rIns="0" bIns="0" anchor="t">
-            <a:spAutoFit/>
-          </a:bodyPr>
-          <a:lstStyle/>
-          <a:p>
-            <a:pPr algn="l"/>
-            <a:endParaRPr sz="1250" b="1" i="0" dirty="0">
-              <a:solidFill>
-                <a:srgbClr val="171C1B"/>
-              </a:solidFill>
-            </a:endParaRPr>
-          </a:p>
-          <a:p>
-            <a:pPr algn="l">
-              <a:spcBef>
-                <a:spcPts val="400"/>
-              </a:spcBef>
-            </a:pPr>
-            <a:r>
-              <a:rPr lang="de-CH" sz="1250" b="1" i="0" dirty="0">
-                <a:solidFill>
-                  <a:srgbClr val="171C1B"/>
-                </a:solidFill>
-              </a:rPr>
-              <a:t>Zentrum ist a</a:t>
-            </a:r>
-            <a:r>
-              <a:rPr sz="1250" b="1" i="0" dirty="0" err="1">
-                <a:solidFill>
-                  <a:srgbClr val="171C1B"/>
-                </a:solidFill>
-              </a:rPr>
-              <a:t>nerkannt</a:t>
-            </a:r>
-            <a:r>
-              <a:rPr sz="1250" b="1" i="0" dirty="0">
-                <a:solidFill>
-                  <a:srgbClr val="171C1B"/>
-                </a:solidFill>
-              </a:rPr>
-              <a:t> </a:t>
-            </a:r>
-            <a:r>
-              <a:rPr sz="1250" b="1" i="0" dirty="0" err="1">
-                <a:solidFill>
-                  <a:srgbClr val="171C1B"/>
-                </a:solidFill>
-              </a:rPr>
-              <a:t>als</a:t>
-            </a:r>
-            <a:r>
-              <a:rPr sz="1250" b="1" i="0" dirty="0">
-                <a:solidFill>
-                  <a:srgbClr val="171C1B"/>
-                </a:solidFill>
-              </a:rPr>
-              <a:t> Swiss Medical Obesity Center</a:t>
-            </a:r>
-          </a:p>
-        </p:txBody>
-      </p:sp>
-      <p:sp>
-        <p:nvSpPr>
-          <p:cNvPr id="4" name="Rectangle 28">
-            <a:extLst>
-              <a:ext uri="{FF2B5EF4-FFF2-40B4-BE49-F238E27FC236}">
-                <a16:creationId xmlns:a16="http://schemas.microsoft.com/office/drawing/2014/main" id="{C75EF914-26A9-50D6-A598-6FE84184A0CA}"/>
-              </a:ext>
-            </a:extLst>
-          </p:cNvPr>
-          <p:cNvSpPr/>
-          <p:nvPr/>
-        </p:nvSpPr>
-        <p:spPr>
-          <a:xfrm>
-            <a:off x="6574536" y="1630277"/>
-            <a:ext cx="1865376" cy="1572768"/>
-          </a:xfrm>
-          <a:prstGeom prst="rect">
-            <a:avLst/>
-          </a:prstGeom>
-          <a:solidFill>
-            <a:srgbClr val="F0F6F3"/>
-          </a:solidFill>
-          <a:ln>
-            <a:noFill/>
-          </a:ln>
-          <a:effectLst/>
-        </p:spPr>
-        <p:style>
-          <a:lnRef idx="1">
-            <a:schemeClr val="accent1"/>
-          </a:lnRef>
-          <a:fillRef idx="3">
-            <a:schemeClr val="accent1"/>
-          </a:fillRef>
-          <a:effectRef idx="2">
-            <a:schemeClr val="accent1"/>
-          </a:effectRef>
-          <a:fontRef idx="minor">
-            <a:schemeClr val="lt1"/>
-          </a:fontRef>
-        </p:style>
-        <p:txBody>
-          <a:bodyPr rtlCol="0" anchor="ctr"/>
-          <a:lstStyle/>
-          <a:p>
-            <a:pPr algn="ctr"/>
-            <a:endParaRPr/>
-          </a:p>
-        </p:txBody>
-      </p:sp>
-      <p:sp>
-        <p:nvSpPr>
-          <p:cNvPr id="5" name="TextBox 29">
-            <a:extLst>
-              <a:ext uri="{FF2B5EF4-FFF2-40B4-BE49-F238E27FC236}">
-                <a16:creationId xmlns:a16="http://schemas.microsoft.com/office/drawing/2014/main" id="{9623F609-CC7F-7C85-13A5-E9D470945EE4}"/>
-              </a:ext>
-            </a:extLst>
-          </p:cNvPr>
-          <p:cNvSpPr txBox="1"/>
-          <p:nvPr/>
-        </p:nvSpPr>
-        <p:spPr>
-          <a:xfrm>
-            <a:off x="6711696" y="1767437"/>
-            <a:ext cx="1591056" cy="182880"/>
-          </a:xfrm>
-          <a:prstGeom prst="rect">
-            <a:avLst/>
-          </a:prstGeom>
-          <a:noFill/>
-        </p:spPr>
-        <p:txBody>
-          <a:bodyPr wrap="square" lIns="0" tIns="0" rIns="0" bIns="0" anchor="t">
-            <a:spAutoFit/>
-          </a:bodyPr>
-          <a:lstStyle/>
-          <a:p>
-            <a:pPr algn="l"/>
-            <a:r>
-              <a:rPr sz="980" b="1" i="0">
-                <a:solidFill>
-                  <a:srgbClr val="009670"/>
-                </a:solidFill>
-              </a:rPr>
-              <a:t>UDEM</a:t>
-            </a:r>
-          </a:p>
-        </p:txBody>
-      </p:sp>
-      <p:sp>
-        <p:nvSpPr>
-          <p:cNvPr id="6" name="TextBox 30">
-            <a:extLst>
-              <a:ext uri="{FF2B5EF4-FFF2-40B4-BE49-F238E27FC236}">
-                <a16:creationId xmlns:a16="http://schemas.microsoft.com/office/drawing/2014/main" id="{7DDF5FFA-6DA8-8847-2BF7-8BF7008BCF33}"/>
-              </a:ext>
-            </a:extLst>
-          </p:cNvPr>
-          <p:cNvSpPr txBox="1"/>
-          <p:nvPr/>
-        </p:nvSpPr>
-        <p:spPr>
-          <a:xfrm>
-            <a:off x="6711696" y="2014325"/>
-            <a:ext cx="1591056" cy="430887"/>
-          </a:xfrm>
-          <a:prstGeom prst="rect">
-            <a:avLst/>
-          </a:prstGeom>
-          <a:noFill/>
-        </p:spPr>
-        <p:txBody>
-          <a:bodyPr wrap="square" lIns="0" tIns="0" rIns="0" bIns="0" anchor="t">
-            <a:spAutoFit/>
-          </a:bodyPr>
-          <a:lstStyle/>
-          <a:p>
-            <a:pPr algn="l"/>
-            <a:r>
-              <a:rPr lang="de-CH" sz="1400" b="1" i="0" dirty="0">
-                <a:solidFill>
-                  <a:srgbClr val="171C1B"/>
-                </a:solidFill>
-              </a:rPr>
-              <a:t>Postbariatrische Chirurgie</a:t>
-            </a:r>
-            <a:endParaRPr sz="1400" b="1" i="0" dirty="0">
-              <a:solidFill>
-                <a:srgbClr val="171C1B"/>
-              </a:solidFill>
-            </a:endParaRPr>
-          </a:p>
-        </p:txBody>
-      </p:sp>
-      <p:sp>
-        <p:nvSpPr>
-          <p:cNvPr id="7" name="TextBox 31">
-            <a:extLst>
-              <a:ext uri="{FF2B5EF4-FFF2-40B4-BE49-F238E27FC236}">
-                <a16:creationId xmlns:a16="http://schemas.microsoft.com/office/drawing/2014/main" id="{59B006AD-0144-8908-4E2B-60A6E5770CDE}"/>
-              </a:ext>
-            </a:extLst>
-          </p:cNvPr>
-          <p:cNvSpPr txBox="1"/>
-          <p:nvPr/>
-        </p:nvSpPr>
-        <p:spPr>
-          <a:xfrm>
-            <a:off x="6711696" y="2562965"/>
-            <a:ext cx="1609344" cy="169277"/>
-          </a:xfrm>
-          <a:prstGeom prst="rect">
-            <a:avLst/>
-          </a:prstGeom>
-          <a:noFill/>
-        </p:spPr>
-        <p:txBody>
-          <a:bodyPr wrap="square" lIns="0" tIns="0" rIns="0" bIns="0" anchor="t">
-            <a:spAutoFit/>
-          </a:bodyPr>
-          <a:lstStyle/>
-          <a:p>
-            <a:pPr algn="l"/>
-            <a:r>
-              <a:rPr lang="de-CH" sz="1100" b="0" i="0" dirty="0">
-                <a:solidFill>
-                  <a:srgbClr val="171C1B"/>
-                </a:solidFill>
-              </a:rPr>
-              <a:t>Nachsorge</a:t>
-            </a:r>
-            <a:endParaRPr sz="1100" b="0" i="0" dirty="0">
-              <a:solidFill>
-                <a:srgbClr val="171C1B"/>
-              </a:solidFill>
-            </a:endParaRPr>
-          </a:p>
-        </p:txBody>
-      </p:sp>
-    </p:spTree>
-  </p:cSld>
-  <p:clrMapOvr>
-    <a:masterClrMapping/>
-  </p:clrMapOvr>
 </p:sld>
 </file>
 

</xml_diff>

<commit_message>
Präsentation: EASO COMs und Swiss Medical Obesity Center als zwei Zertifikate
Auf der Zielbild-Folie stehen die beiden Zertifikate des ZSG nun in
getrennten Zeilen mit je eigenem Kürzel.

Co-Authored-By: Claude Opus 5.5 <noreply@anthropic.com>
Claude-Session: https://claude.ai/code/session_01Y3aMFwC6xTttGKHnTQtGy4
</commit_message>
<xml_diff>
--- a/praesentation/Zusammenarbeit_Adipositas_UDEM_UVCM_Entwurf.pptx
+++ b/praesentation/Zusammenarbeit_Adipositas_UDEM_UVCM_Entwurf.pptx
@@ -25269,7 +25269,7 @@
         <p:spPr>
           <a:xfrm>
             <a:off x="731520" y="2011680"/>
-            <a:ext cx="1796796" cy="1115568"/>
+            <a:ext cx="1796796" cy="1005840"/>
           </a:xfrm>
           <a:prstGeom prst="rect">
             <a:avLst/>
@@ -25380,7 +25380,7 @@
         </p:nvSpPr>
         <p:spPr>
           <a:xfrm>
-            <a:off x="868680" y="2743200"/>
+            <a:off x="868680" y="2633472"/>
             <a:ext cx="1522476" cy="310896"/>
           </a:xfrm>
           <a:prstGeom prst="rect">
@@ -25415,7 +25415,7 @@
         <p:spPr>
           <a:xfrm>
             <a:off x="2692908" y="2011680"/>
-            <a:ext cx="1796796" cy="1115568"/>
+            <a:ext cx="1796796" cy="1005840"/>
           </a:xfrm>
           <a:prstGeom prst="rect">
             <a:avLst/>
@@ -25526,7 +25526,7 @@
         </p:nvSpPr>
         <p:spPr>
           <a:xfrm>
-            <a:off x="2830068" y="2743200"/>
+            <a:off x="2830068" y="2633472"/>
             <a:ext cx="1522476" cy="310896"/>
           </a:xfrm>
           <a:prstGeom prst="rect">
@@ -25561,7 +25561,7 @@
         <p:spPr>
           <a:xfrm>
             <a:off x="4654296" y="2011680"/>
-            <a:ext cx="1796796" cy="1115568"/>
+            <a:ext cx="1796796" cy="1005840"/>
           </a:xfrm>
           <a:prstGeom prst="rect">
             <a:avLst/>
@@ -25672,7 +25672,7 @@
         </p:nvSpPr>
         <p:spPr>
           <a:xfrm>
-            <a:off x="4791456" y="2743200"/>
+            <a:off x="4791456" y="2633472"/>
             <a:ext cx="1522476" cy="310896"/>
           </a:xfrm>
           <a:prstGeom prst="rect">
@@ -25707,7 +25707,7 @@
         <p:spPr>
           <a:xfrm>
             <a:off x="6615684" y="2011680"/>
-            <a:ext cx="1796796" cy="1115568"/>
+            <a:ext cx="1796796" cy="1005840"/>
           </a:xfrm>
           <a:prstGeom prst="rect">
             <a:avLst/>
@@ -25818,7 +25818,7 @@
         </p:nvSpPr>
         <p:spPr>
           <a:xfrm>
-            <a:off x="6752844" y="2743200"/>
+            <a:off x="6752844" y="2633472"/>
             <a:ext cx="1522476" cy="310896"/>
           </a:xfrm>
           <a:prstGeom prst="rect">
@@ -25852,7 +25852,7 @@
         </p:nvSpPr>
         <p:spPr>
           <a:xfrm>
-            <a:off x="548640" y="3191256"/>
+            <a:off x="548640" y="3081528"/>
             <a:ext cx="8046720" cy="36576"/>
           </a:xfrm>
           <a:prstGeom prst="rect">
@@ -25896,8 +25896,8 @@
         </p:nvSpPr>
         <p:spPr>
           <a:xfrm>
-            <a:off x="548640" y="3291840"/>
-            <a:ext cx="3977639" cy="1389888"/>
+            <a:off x="548640" y="3172968"/>
+            <a:ext cx="3977639" cy="1536192"/>
           </a:xfrm>
           <a:prstGeom prst="rect">
             <a:avLst/>
@@ -25942,7 +25942,7 @@
         </p:nvSpPr>
         <p:spPr>
           <a:xfrm>
-            <a:off x="713232" y="3383280"/>
+            <a:off x="713232" y="3264408"/>
             <a:ext cx="2743200" cy="164592"/>
           </a:xfrm>
           <a:prstGeom prst="rect">
@@ -25984,8 +25984,8 @@
         </p:blipFill>
         <p:spPr>
           <a:xfrm>
-            <a:off x="731520" y="3621024"/>
-            <a:ext cx="475488" cy="475488"/>
+            <a:off x="731520" y="3483864"/>
+            <a:ext cx="457200" cy="457200"/>
           </a:xfrm>
           <a:prstGeom prst="rect">
             <a:avLst/>
@@ -26000,7 +26000,7 @@
         </p:nvSpPr>
         <p:spPr>
           <a:xfrm>
-            <a:off x="1325880" y="3703320"/>
+            <a:off x="1325880" y="3547872"/>
             <a:ext cx="2468880" cy="365760"/>
           </a:xfrm>
           <a:prstGeom prst="rect">
@@ -26045,7 +26045,7 @@
         </p:nvSpPr>
         <p:spPr>
           <a:xfrm>
-            <a:off x="3840480" y="3730752"/>
+            <a:off x="3840480" y="3602736"/>
             <a:ext cx="566928" cy="173736"/>
           </a:xfrm>
           <a:prstGeom prst="roundRect">
@@ -26099,7 +26099,7 @@
         </p:nvCxnSpPr>
         <p:spPr>
           <a:xfrm>
-            <a:off x="713232" y="4178808"/>
+            <a:off x="713232" y="4014216"/>
             <a:ext cx="3648456" cy="0"/>
           </a:xfrm>
           <a:prstGeom prst="line">
@@ -26142,8 +26142,8 @@
         </p:blipFill>
         <p:spPr>
           <a:xfrm>
-            <a:off x="713232" y="4270248"/>
-            <a:ext cx="1371600" cy="280555"/>
+            <a:off x="713232" y="4078224"/>
+            <a:ext cx="1325880" cy="271203"/>
           </a:xfrm>
           <a:prstGeom prst="rect">
             <a:avLst/>
@@ -26158,8 +26158,8 @@
         </p:nvSpPr>
         <p:spPr>
           <a:xfrm>
-            <a:off x="2240280" y="4242816"/>
-            <a:ext cx="1554480" cy="365760"/>
+            <a:off x="2194560" y="4142232"/>
+            <a:ext cx="1554480" cy="182880"/>
           </a:xfrm>
           <a:prstGeom prst="rect">
             <a:avLst/>
@@ -26182,17 +26182,6 @@
               <a:t>EASO COMs</a:t>
             </a:r>
           </a:p>
-          <a:p>
-            <a:pPr algn="l"/>
-            <a:r>
-              <a:rPr sz="850" b="0" i="0">
-                <a:solidFill>
-                  <a:srgbClr val="677078"/>
-                </a:solidFill>
-              </a:rPr>
-              <a:t>Swiss Medical Obesity Center</a:t>
-            </a:r>
-          </a:p>
         </p:txBody>
       </p:sp>
       <p:sp>
@@ -26203,7 +26192,7 @@
         </p:nvSpPr>
         <p:spPr>
           <a:xfrm>
-            <a:off x="3840480" y="4279392"/>
+            <a:off x="3840480" y="4151376"/>
             <a:ext cx="566928" cy="173736"/>
           </a:xfrm>
           <a:prstGeom prst="roundRect">
@@ -26249,27 +26238,96 @@
           </a:p>
         </p:txBody>
       </p:sp>
-      <p:sp>
-        <p:nvSpPr>
-          <p:cNvPr id="48" name="Rectangle 47"/>
-          <p:cNvSpPr/>
+      <p:cxnSp>
+        <p:nvCxnSpPr>
+          <p:cNvPr id="48" name="Connector 47"/>
+          <p:cNvCxnSpPr/>
           <p:nvPr/>
-        </p:nvSpPr>
-        <p:spPr>
-          <a:xfrm>
-            <a:off x="4617720" y="3291840"/>
-            <a:ext cx="3977639" cy="1389888"/>
-          </a:xfrm>
-          <a:prstGeom prst="rect">
+        </p:nvCxnSpPr>
+        <p:spPr>
+          <a:xfrm>
+            <a:off x="713232" y="4407408"/>
+            <a:ext cx="3648456" cy="0"/>
+          </a:xfrm>
+          <a:prstGeom prst="line">
             <a:avLst/>
           </a:prstGeom>
-          <a:solidFill>
-            <a:srgbClr val="FFFFFF"/>
-          </a:solidFill>
           <a:ln w="12700">
             <a:solidFill>
               <a:srgbClr val="CFD8D5"/>
             </a:solidFill>
+          </a:ln>
+        </p:spPr>
+        <p:style>
+          <a:lnRef idx="2">
+            <a:schemeClr val="accent1"/>
+          </a:lnRef>
+          <a:fillRef idx="0">
+            <a:schemeClr val="accent1"/>
+          </a:fillRef>
+          <a:effectRef idx="1">
+            <a:schemeClr val="accent1"/>
+          </a:effectRef>
+          <a:fontRef idx="minor">
+            <a:schemeClr val="tx1"/>
+          </a:fontRef>
+        </p:style>
+      </p:cxnSp>
+      <p:sp>
+        <p:nvSpPr>
+          <p:cNvPr id="49" name="TextBox 48"/>
+          <p:cNvSpPr txBox="1"/>
+          <p:nvPr/>
+        </p:nvSpPr>
+        <p:spPr>
+          <a:xfrm>
+            <a:off x="713232" y="4480560"/>
+            <a:ext cx="3017520" cy="182880"/>
+          </a:xfrm>
+          <a:prstGeom prst="rect">
+            <a:avLst/>
+          </a:prstGeom>
+          <a:noFill/>
+        </p:spPr>
+        <p:txBody>
+          <a:bodyPr wrap="square" lIns="0" rIns="0" tIns="0" bIns="0" anchor="t">
+            <a:spAutoFit/>
+          </a:bodyPr>
+          <a:lstStyle/>
+          <a:p>
+            <a:pPr algn="l"/>
+            <a:r>
+              <a:rPr sz="1000" b="1" i="0">
+                <a:solidFill>
+                  <a:srgbClr val="171C1B"/>
+                </a:solidFill>
+              </a:rPr>
+              <a:t>Swiss Medical Obesity Center</a:t>
+            </a:r>
+          </a:p>
+        </p:txBody>
+      </p:sp>
+      <p:sp>
+        <p:nvSpPr>
+          <p:cNvPr id="50" name="Rounded Rectangle 49"/>
+          <p:cNvSpPr/>
+          <p:nvPr/>
+        </p:nvSpPr>
+        <p:spPr>
+          <a:xfrm>
+            <a:off x="3840480" y="4480560"/>
+            <a:ext cx="566928" cy="173736"/>
+          </a:xfrm>
+          <a:prstGeom prst="roundRect">
+            <a:avLst>
+              <a:gd name="adj" fmla="val 50000"/>
+            </a:avLst>
+          </a:prstGeom>
+          <a:solidFill>
+            <a:srgbClr val="009670"/>
+          </a:solidFill>
+          <a:ln>
+            <a:noFill/>
           </a:ln>
           <a:effectLst/>
         </p:spPr>
@@ -26288,102 +26346,42 @@
           </a:fontRef>
         </p:style>
         <p:txBody>
-          <a:bodyPr rtlCol="0" anchor="ctr"/>
+          <a:bodyPr rtlCol="0" anchor="ctr" wrap="square" lIns="18288" rIns="18288" tIns="18288" bIns="18288"/>
           <a:lstStyle/>
           <a:p>
             <a:pPr algn="ctr"/>
-          </a:p>
-        </p:txBody>
-      </p:sp>
-      <p:sp>
-        <p:nvSpPr>
-          <p:cNvPr id="49" name="TextBox 48"/>
-          <p:cNvSpPr txBox="1"/>
+            <a:r>
+              <a:rPr sz="750" b="1">
+                <a:solidFill>
+                  <a:srgbClr val="FFFFFF"/>
+                </a:solidFill>
+              </a:rPr>
+              <a:t>ZSG</a:t>
+            </a:r>
+          </a:p>
+        </p:txBody>
+      </p:sp>
+      <p:sp>
+        <p:nvSpPr>
+          <p:cNvPr id="51" name="Rectangle 50"/>
+          <p:cNvSpPr/>
           <p:nvPr/>
         </p:nvSpPr>
         <p:spPr>
           <a:xfrm>
-            <a:off x="4782312" y="3383280"/>
-            <a:ext cx="2743200" cy="164592"/>
+            <a:off x="4617720" y="3172968"/>
+            <a:ext cx="3977639" cy="1536192"/>
           </a:xfrm>
           <a:prstGeom prst="rect">
             <a:avLst/>
           </a:prstGeom>
-          <a:noFill/>
-        </p:spPr>
-        <p:txBody>
-          <a:bodyPr wrap="square" lIns="0" rIns="0" tIns="0" bIns="0" anchor="t">
-            <a:spAutoFit/>
-          </a:bodyPr>
-          <a:lstStyle/>
-          <a:p>
-            <a:pPr algn="l"/>
-            <a:r>
-              <a:rPr sz="980" b="1" i="0">
-                <a:solidFill>
-                  <a:srgbClr val="009670"/>
-                </a:solidFill>
-              </a:rPr>
-              <a:t>FORSCHUNG</a:t>
-            </a:r>
-          </a:p>
-        </p:txBody>
-      </p:sp>
-      <p:sp>
-        <p:nvSpPr>
-          <p:cNvPr id="50" name="TextBox 49"/>
-          <p:cNvSpPr txBox="1"/>
-          <p:nvPr/>
-        </p:nvSpPr>
-        <p:spPr>
-          <a:xfrm>
-            <a:off x="4782312" y="3675888"/>
-            <a:ext cx="2926080" cy="201168"/>
-          </a:xfrm>
-          <a:prstGeom prst="rect">
-            <a:avLst/>
-          </a:prstGeom>
-          <a:noFill/>
-        </p:spPr>
-        <p:txBody>
-          <a:bodyPr wrap="square" lIns="0" rIns="0" tIns="0" bIns="0" anchor="t">
-            <a:spAutoFit/>
-          </a:bodyPr>
-          <a:lstStyle/>
-          <a:p>
-            <a:pPr algn="l"/>
-            <a:r>
-              <a:rPr sz="1100" b="1" i="0">
-                <a:solidFill>
-                  <a:srgbClr val="171C1B"/>
-                </a:solidFill>
-              </a:rPr>
-              <a:t>Swiss Obesity Study (SOS)</a:t>
-            </a:r>
-          </a:p>
-        </p:txBody>
-      </p:sp>
-      <p:sp>
-        <p:nvSpPr>
-          <p:cNvPr id="51" name="Rounded Rectangle 50"/>
-          <p:cNvSpPr/>
-          <p:nvPr/>
-        </p:nvSpPr>
-        <p:spPr>
-          <a:xfrm>
-            <a:off x="7726679" y="3685032"/>
-            <a:ext cx="713232" cy="173736"/>
-          </a:xfrm>
-          <a:prstGeom prst="roundRect">
-            <a:avLst>
-              <a:gd name="adj" fmla="val 50000"/>
-            </a:avLst>
-          </a:prstGeom>
           <a:solidFill>
-            <a:srgbClr val="009670"/>
+            <a:srgbClr val="FFFFFF"/>
           </a:solidFill>
-          <a:ln>
-            <a:noFill/>
+          <a:ln w="12700">
+            <a:solidFill>
+              <a:srgbClr val="CFD8D5"/>
+            </a:solidFill>
           </a:ln>
           <a:effectLst/>
         </p:spPr>
@@ -26402,6 +26400,120 @@
           </a:fontRef>
         </p:style>
         <p:txBody>
+          <a:bodyPr rtlCol="0" anchor="ctr"/>
+          <a:lstStyle/>
+          <a:p>
+            <a:pPr algn="ctr"/>
+          </a:p>
+        </p:txBody>
+      </p:sp>
+      <p:sp>
+        <p:nvSpPr>
+          <p:cNvPr id="52" name="TextBox 51"/>
+          <p:cNvSpPr txBox="1"/>
+          <p:nvPr/>
+        </p:nvSpPr>
+        <p:spPr>
+          <a:xfrm>
+            <a:off x="4782312" y="3264408"/>
+            <a:ext cx="2743200" cy="164592"/>
+          </a:xfrm>
+          <a:prstGeom prst="rect">
+            <a:avLst/>
+          </a:prstGeom>
+          <a:noFill/>
+        </p:spPr>
+        <p:txBody>
+          <a:bodyPr wrap="square" lIns="0" rIns="0" tIns="0" bIns="0" anchor="t">
+            <a:spAutoFit/>
+          </a:bodyPr>
+          <a:lstStyle/>
+          <a:p>
+            <a:pPr algn="l"/>
+            <a:r>
+              <a:rPr sz="980" b="1" i="0">
+                <a:solidFill>
+                  <a:srgbClr val="009670"/>
+                </a:solidFill>
+              </a:rPr>
+              <a:t>FORSCHUNG</a:t>
+            </a:r>
+          </a:p>
+        </p:txBody>
+      </p:sp>
+      <p:sp>
+        <p:nvSpPr>
+          <p:cNvPr id="53" name="TextBox 52"/>
+          <p:cNvSpPr txBox="1"/>
+          <p:nvPr/>
+        </p:nvSpPr>
+        <p:spPr>
+          <a:xfrm>
+            <a:off x="4782312" y="3557016"/>
+            <a:ext cx="2926080" cy="201168"/>
+          </a:xfrm>
+          <a:prstGeom prst="rect">
+            <a:avLst/>
+          </a:prstGeom>
+          <a:noFill/>
+        </p:spPr>
+        <p:txBody>
+          <a:bodyPr wrap="square" lIns="0" rIns="0" tIns="0" bIns="0" anchor="t">
+            <a:spAutoFit/>
+          </a:bodyPr>
+          <a:lstStyle/>
+          <a:p>
+            <a:pPr algn="l"/>
+            <a:r>
+              <a:rPr sz="1100" b="1" i="0">
+                <a:solidFill>
+                  <a:srgbClr val="171C1B"/>
+                </a:solidFill>
+              </a:rPr>
+              <a:t>Swiss Obesity Study (SOS)</a:t>
+            </a:r>
+          </a:p>
+        </p:txBody>
+      </p:sp>
+      <p:sp>
+        <p:nvSpPr>
+          <p:cNvPr id="54" name="Rounded Rectangle 53"/>
+          <p:cNvSpPr/>
+          <p:nvPr/>
+        </p:nvSpPr>
+        <p:spPr>
+          <a:xfrm>
+            <a:off x="7726679" y="3566160"/>
+            <a:ext cx="713232" cy="173736"/>
+          </a:xfrm>
+          <a:prstGeom prst="roundRect">
+            <a:avLst>
+              <a:gd name="adj" fmla="val 50000"/>
+            </a:avLst>
+          </a:prstGeom>
+          <a:solidFill>
+            <a:srgbClr val="009670"/>
+          </a:solidFill>
+          <a:ln>
+            <a:noFill/>
+          </a:ln>
+          <a:effectLst/>
+        </p:spPr>
+        <p:style>
+          <a:lnRef idx="1">
+            <a:schemeClr val="accent1"/>
+          </a:lnRef>
+          <a:fillRef idx="3">
+            <a:schemeClr val="accent1"/>
+          </a:fillRef>
+          <a:effectRef idx="2">
+            <a:schemeClr val="accent1"/>
+          </a:effectRef>
+          <a:fontRef idx="minor">
+            <a:schemeClr val="lt1"/>
+          </a:fontRef>
+        </p:style>
+        <p:txBody>
           <a:bodyPr rtlCol="0" anchor="ctr" wrap="square" lIns="18288" rIns="18288" tIns="18288" bIns="18288"/>
           <a:lstStyle/>
           <a:p>
@@ -26419,13 +26531,13 @@
       </p:sp>
       <p:sp>
         <p:nvSpPr>
-          <p:cNvPr id="52" name="TextBox 51"/>
+          <p:cNvPr id="55" name="TextBox 54"/>
           <p:cNvSpPr txBox="1"/>
           <p:nvPr/>
         </p:nvSpPr>
         <p:spPr>
           <a:xfrm>
-            <a:off x="4782312" y="3913632"/>
+            <a:off x="4782312" y="3794760"/>
             <a:ext cx="3657600" cy="164592"/>
           </a:xfrm>
           <a:prstGeom prst="rect">
@@ -26453,13 +26565,13 @@
       </p:sp>
       <p:sp>
         <p:nvSpPr>
-          <p:cNvPr id="53" name="TextBox 52"/>
+          <p:cNvPr id="56" name="TextBox 55"/>
           <p:cNvSpPr txBox="1"/>
           <p:nvPr/>
         </p:nvSpPr>
         <p:spPr>
           <a:xfrm>
-            <a:off x="4782312" y="4187952"/>
+            <a:off x="4782312" y="4069080"/>
             <a:ext cx="3657600" cy="256032"/>
           </a:xfrm>
           <a:prstGeom prst="rect">

</xml_diff>